<commit_message>
docs: rebuild the pitch deck with a real design, not the template default
hackager slides produced the plain python-pptx-default look and flagged 5
of 7 slides over the 60-word density limit. docs/scripts/build_pitch_deck.py
replaces it: 13 slides, chunked so none exceeds ~60 words, laid out with a
header/accent-bar system (title, section-divider, bullet, stat, closing
slide types) instead of one generic bullet template.

Content is transcribed from docs/PITCH.md, nothing invented. Colors reuse
the validated categorical/status palette already used in web-demo/ and
watch/'s terminal dashboard, so the deck, the site, and the panel read as
one system. Verified structurally (no out-of-bounds shapes, no slide over
the density threshold) -- no renderer available here to screenshot it, so
worth a manual look before it goes in front of a judge.
</commit_message>
<xml_diff>
--- a/docs/AverisMonash2026.pptx
+++ b/docs/AverisMonash2026.pptx
@@ -12,6 +12,12 @@
     <p:sldId id="260" r:id="rId11"/>
     <p:sldId id="261" r:id="rId12"/>
     <p:sldId id="262" r:id="rId13"/>
+    <p:sldId id="263" r:id="rId14"/>
+    <p:sldId id="264" r:id="rId15"/>
+    <p:sldId id="265" r:id="rId16"/>
+    <p:sldId id="266" r:id="rId17"/>
+    <p:sldId id="267" r:id="rId18"/>
+    <p:sldId id="268" r:id="rId19"/>
   </p:sldIdLst>
   <p:sldSz cx="12191695" cy="6858000" type="screen4x3"/>
   <p:notesSz cx="6858000" cy="9144000"/>
@@ -3096,14 +3102,102 @@
       <p:grpSpPr/>
       <p:sp>
         <p:nvSpPr>
-          <p:cNvPr id="2" name="TextBox 1"/>
+          <p:cNvPr id="2" name="Rectangle 1"/>
+          <p:cNvSpPr/>
+          <p:nvPr/>
+        </p:nvSpPr>
+        <p:spPr>
+          <a:xfrm>
+            <a:off x="0" y="0"/>
+            <a:ext cx="12191695" cy="6858000"/>
+          </a:xfrm>
+          <a:prstGeom prst="rect">
+            <a:avLst/>
+          </a:prstGeom>
+          <a:solidFill>
+            <a:srgbClr val="0D1B2A"/>
+          </a:solidFill>
+          <a:ln>
+            <a:noFill/>
+          </a:ln>
+          <a:effectLst/>
+        </p:spPr>
+        <p:style>
+          <a:lnRef idx="1">
+            <a:schemeClr val="accent1"/>
+          </a:lnRef>
+          <a:fillRef idx="3">
+            <a:schemeClr val="accent1"/>
+          </a:fillRef>
+          <a:effectRef idx="2">
+            <a:schemeClr val="accent1"/>
+          </a:effectRef>
+          <a:fontRef idx="minor">
+            <a:schemeClr val="lt1"/>
+          </a:fontRef>
+        </p:style>
+        <p:txBody>
+          <a:bodyPr rtlCol="0" anchor="ctr"/>
+          <a:lstStyle/>
+          <a:p>
+            <a:pPr algn="ctr"/>
+          </a:p>
+        </p:txBody>
+      </p:sp>
+      <p:sp>
+        <p:nvSpPr>
+          <p:cNvPr id="3" name="Rectangle 2"/>
+          <p:cNvSpPr/>
+          <p:nvPr/>
+        </p:nvSpPr>
+        <p:spPr>
+          <a:xfrm>
+            <a:off x="0" y="6309360"/>
+            <a:ext cx="12191695" cy="109728"/>
+          </a:xfrm>
+          <a:prstGeom prst="rect">
+            <a:avLst/>
+          </a:prstGeom>
+          <a:solidFill>
+            <a:srgbClr val="EDA100"/>
+          </a:solidFill>
+          <a:ln>
+            <a:noFill/>
+          </a:ln>
+          <a:effectLst/>
+        </p:spPr>
+        <p:style>
+          <a:lnRef idx="1">
+            <a:schemeClr val="accent1"/>
+          </a:lnRef>
+          <a:fillRef idx="3">
+            <a:schemeClr val="accent1"/>
+          </a:fillRef>
+          <a:effectRef idx="2">
+            <a:schemeClr val="accent1"/>
+          </a:effectRef>
+          <a:fontRef idx="minor">
+            <a:schemeClr val="lt1"/>
+          </a:fontRef>
+        </p:style>
+        <p:txBody>
+          <a:bodyPr rtlCol="0" anchor="ctr"/>
+          <a:lstStyle/>
+          <a:p>
+            <a:pPr algn="ctr"/>
+          </a:p>
+        </p:txBody>
+      </p:sp>
+      <p:sp>
+        <p:nvSpPr>
+          <p:cNvPr id="4" name="TextBox 3"/>
           <p:cNvSpPr txBox="1"/>
           <p:nvPr/>
         </p:nvSpPr>
         <p:spPr>
           <a:xfrm>
-            <a:off x="731520" y="2377440"/>
-            <a:ext cx="10728655" cy="1371600"/>
+            <a:off x="640080" y="1737360"/>
+            <a:ext cx="10911535" cy="457200"/>
           </a:xfrm>
           <a:prstGeom prst="rect">
             <a:avLst/>
@@ -3111,34 +3205,1503 @@
           <a:noFill/>
         </p:spPr>
         <p:txBody>
-          <a:bodyPr wrap="none">
+          <a:bodyPr wrap="square">
             <a:spAutoFit/>
           </a:bodyPr>
           <a:lstStyle/>
           <a:p>
             <a:pPr>
-              <a:defRPr sz="4400" b="1">
-                <a:solidFill>
-                  <a:srgbClr val="003366"/>
-                </a:solidFill>
-                <a:latin typeface="Calibri"/>
+              <a:defRPr sz="1600" b="1">
+                <a:solidFill>
+                  <a:srgbClr val="EDA100"/>
+                </a:solidFill>
+                <a:latin typeface="Helvetica Neue"/>
               </a:defRPr>
             </a:pPr>
             <a:r>
+              <a:t>AVERIS × MONASH HACKATHON 2026 — TEAM DEVSELF</a:t>
+            </a:r>
+          </a:p>
+        </p:txBody>
+      </p:sp>
+      <p:sp>
+        <p:nvSpPr>
+          <p:cNvPr id="5" name="TextBox 4"/>
+          <p:cNvSpPr txBox="1"/>
+          <p:nvPr/>
+        </p:nvSpPr>
+        <p:spPr>
+          <a:xfrm>
+            <a:off x="640080" y="2286000"/>
+            <a:ext cx="10911535" cy="1463040"/>
+          </a:xfrm>
+          <a:prstGeom prst="rect">
+            <a:avLst/>
+          </a:prstGeom>
+          <a:noFill/>
+        </p:spPr>
+        <p:txBody>
+          <a:bodyPr wrap="square">
+            <a:spAutoFit/>
+          </a:bodyPr>
+          <a:lstStyle/>
+          <a:p>
+            <a:pPr>
+              <a:defRPr sz="5400" b="1">
+                <a:solidFill>
+                  <a:srgbClr val="FFFFFF"/>
+                </a:solidFill>
+                <a:latin typeface="Helvetica Neue"/>
+              </a:defRPr>
+            </a:pPr>
+            <a:r>
               <a:t>Evermon</a:t>
             </a:r>
           </a:p>
+        </p:txBody>
+      </p:sp>
+      <p:sp>
+        <p:nvSpPr>
+          <p:cNvPr id="6" name="TextBox 5"/>
+          <p:cNvSpPr txBox="1"/>
+          <p:nvPr/>
+        </p:nvSpPr>
+        <p:spPr>
+          <a:xfrm>
+            <a:off x="640080" y="3931920"/>
+            <a:ext cx="10911535" cy="1645920"/>
+          </a:xfrm>
+          <a:prstGeom prst="rect">
+            <a:avLst/>
+          </a:prstGeom>
+          <a:noFill/>
+        </p:spPr>
+        <p:txBody>
+          <a:bodyPr wrap="square">
+            <a:spAutoFit/>
+          </a:bodyPr>
+          <a:lstStyle/>
           <a:p>
             <a:pPr>
-              <a:defRPr sz="2000">
-                <a:solidFill>
-                  <a:srgbClr val="333333"/>
-                </a:solidFill>
-                <a:latin typeface="Calibri"/>
+              <a:defRPr sz="2000" b="0">
+                <a:solidFill>
+                  <a:srgbClr val="C3C9D1"/>
+                </a:solidFill>
+                <a:latin typeface="Helvetica Neue"/>
               </a:defRPr>
             </a:pPr>
             <a:r>
-              <a:t>Evermon reads a shipping-documentation inbox, matches SI against draft BL by meaning (not header text), flags the seven fields that actually matter, and escalates to a human with a stated reason when it can't decide.</a:t>
+              <a:t>Reads a shipping-documentation inbox, compares SI against draft BL by meaning, escalates to a person with a stated reason instead of guessing.</a:t>
+            </a:r>
+          </a:p>
+        </p:txBody>
+      </p:sp>
+      <p:sp>
+        <p:nvSpPr>
+          <p:cNvPr id="7" name="Rectangle 6"/>
+          <p:cNvSpPr/>
+          <p:nvPr/>
+        </p:nvSpPr>
+        <p:spPr>
+          <a:xfrm>
+            <a:off x="0" y="6803136"/>
+            <a:ext cx="12191695" cy="54864"/>
+          </a:xfrm>
+          <a:prstGeom prst="rect">
+            <a:avLst/>
+          </a:prstGeom>
+          <a:solidFill>
+            <a:srgbClr val="EDA100"/>
+          </a:solidFill>
+          <a:ln>
+            <a:noFill/>
+          </a:ln>
+          <a:effectLst/>
+        </p:spPr>
+        <p:style>
+          <a:lnRef idx="1">
+            <a:schemeClr val="accent1"/>
+          </a:lnRef>
+          <a:fillRef idx="3">
+            <a:schemeClr val="accent1"/>
+          </a:fillRef>
+          <a:effectRef idx="2">
+            <a:schemeClr val="accent1"/>
+          </a:effectRef>
+          <a:fontRef idx="minor">
+            <a:schemeClr val="lt1"/>
+          </a:fontRef>
+        </p:style>
+        <p:txBody>
+          <a:bodyPr rtlCol="0" anchor="ctr"/>
+          <a:lstStyle/>
+          <a:p>
+            <a:pPr algn="ctr"/>
+          </a:p>
+        </p:txBody>
+      </p:sp>
+      <p:sp>
+        <p:nvSpPr>
+          <p:cNvPr id="8" name="TextBox 7"/>
+          <p:cNvSpPr txBox="1"/>
+          <p:nvPr/>
+        </p:nvSpPr>
+        <p:spPr>
+          <a:xfrm>
+            <a:off x="640080" y="6473952"/>
+            <a:ext cx="7315200" cy="274320"/>
+          </a:xfrm>
+          <a:prstGeom prst="rect">
+            <a:avLst/>
+          </a:prstGeom>
+          <a:noFill/>
+        </p:spPr>
+        <p:txBody>
+          <a:bodyPr wrap="square">
+            <a:spAutoFit/>
+          </a:bodyPr>
+          <a:lstStyle/>
+          <a:p>
+            <a:pPr>
+              <a:defRPr sz="1000" b="0">
+                <a:solidFill>
+                  <a:srgbClr val="52514E"/>
+                </a:solidFill>
+                <a:latin typeface="Helvetica Neue"/>
+              </a:defRPr>
+            </a:pPr>
+            <a:r>
+              <a:t>Evermon — Averis × Monash Hackathon 2026</a:t>
+            </a:r>
+          </a:p>
+        </p:txBody>
+      </p:sp>
+      <p:sp>
+        <p:nvSpPr>
+          <p:cNvPr id="9" name="TextBox 8"/>
+          <p:cNvSpPr txBox="1"/>
+          <p:nvPr/>
+        </p:nvSpPr>
+        <p:spPr>
+          <a:xfrm>
+            <a:off x="11277295" y="6473952"/>
+            <a:ext cx="548640" cy="274320"/>
+          </a:xfrm>
+          <a:prstGeom prst="rect">
+            <a:avLst/>
+          </a:prstGeom>
+          <a:noFill/>
+        </p:spPr>
+        <p:txBody>
+          <a:bodyPr wrap="square">
+            <a:spAutoFit/>
+          </a:bodyPr>
+          <a:lstStyle/>
+          <a:p>
+            <a:pPr algn="r">
+              <a:defRPr sz="1000" b="1">
+                <a:solidFill>
+                  <a:srgbClr val="2A78D6"/>
+                </a:solidFill>
+                <a:latin typeface="Helvetica Neue"/>
+              </a:defRPr>
+            </a:pPr>
+            <a:r>
+              <a:t>1</a:t>
+            </a:r>
+          </a:p>
+        </p:txBody>
+      </p:sp>
+    </p:spTree>
+  </p:cSld>
+  <p:clrMapOvr>
+    <a:masterClrMapping/>
+  </p:clrMapOvr>
+</p:sld>
+</file>
+
+<file path=ppt/slides/slide10.xml><?xml version="1.0" encoding="utf-8"?>
+<p:sld xmlns:a="http://schemas.openxmlformats.org/drawingml/2006/main" xmlns:p="http://schemas.openxmlformats.org/presentationml/2006/main" xmlns:r="http://schemas.openxmlformats.org/officeDocument/2006/relationships">
+  <p:cSld>
+    <p:spTree>
+      <p:nvGrpSpPr>
+        <p:cNvPr id="1" name=""/>
+        <p:cNvGrpSpPr/>
+        <p:nvPr/>
+      </p:nvGrpSpPr>
+      <p:grpSpPr/>
+      <p:sp>
+        <p:nvSpPr>
+          <p:cNvPr id="2" name="Rectangle 1"/>
+          <p:cNvSpPr/>
+          <p:nvPr/>
+        </p:nvSpPr>
+        <p:spPr>
+          <a:xfrm>
+            <a:off x="0" y="0"/>
+            <a:ext cx="12191695" cy="6858000"/>
+          </a:xfrm>
+          <a:prstGeom prst="rect">
+            <a:avLst/>
+          </a:prstGeom>
+          <a:solidFill>
+            <a:srgbClr val="2A78D6"/>
+          </a:solidFill>
+          <a:ln>
+            <a:noFill/>
+          </a:ln>
+          <a:effectLst/>
+        </p:spPr>
+        <p:style>
+          <a:lnRef idx="1">
+            <a:schemeClr val="accent1"/>
+          </a:lnRef>
+          <a:fillRef idx="3">
+            <a:schemeClr val="accent1"/>
+          </a:fillRef>
+          <a:effectRef idx="2">
+            <a:schemeClr val="accent1"/>
+          </a:effectRef>
+          <a:fontRef idx="minor">
+            <a:schemeClr val="lt1"/>
+          </a:fontRef>
+        </p:style>
+        <p:txBody>
+          <a:bodyPr rtlCol="0" anchor="ctr"/>
+          <a:lstStyle/>
+          <a:p>
+            <a:pPr algn="ctr"/>
+          </a:p>
+        </p:txBody>
+      </p:sp>
+      <p:sp>
+        <p:nvSpPr>
+          <p:cNvPr id="3" name="TextBox 2"/>
+          <p:cNvSpPr txBox="1"/>
+          <p:nvPr/>
+        </p:nvSpPr>
+        <p:spPr>
+          <a:xfrm>
+            <a:off x="640080" y="2011680"/>
+            <a:ext cx="2286000" cy="1280160"/>
+          </a:xfrm>
+          <a:prstGeom prst="rect">
+            <a:avLst/>
+          </a:prstGeom>
+          <a:noFill/>
+        </p:spPr>
+        <p:txBody>
+          <a:bodyPr wrap="square">
+            <a:spAutoFit/>
+          </a:bodyPr>
+          <a:lstStyle/>
+          <a:p>
+            <a:pPr>
+              <a:defRPr sz="8000" b="1">
+                <a:solidFill>
+                  <a:srgbClr val="EDA100"/>
+                </a:solidFill>
+                <a:latin typeface="Helvetica Neue"/>
+              </a:defRPr>
+            </a:pPr>
+            <a:r>
+              <a:t>05</a:t>
+            </a:r>
+          </a:p>
+        </p:txBody>
+      </p:sp>
+      <p:sp>
+        <p:nvSpPr>
+          <p:cNvPr id="4" name="TextBox 3"/>
+          <p:cNvSpPr txBox="1"/>
+          <p:nvPr/>
+        </p:nvSpPr>
+        <p:spPr>
+          <a:xfrm>
+            <a:off x="640080" y="3200400"/>
+            <a:ext cx="10911535" cy="1188720"/>
+          </a:xfrm>
+          <a:prstGeom prst="rect">
+            <a:avLst/>
+          </a:prstGeom>
+          <a:noFill/>
+        </p:spPr>
+        <p:txBody>
+          <a:bodyPr wrap="square">
+            <a:spAutoFit/>
+          </a:bodyPr>
+          <a:lstStyle/>
+          <a:p>
+            <a:pPr>
+              <a:defRPr sz="4000" b="1">
+                <a:solidFill>
+                  <a:srgbClr val="FFFFFF"/>
+                </a:solidFill>
+                <a:latin typeface="Helvetica Neue"/>
+              </a:defRPr>
+            </a:pPr>
+            <a:r>
+              <a:t>Live Demo</a:t>
+            </a:r>
+          </a:p>
+        </p:txBody>
+      </p:sp>
+      <p:sp>
+        <p:nvSpPr>
+          <p:cNvPr id="5" name="Rectangle 4"/>
+          <p:cNvSpPr/>
+          <p:nvPr/>
+        </p:nvSpPr>
+        <p:spPr>
+          <a:xfrm>
+            <a:off x="0" y="6803136"/>
+            <a:ext cx="12191695" cy="54864"/>
+          </a:xfrm>
+          <a:prstGeom prst="rect">
+            <a:avLst/>
+          </a:prstGeom>
+          <a:solidFill>
+            <a:srgbClr val="EDA100"/>
+          </a:solidFill>
+          <a:ln>
+            <a:noFill/>
+          </a:ln>
+          <a:effectLst/>
+        </p:spPr>
+        <p:style>
+          <a:lnRef idx="1">
+            <a:schemeClr val="accent1"/>
+          </a:lnRef>
+          <a:fillRef idx="3">
+            <a:schemeClr val="accent1"/>
+          </a:fillRef>
+          <a:effectRef idx="2">
+            <a:schemeClr val="accent1"/>
+          </a:effectRef>
+          <a:fontRef idx="minor">
+            <a:schemeClr val="lt1"/>
+          </a:fontRef>
+        </p:style>
+        <p:txBody>
+          <a:bodyPr rtlCol="0" anchor="ctr"/>
+          <a:lstStyle/>
+          <a:p>
+            <a:pPr algn="ctr"/>
+          </a:p>
+        </p:txBody>
+      </p:sp>
+      <p:sp>
+        <p:nvSpPr>
+          <p:cNvPr id="6" name="TextBox 5"/>
+          <p:cNvSpPr txBox="1"/>
+          <p:nvPr/>
+        </p:nvSpPr>
+        <p:spPr>
+          <a:xfrm>
+            <a:off x="640080" y="6473952"/>
+            <a:ext cx="7315200" cy="274320"/>
+          </a:xfrm>
+          <a:prstGeom prst="rect">
+            <a:avLst/>
+          </a:prstGeom>
+          <a:noFill/>
+        </p:spPr>
+        <p:txBody>
+          <a:bodyPr wrap="square">
+            <a:spAutoFit/>
+          </a:bodyPr>
+          <a:lstStyle/>
+          <a:p>
+            <a:pPr>
+              <a:defRPr sz="1000" b="0">
+                <a:solidFill>
+                  <a:srgbClr val="52514E"/>
+                </a:solidFill>
+                <a:latin typeface="Helvetica Neue"/>
+              </a:defRPr>
+            </a:pPr>
+            <a:r>
+              <a:t>Evermon — Averis × Monash Hackathon 2026</a:t>
+            </a:r>
+          </a:p>
+        </p:txBody>
+      </p:sp>
+      <p:sp>
+        <p:nvSpPr>
+          <p:cNvPr id="7" name="TextBox 6"/>
+          <p:cNvSpPr txBox="1"/>
+          <p:nvPr/>
+        </p:nvSpPr>
+        <p:spPr>
+          <a:xfrm>
+            <a:off x="11277295" y="6473952"/>
+            <a:ext cx="548640" cy="274320"/>
+          </a:xfrm>
+          <a:prstGeom prst="rect">
+            <a:avLst/>
+          </a:prstGeom>
+          <a:noFill/>
+        </p:spPr>
+        <p:txBody>
+          <a:bodyPr wrap="square">
+            <a:spAutoFit/>
+          </a:bodyPr>
+          <a:lstStyle/>
+          <a:p>
+            <a:pPr algn="r">
+              <a:defRPr sz="1000" b="1">
+                <a:solidFill>
+                  <a:srgbClr val="2A78D6"/>
+                </a:solidFill>
+                <a:latin typeface="Helvetica Neue"/>
+              </a:defRPr>
+            </a:pPr>
+            <a:r>
+              <a:t>10</a:t>
+            </a:r>
+          </a:p>
+        </p:txBody>
+      </p:sp>
+    </p:spTree>
+  </p:cSld>
+  <p:clrMapOvr>
+    <a:masterClrMapping/>
+  </p:clrMapOvr>
+</p:sld>
+</file>
+
+<file path=ppt/slides/slide11.xml><?xml version="1.0" encoding="utf-8"?>
+<p:sld xmlns:a="http://schemas.openxmlformats.org/drawingml/2006/main" xmlns:p="http://schemas.openxmlformats.org/presentationml/2006/main" xmlns:r="http://schemas.openxmlformats.org/officeDocument/2006/relationships">
+  <p:cSld>
+    <p:spTree>
+      <p:nvGrpSpPr>
+        <p:cNvPr id="1" name=""/>
+        <p:cNvGrpSpPr/>
+        <p:nvPr/>
+      </p:nvGrpSpPr>
+      <p:grpSpPr/>
+      <p:sp>
+        <p:nvSpPr>
+          <p:cNvPr id="2" name="Rectangle 1"/>
+          <p:cNvSpPr/>
+          <p:nvPr/>
+        </p:nvSpPr>
+        <p:spPr>
+          <a:xfrm>
+            <a:off x="0" y="0"/>
+            <a:ext cx="12191695" cy="1188720"/>
+          </a:xfrm>
+          <a:prstGeom prst="rect">
+            <a:avLst/>
+          </a:prstGeom>
+          <a:solidFill>
+            <a:srgbClr val="2A78D6"/>
+          </a:solidFill>
+          <a:ln>
+            <a:noFill/>
+          </a:ln>
+          <a:effectLst/>
+        </p:spPr>
+        <p:style>
+          <a:lnRef idx="1">
+            <a:schemeClr val="accent1"/>
+          </a:lnRef>
+          <a:fillRef idx="3">
+            <a:schemeClr val="accent1"/>
+          </a:fillRef>
+          <a:effectRef idx="2">
+            <a:schemeClr val="accent1"/>
+          </a:effectRef>
+          <a:fontRef idx="minor">
+            <a:schemeClr val="lt1"/>
+          </a:fontRef>
+        </p:style>
+        <p:txBody>
+          <a:bodyPr rtlCol="0" anchor="ctr"/>
+          <a:lstStyle/>
+          <a:p>
+            <a:pPr algn="ctr"/>
+          </a:p>
+        </p:txBody>
+      </p:sp>
+      <p:sp>
+        <p:nvSpPr>
+          <p:cNvPr id="3" name="TextBox 2"/>
+          <p:cNvSpPr txBox="1"/>
+          <p:nvPr/>
+        </p:nvSpPr>
+        <p:spPr>
+          <a:xfrm>
+            <a:off x="640080" y="274320"/>
+            <a:ext cx="10911535" cy="731520"/>
+          </a:xfrm>
+          <a:prstGeom prst="rect">
+            <a:avLst/>
+          </a:prstGeom>
+          <a:noFill/>
+        </p:spPr>
+        <p:txBody>
+          <a:bodyPr wrap="square">
+            <a:spAutoFit/>
+          </a:bodyPr>
+          <a:lstStyle/>
+          <a:p>
+            <a:pPr>
+              <a:defRPr sz="2800" b="1">
+                <a:solidFill>
+                  <a:srgbClr val="FFFFFF"/>
+                </a:solidFill>
+                <a:latin typeface="Helvetica Neue"/>
+              </a:defRPr>
+            </a:pPr>
+            <a:r>
+              <a:t>Three steps, under two minutes</a:t>
+            </a:r>
+          </a:p>
+        </p:txBody>
+      </p:sp>
+      <p:sp>
+        <p:nvSpPr>
+          <p:cNvPr id="4" name="TextBox 3"/>
+          <p:cNvSpPr txBox="1"/>
+          <p:nvPr/>
+        </p:nvSpPr>
+        <p:spPr>
+          <a:xfrm>
+            <a:off x="640080" y="1554480"/>
+            <a:ext cx="10911535" cy="4572000"/>
+          </a:xfrm>
+          <a:prstGeom prst="rect">
+            <a:avLst/>
+          </a:prstGeom>
+          <a:noFill/>
+        </p:spPr>
+        <p:txBody>
+          <a:bodyPr wrap="square">
+            <a:spAutoFit/>
+          </a:bodyPr>
+          <a:lstStyle/>
+          <a:p>
+            <a:pPr>
+              <a:spcAft>
+                <a:spcPts val="1600"/>
+              </a:spcAft>
+              <a:defRPr sz="1800" b="0">
+                <a:solidFill>
+                  <a:srgbClr val="0B0B0B"/>
+                </a:solidFill>
+                <a:latin typeface="Helvetica Neue"/>
+              </a:defRPr>
+            </a:pPr>
+            <a:r>
+              <a:t>▸  Classify: spam, invoice chase, and a real SI+draft-BL pair — sorted correctly in one pass.</a:t>
+            </a:r>
+          </a:p>
+          <a:p>
+            <a:pPr>
+              <a:spcAft>
+                <a:spcPts val="1600"/>
+              </a:spcAft>
+              <a:defRPr sz="1800" b="0">
+                <a:solidFill>
+                  <a:srgbClr val="0B0B0B"/>
+                </a:solidFill>
+                <a:latin typeface="Helvetica Neue"/>
+              </a:defRPr>
+            </a:pPr>
+            <a:r>
+              <a:t>▸  Relabelled fields ("Load Port" vs "Port of Loading") still align and flag a real mismatch.</a:t>
+            </a:r>
+          </a:p>
+          <a:p>
+            <a:pPr>
+              <a:spcAft>
+                <a:spcPts val="1600"/>
+              </a:spcAft>
+              <a:defRPr sz="1800" b="0">
+                <a:solidFill>
+                  <a:srgbClr val="0B0B0B"/>
+                </a:solidFill>
+                <a:latin typeface="Helvetica Neue"/>
+              </a:defRPr>
+            </a:pPr>
+            <a:r>
+              <a:t>▸  A missing/unreadable attachment escalates to NEEDS_REVIEW with the specific reason, not a guess.</a:t>
+            </a:r>
+          </a:p>
+        </p:txBody>
+      </p:sp>
+      <p:sp>
+        <p:nvSpPr>
+          <p:cNvPr id="5" name="Rectangle 4"/>
+          <p:cNvSpPr/>
+          <p:nvPr/>
+        </p:nvSpPr>
+        <p:spPr>
+          <a:xfrm>
+            <a:off x="0" y="6803136"/>
+            <a:ext cx="12191695" cy="54864"/>
+          </a:xfrm>
+          <a:prstGeom prst="rect">
+            <a:avLst/>
+          </a:prstGeom>
+          <a:solidFill>
+            <a:srgbClr val="EDA100"/>
+          </a:solidFill>
+          <a:ln>
+            <a:noFill/>
+          </a:ln>
+          <a:effectLst/>
+        </p:spPr>
+        <p:style>
+          <a:lnRef idx="1">
+            <a:schemeClr val="accent1"/>
+          </a:lnRef>
+          <a:fillRef idx="3">
+            <a:schemeClr val="accent1"/>
+          </a:fillRef>
+          <a:effectRef idx="2">
+            <a:schemeClr val="accent1"/>
+          </a:effectRef>
+          <a:fontRef idx="minor">
+            <a:schemeClr val="lt1"/>
+          </a:fontRef>
+        </p:style>
+        <p:txBody>
+          <a:bodyPr rtlCol="0" anchor="ctr"/>
+          <a:lstStyle/>
+          <a:p>
+            <a:pPr algn="ctr"/>
+          </a:p>
+        </p:txBody>
+      </p:sp>
+      <p:sp>
+        <p:nvSpPr>
+          <p:cNvPr id="6" name="TextBox 5"/>
+          <p:cNvSpPr txBox="1"/>
+          <p:nvPr/>
+        </p:nvSpPr>
+        <p:spPr>
+          <a:xfrm>
+            <a:off x="640080" y="6473952"/>
+            <a:ext cx="7315200" cy="274320"/>
+          </a:xfrm>
+          <a:prstGeom prst="rect">
+            <a:avLst/>
+          </a:prstGeom>
+          <a:noFill/>
+        </p:spPr>
+        <p:txBody>
+          <a:bodyPr wrap="square">
+            <a:spAutoFit/>
+          </a:bodyPr>
+          <a:lstStyle/>
+          <a:p>
+            <a:pPr>
+              <a:defRPr sz="1000" b="0">
+                <a:solidFill>
+                  <a:srgbClr val="52514E"/>
+                </a:solidFill>
+                <a:latin typeface="Helvetica Neue"/>
+              </a:defRPr>
+            </a:pPr>
+            <a:r>
+              <a:t>Evermon — Averis × Monash Hackathon 2026</a:t>
+            </a:r>
+          </a:p>
+        </p:txBody>
+      </p:sp>
+      <p:sp>
+        <p:nvSpPr>
+          <p:cNvPr id="7" name="TextBox 6"/>
+          <p:cNvSpPr txBox="1"/>
+          <p:nvPr/>
+        </p:nvSpPr>
+        <p:spPr>
+          <a:xfrm>
+            <a:off x="11277295" y="6473952"/>
+            <a:ext cx="548640" cy="274320"/>
+          </a:xfrm>
+          <a:prstGeom prst="rect">
+            <a:avLst/>
+          </a:prstGeom>
+          <a:noFill/>
+        </p:spPr>
+        <p:txBody>
+          <a:bodyPr wrap="square">
+            <a:spAutoFit/>
+          </a:bodyPr>
+          <a:lstStyle/>
+          <a:p>
+            <a:pPr algn="r">
+              <a:defRPr sz="1000" b="1">
+                <a:solidFill>
+                  <a:srgbClr val="2A78D6"/>
+                </a:solidFill>
+                <a:latin typeface="Helvetica Neue"/>
+              </a:defRPr>
+            </a:pPr>
+            <a:r>
+              <a:t>11</a:t>
+            </a:r>
+          </a:p>
+        </p:txBody>
+      </p:sp>
+    </p:spTree>
+  </p:cSld>
+  <p:clrMapOvr>
+    <a:masterClrMapping/>
+  </p:clrMapOvr>
+</p:sld>
+</file>
+
+<file path=ppt/slides/slide12.xml><?xml version="1.0" encoding="utf-8"?>
+<p:sld xmlns:a="http://schemas.openxmlformats.org/drawingml/2006/main" xmlns:p="http://schemas.openxmlformats.org/presentationml/2006/main" xmlns:r="http://schemas.openxmlformats.org/officeDocument/2006/relationships">
+  <p:cSld>
+    <p:spTree>
+      <p:nvGrpSpPr>
+        <p:cNvPr id="1" name=""/>
+        <p:cNvGrpSpPr/>
+        <p:nvPr/>
+      </p:nvGrpSpPr>
+      <p:grpSpPr/>
+      <p:sp>
+        <p:nvSpPr>
+          <p:cNvPr id="2" name="Rectangle 1"/>
+          <p:cNvSpPr/>
+          <p:nvPr/>
+        </p:nvSpPr>
+        <p:spPr>
+          <a:xfrm>
+            <a:off x="0" y="0"/>
+            <a:ext cx="12191695" cy="6858000"/>
+          </a:xfrm>
+          <a:prstGeom prst="rect">
+            <a:avLst/>
+          </a:prstGeom>
+          <a:solidFill>
+            <a:srgbClr val="F9F9F7"/>
+          </a:solidFill>
+          <a:ln>
+            <a:noFill/>
+          </a:ln>
+          <a:effectLst/>
+        </p:spPr>
+        <p:style>
+          <a:lnRef idx="1">
+            <a:schemeClr val="accent1"/>
+          </a:lnRef>
+          <a:fillRef idx="3">
+            <a:schemeClr val="accent1"/>
+          </a:fillRef>
+          <a:effectRef idx="2">
+            <a:schemeClr val="accent1"/>
+          </a:effectRef>
+          <a:fontRef idx="minor">
+            <a:schemeClr val="lt1"/>
+          </a:fontRef>
+        </p:style>
+        <p:txBody>
+          <a:bodyPr rtlCol="0" anchor="ctr"/>
+          <a:lstStyle/>
+          <a:p>
+            <a:pPr algn="ctr"/>
+          </a:p>
+        </p:txBody>
+      </p:sp>
+      <p:sp>
+        <p:nvSpPr>
+          <p:cNvPr id="3" name="TextBox 2"/>
+          <p:cNvSpPr txBox="1"/>
+          <p:nvPr/>
+        </p:nvSpPr>
+        <p:spPr>
+          <a:xfrm>
+            <a:off x="640080" y="457200"/>
+            <a:ext cx="10911535" cy="731520"/>
+          </a:xfrm>
+          <a:prstGeom prst="rect">
+            <a:avLst/>
+          </a:prstGeom>
+          <a:noFill/>
+        </p:spPr>
+        <p:txBody>
+          <a:bodyPr wrap="square">
+            <a:spAutoFit/>
+          </a:bodyPr>
+          <a:lstStyle/>
+          <a:p>
+            <a:pPr>
+              <a:defRPr sz="2800" b="1">
+                <a:solidFill>
+                  <a:srgbClr val="0B0B0B"/>
+                </a:solidFill>
+                <a:latin typeface="Helvetica Neue"/>
+              </a:defRPr>
+            </a:pPr>
+            <a:r>
+              <a:t>Verified against the organisers' own grader</a:t>
+            </a:r>
+          </a:p>
+        </p:txBody>
+      </p:sp>
+      <p:sp>
+        <p:nvSpPr>
+          <p:cNvPr id="4" name="TextBox 3"/>
+          <p:cNvSpPr txBox="1"/>
+          <p:nvPr/>
+        </p:nvSpPr>
+        <p:spPr>
+          <a:xfrm>
+            <a:off x="640080" y="2103120"/>
+            <a:ext cx="3637178" cy="1280160"/>
+          </a:xfrm>
+          <a:prstGeom prst="rect">
+            <a:avLst/>
+          </a:prstGeom>
+          <a:noFill/>
+        </p:spPr>
+        <p:txBody>
+          <a:bodyPr wrap="square">
+            <a:spAutoFit/>
+          </a:bodyPr>
+          <a:lstStyle/>
+          <a:p>
+            <a:pPr algn="ctr">
+              <a:defRPr sz="5600" b="1">
+                <a:solidFill>
+                  <a:srgbClr val="2A78D6"/>
+                </a:solidFill>
+                <a:latin typeface="Helvetica Neue"/>
+              </a:defRPr>
+            </a:pPr>
+            <a:r>
+              <a:t>1.0000</a:t>
+            </a:r>
+          </a:p>
+        </p:txBody>
+      </p:sp>
+      <p:sp>
+        <p:nvSpPr>
+          <p:cNvPr id="5" name="TextBox 4"/>
+          <p:cNvSpPr txBox="1"/>
+          <p:nvPr/>
+        </p:nvSpPr>
+        <p:spPr>
+          <a:xfrm>
+            <a:off x="640080" y="3383280"/>
+            <a:ext cx="3637178" cy="914400"/>
+          </a:xfrm>
+          <a:prstGeom prst="rect">
+            <a:avLst/>
+          </a:prstGeom>
+          <a:noFill/>
+        </p:spPr>
+        <p:txBody>
+          <a:bodyPr wrap="square">
+            <a:spAutoFit/>
+          </a:bodyPr>
+          <a:lstStyle/>
+          <a:p>
+            <a:pPr algn="ctr">
+              <a:defRPr sz="1500">
+                <a:solidFill>
+                  <a:srgbClr val="52514E"/>
+                </a:solidFill>
+                <a:latin typeface="Helvetica Neue"/>
+              </a:defRPr>
+            </a:pPr>
+            <a:r>
+              <a:t>overall score — classification, comparison, escalation</a:t>
+            </a:r>
+          </a:p>
+        </p:txBody>
+      </p:sp>
+      <p:sp>
+        <p:nvSpPr>
+          <p:cNvPr id="6" name="TextBox 5"/>
+          <p:cNvSpPr txBox="1"/>
+          <p:nvPr/>
+        </p:nvSpPr>
+        <p:spPr>
+          <a:xfrm>
+            <a:off x="4277258" y="2103120"/>
+            <a:ext cx="3637178" cy="1280160"/>
+          </a:xfrm>
+          <a:prstGeom prst="rect">
+            <a:avLst/>
+          </a:prstGeom>
+          <a:noFill/>
+        </p:spPr>
+        <p:txBody>
+          <a:bodyPr wrap="square">
+            <a:spAutoFit/>
+          </a:bodyPr>
+          <a:lstStyle/>
+          <a:p>
+            <a:pPr algn="ctr">
+              <a:defRPr sz="5600" b="1">
+                <a:solidFill>
+                  <a:srgbClr val="0CA30C"/>
+                </a:solidFill>
+                <a:latin typeface="Helvetica Neue"/>
+              </a:defRPr>
+            </a:pPr>
+            <a:r>
+              <a:t>129</a:t>
+            </a:r>
+          </a:p>
+        </p:txBody>
+      </p:sp>
+      <p:sp>
+        <p:nvSpPr>
+          <p:cNvPr id="7" name="TextBox 6"/>
+          <p:cNvSpPr txBox="1"/>
+          <p:nvPr/>
+        </p:nvSpPr>
+        <p:spPr>
+          <a:xfrm>
+            <a:off x="4277258" y="3383280"/>
+            <a:ext cx="3637178" cy="914400"/>
+          </a:xfrm>
+          <a:prstGeom prst="rect">
+            <a:avLst/>
+          </a:prstGeom>
+          <a:noFill/>
+        </p:spPr>
+        <p:txBody>
+          <a:bodyPr wrap="square">
+            <a:spAutoFit/>
+          </a:bodyPr>
+          <a:lstStyle/>
+          <a:p>
+            <a:pPr algn="ctr">
+              <a:defRPr sz="1500">
+                <a:solidFill>
+                  <a:srgbClr val="52514E"/>
+                </a:solidFill>
+                <a:latin typeface="Helvetica Neue"/>
+              </a:defRPr>
+            </a:pPr>
+            <a:r>
+              <a:t>deterministic tests — no network, no LLM</a:t>
+            </a:r>
+          </a:p>
+        </p:txBody>
+      </p:sp>
+      <p:sp>
+        <p:nvSpPr>
+          <p:cNvPr id="8" name="TextBox 7"/>
+          <p:cNvSpPr txBox="1"/>
+          <p:nvPr/>
+        </p:nvSpPr>
+        <p:spPr>
+          <a:xfrm>
+            <a:off x="7914436" y="2103120"/>
+            <a:ext cx="3637178" cy="1280160"/>
+          </a:xfrm>
+          <a:prstGeom prst="rect">
+            <a:avLst/>
+          </a:prstGeom>
+          <a:noFill/>
+        </p:spPr>
+        <p:txBody>
+          <a:bodyPr wrap="square">
+            <a:spAutoFit/>
+          </a:bodyPr>
+          <a:lstStyle/>
+          <a:p>
+            <a:pPr algn="ctr">
+              <a:defRPr sz="5600" b="1">
+                <a:solidFill>
+                  <a:srgbClr val="D03B3B"/>
+                </a:solidFill>
+                <a:latin typeface="Helvetica Neue"/>
+              </a:defRPr>
+            </a:pPr>
+            <a:r>
+              <a:t>46 / 46</a:t>
+            </a:r>
+          </a:p>
+        </p:txBody>
+      </p:sp>
+      <p:sp>
+        <p:nvSpPr>
+          <p:cNvPr id="9" name="TextBox 8"/>
+          <p:cNvSpPr txBox="1"/>
+          <p:nvPr/>
+        </p:nvSpPr>
+        <p:spPr>
+          <a:xfrm>
+            <a:off x="7914436" y="3383280"/>
+            <a:ext cx="3637178" cy="914400"/>
+          </a:xfrm>
+          <a:prstGeom prst="rect">
+            <a:avLst/>
+          </a:prstGeom>
+          <a:noFill/>
+        </p:spPr>
+        <p:txBody>
+          <a:bodyPr wrap="square">
+            <a:spAutoFit/>
+          </a:bodyPr>
+          <a:lstStyle/>
+          <a:p>
+            <a:pPr algn="ctr">
+              <a:defRPr sz="1500">
+                <a:solidFill>
+                  <a:srgbClr val="52514E"/>
+                </a:solidFill>
+                <a:latin typeface="Helvetica Neue"/>
+              </a:defRPr>
+            </a:pPr>
+            <a:r>
+              <a:t>real defect emails caught, 20 / 20 correctly escalated</a:t>
+            </a:r>
+          </a:p>
+        </p:txBody>
+      </p:sp>
+      <p:sp>
+        <p:nvSpPr>
+          <p:cNvPr id="10" name="Rectangle 9"/>
+          <p:cNvSpPr/>
+          <p:nvPr/>
+        </p:nvSpPr>
+        <p:spPr>
+          <a:xfrm>
+            <a:off x="0" y="6803136"/>
+            <a:ext cx="12191695" cy="54864"/>
+          </a:xfrm>
+          <a:prstGeom prst="rect">
+            <a:avLst/>
+          </a:prstGeom>
+          <a:solidFill>
+            <a:srgbClr val="EDA100"/>
+          </a:solidFill>
+          <a:ln>
+            <a:noFill/>
+          </a:ln>
+          <a:effectLst/>
+        </p:spPr>
+        <p:style>
+          <a:lnRef idx="1">
+            <a:schemeClr val="accent1"/>
+          </a:lnRef>
+          <a:fillRef idx="3">
+            <a:schemeClr val="accent1"/>
+          </a:fillRef>
+          <a:effectRef idx="2">
+            <a:schemeClr val="accent1"/>
+          </a:effectRef>
+          <a:fontRef idx="minor">
+            <a:schemeClr val="lt1"/>
+          </a:fontRef>
+        </p:style>
+        <p:txBody>
+          <a:bodyPr rtlCol="0" anchor="ctr"/>
+          <a:lstStyle/>
+          <a:p>
+            <a:pPr algn="ctr"/>
+          </a:p>
+        </p:txBody>
+      </p:sp>
+      <p:sp>
+        <p:nvSpPr>
+          <p:cNvPr id="11" name="TextBox 10"/>
+          <p:cNvSpPr txBox="1"/>
+          <p:nvPr/>
+        </p:nvSpPr>
+        <p:spPr>
+          <a:xfrm>
+            <a:off x="640080" y="6473952"/>
+            <a:ext cx="7315200" cy="274320"/>
+          </a:xfrm>
+          <a:prstGeom prst="rect">
+            <a:avLst/>
+          </a:prstGeom>
+          <a:noFill/>
+        </p:spPr>
+        <p:txBody>
+          <a:bodyPr wrap="square">
+            <a:spAutoFit/>
+          </a:bodyPr>
+          <a:lstStyle/>
+          <a:p>
+            <a:pPr>
+              <a:defRPr sz="1000" b="0">
+                <a:solidFill>
+                  <a:srgbClr val="52514E"/>
+                </a:solidFill>
+                <a:latin typeface="Helvetica Neue"/>
+              </a:defRPr>
+            </a:pPr>
+            <a:r>
+              <a:t>Evermon — Averis × Monash Hackathon 2026</a:t>
+            </a:r>
+          </a:p>
+        </p:txBody>
+      </p:sp>
+      <p:sp>
+        <p:nvSpPr>
+          <p:cNvPr id="12" name="TextBox 11"/>
+          <p:cNvSpPr txBox="1"/>
+          <p:nvPr/>
+        </p:nvSpPr>
+        <p:spPr>
+          <a:xfrm>
+            <a:off x="11277295" y="6473952"/>
+            <a:ext cx="548640" cy="274320"/>
+          </a:xfrm>
+          <a:prstGeom prst="rect">
+            <a:avLst/>
+          </a:prstGeom>
+          <a:noFill/>
+        </p:spPr>
+        <p:txBody>
+          <a:bodyPr wrap="square">
+            <a:spAutoFit/>
+          </a:bodyPr>
+          <a:lstStyle/>
+          <a:p>
+            <a:pPr algn="r">
+              <a:defRPr sz="1000" b="1">
+                <a:solidFill>
+                  <a:srgbClr val="2A78D6"/>
+                </a:solidFill>
+                <a:latin typeface="Helvetica Neue"/>
+              </a:defRPr>
+            </a:pPr>
+            <a:r>
+              <a:t>12</a:t>
+            </a:r>
+          </a:p>
+        </p:txBody>
+      </p:sp>
+    </p:spTree>
+  </p:cSld>
+  <p:clrMapOvr>
+    <a:masterClrMapping/>
+  </p:clrMapOvr>
+</p:sld>
+</file>
+
+<file path=ppt/slides/slide13.xml><?xml version="1.0" encoding="utf-8"?>
+<p:sld xmlns:a="http://schemas.openxmlformats.org/drawingml/2006/main" xmlns:p="http://schemas.openxmlformats.org/presentationml/2006/main" xmlns:r="http://schemas.openxmlformats.org/officeDocument/2006/relationships">
+  <p:cSld>
+    <p:spTree>
+      <p:nvGrpSpPr>
+        <p:cNvPr id="1" name=""/>
+        <p:cNvGrpSpPr/>
+        <p:nvPr/>
+      </p:nvGrpSpPr>
+      <p:grpSpPr/>
+      <p:sp>
+        <p:nvSpPr>
+          <p:cNvPr id="2" name="Rectangle 1"/>
+          <p:cNvSpPr/>
+          <p:nvPr/>
+        </p:nvSpPr>
+        <p:spPr>
+          <a:xfrm>
+            <a:off x="0" y="0"/>
+            <a:ext cx="12191695" cy="6858000"/>
+          </a:xfrm>
+          <a:prstGeom prst="rect">
+            <a:avLst/>
+          </a:prstGeom>
+          <a:solidFill>
+            <a:srgbClr val="0D1B2A"/>
+          </a:solidFill>
+          <a:ln>
+            <a:noFill/>
+          </a:ln>
+          <a:effectLst/>
+        </p:spPr>
+        <p:style>
+          <a:lnRef idx="1">
+            <a:schemeClr val="accent1"/>
+          </a:lnRef>
+          <a:fillRef idx="3">
+            <a:schemeClr val="accent1"/>
+          </a:fillRef>
+          <a:effectRef idx="2">
+            <a:schemeClr val="accent1"/>
+          </a:effectRef>
+          <a:fontRef idx="minor">
+            <a:schemeClr val="lt1"/>
+          </a:fontRef>
+        </p:style>
+        <p:txBody>
+          <a:bodyPr rtlCol="0" anchor="ctr"/>
+          <a:lstStyle/>
+          <a:p>
+            <a:pPr algn="ctr"/>
+          </a:p>
+        </p:txBody>
+      </p:sp>
+      <p:sp>
+        <p:nvSpPr>
+          <p:cNvPr id="3" name="Rectangle 2"/>
+          <p:cNvSpPr/>
+          <p:nvPr/>
+        </p:nvSpPr>
+        <p:spPr>
+          <a:xfrm>
+            <a:off x="0" y="0"/>
+            <a:ext cx="12191695" cy="109728"/>
+          </a:xfrm>
+          <a:prstGeom prst="rect">
+            <a:avLst/>
+          </a:prstGeom>
+          <a:solidFill>
+            <a:srgbClr val="EDA100"/>
+          </a:solidFill>
+          <a:ln>
+            <a:noFill/>
+          </a:ln>
+          <a:effectLst/>
+        </p:spPr>
+        <p:style>
+          <a:lnRef idx="1">
+            <a:schemeClr val="accent1"/>
+          </a:lnRef>
+          <a:fillRef idx="3">
+            <a:schemeClr val="accent1"/>
+          </a:fillRef>
+          <a:effectRef idx="2">
+            <a:schemeClr val="accent1"/>
+          </a:effectRef>
+          <a:fontRef idx="minor">
+            <a:schemeClr val="lt1"/>
+          </a:fontRef>
+        </p:style>
+        <p:txBody>
+          <a:bodyPr rtlCol="0" anchor="ctr"/>
+          <a:lstStyle/>
+          <a:p>
+            <a:pPr algn="ctr"/>
+          </a:p>
+        </p:txBody>
+      </p:sp>
+      <p:sp>
+        <p:nvSpPr>
+          <p:cNvPr id="4" name="TextBox 3"/>
+          <p:cNvSpPr txBox="1"/>
+          <p:nvPr/>
+        </p:nvSpPr>
+        <p:spPr>
+          <a:xfrm>
+            <a:off x="640080" y="2103120"/>
+            <a:ext cx="10911535" cy="1097280"/>
+          </a:xfrm>
+          <a:prstGeom prst="rect">
+            <a:avLst/>
+          </a:prstGeom>
+          <a:noFill/>
+        </p:spPr>
+        <p:txBody>
+          <a:bodyPr wrap="square">
+            <a:spAutoFit/>
+          </a:bodyPr>
+          <a:lstStyle/>
+          <a:p>
+            <a:pPr>
+              <a:defRPr sz="4800" b="1">
+                <a:solidFill>
+                  <a:srgbClr val="FFFFFF"/>
+                </a:solidFill>
+                <a:latin typeface="Helvetica Neue"/>
+              </a:defRPr>
+            </a:pPr>
+            <a:r>
+              <a:t>Try it yourself</a:t>
+            </a:r>
+          </a:p>
+        </p:txBody>
+      </p:sp>
+      <p:sp>
+        <p:nvSpPr>
+          <p:cNvPr id="5" name="TextBox 4"/>
+          <p:cNvSpPr txBox="1"/>
+          <p:nvPr/>
+        </p:nvSpPr>
+        <p:spPr>
+          <a:xfrm>
+            <a:off x="640080" y="3383280"/>
+            <a:ext cx="10911535" cy="2286000"/>
+          </a:xfrm>
+          <a:prstGeom prst="rect">
+            <a:avLst/>
+          </a:prstGeom>
+          <a:noFill/>
+        </p:spPr>
+        <p:txBody>
+          <a:bodyPr wrap="square">
+            <a:spAutoFit/>
+          </a:bodyPr>
+          <a:lstStyle/>
+          <a:p>
+            <a:pPr>
+              <a:spcAft>
+                <a:spcPts val="1000"/>
+              </a:spcAft>
+              <a:defRPr sz="1800" b="0">
+                <a:solidFill>
+                  <a:srgbClr val="C3C9D1"/>
+                </a:solidFill>
+                <a:latin typeface="Helvetica Neue"/>
+              </a:defRPr>
+            </a:pPr>
+            <a:r>
+              <a:t>Live prototype: evermon-demo.nazrijz336.workers.dev</a:t>
+            </a:r>
+          </a:p>
+          <a:p>
+            <a:pPr>
+              <a:spcAft>
+                <a:spcPts val="1000"/>
+              </a:spcAft>
+              <a:defRPr sz="1800" b="0">
+                <a:solidFill>
+                  <a:srgbClr val="C3C9D1"/>
+                </a:solidFill>
+                <a:latin typeface="Helvetica Neue"/>
+              </a:defRPr>
+            </a:pPr>
+            <a:r>
+              <a:t>Source: github.com/ponli550/Evermon</a:t>
+            </a:r>
+          </a:p>
+          <a:p>
+            <a:pPr>
+              <a:spcAft>
+                <a:spcPts val="1000"/>
+              </a:spcAft>
+              <a:defRPr sz="1800" b="0">
+                <a:solidFill>
+                  <a:srgbClr val="C3C9D1"/>
+                </a:solidFill>
+                <a:latin typeface="Helvetica Neue"/>
+              </a:defRPr>
+            </a:pPr>
+            <a:r>
+              <a:t>Thank you.</a:t>
+            </a:r>
+          </a:p>
+        </p:txBody>
+      </p:sp>
+      <p:sp>
+        <p:nvSpPr>
+          <p:cNvPr id="6" name="Rectangle 5"/>
+          <p:cNvSpPr/>
+          <p:nvPr/>
+        </p:nvSpPr>
+        <p:spPr>
+          <a:xfrm>
+            <a:off x="0" y="6803136"/>
+            <a:ext cx="12191695" cy="54864"/>
+          </a:xfrm>
+          <a:prstGeom prst="rect">
+            <a:avLst/>
+          </a:prstGeom>
+          <a:solidFill>
+            <a:srgbClr val="EDA100"/>
+          </a:solidFill>
+          <a:ln>
+            <a:noFill/>
+          </a:ln>
+          <a:effectLst/>
+        </p:spPr>
+        <p:style>
+          <a:lnRef idx="1">
+            <a:schemeClr val="accent1"/>
+          </a:lnRef>
+          <a:fillRef idx="3">
+            <a:schemeClr val="accent1"/>
+          </a:fillRef>
+          <a:effectRef idx="2">
+            <a:schemeClr val="accent1"/>
+          </a:effectRef>
+          <a:fontRef idx="minor">
+            <a:schemeClr val="lt1"/>
+          </a:fontRef>
+        </p:style>
+        <p:txBody>
+          <a:bodyPr rtlCol="0" anchor="ctr"/>
+          <a:lstStyle/>
+          <a:p>
+            <a:pPr algn="ctr"/>
+          </a:p>
+        </p:txBody>
+      </p:sp>
+      <p:sp>
+        <p:nvSpPr>
+          <p:cNvPr id="7" name="TextBox 6"/>
+          <p:cNvSpPr txBox="1"/>
+          <p:nvPr/>
+        </p:nvSpPr>
+        <p:spPr>
+          <a:xfrm>
+            <a:off x="640080" y="6473952"/>
+            <a:ext cx="7315200" cy="274320"/>
+          </a:xfrm>
+          <a:prstGeom prst="rect">
+            <a:avLst/>
+          </a:prstGeom>
+          <a:noFill/>
+        </p:spPr>
+        <p:txBody>
+          <a:bodyPr wrap="square">
+            <a:spAutoFit/>
+          </a:bodyPr>
+          <a:lstStyle/>
+          <a:p>
+            <a:pPr>
+              <a:defRPr sz="1000" b="0">
+                <a:solidFill>
+                  <a:srgbClr val="52514E"/>
+                </a:solidFill>
+                <a:latin typeface="Helvetica Neue"/>
+              </a:defRPr>
+            </a:pPr>
+            <a:r>
+              <a:t>Evermon — Averis × Monash Hackathon 2026</a:t>
+            </a:r>
+          </a:p>
+        </p:txBody>
+      </p:sp>
+      <p:sp>
+        <p:nvSpPr>
+          <p:cNvPr id="8" name="TextBox 7"/>
+          <p:cNvSpPr txBox="1"/>
+          <p:nvPr/>
+        </p:nvSpPr>
+        <p:spPr>
+          <a:xfrm>
+            <a:off x="11277295" y="6473952"/>
+            <a:ext cx="548640" cy="274320"/>
+          </a:xfrm>
+          <a:prstGeom prst="rect">
+            <a:avLst/>
+          </a:prstGeom>
+          <a:noFill/>
+        </p:spPr>
+        <p:txBody>
+          <a:bodyPr wrap="square">
+            <a:spAutoFit/>
+          </a:bodyPr>
+          <a:lstStyle/>
+          <a:p>
+            <a:pPr algn="r">
+              <a:defRPr sz="1000" b="1">
+                <a:solidFill>
+                  <a:srgbClr val="2A78D6"/>
+                </a:solidFill>
+                <a:latin typeface="Helvetica Neue"/>
+              </a:defRPr>
+            </a:pPr>
+            <a:r>
+              <a:t>13</a:t>
             </a:r>
           </a:p>
         </p:txBody>
@@ -3163,37 +4726,45 @@
       <p:grpSpPr/>
       <p:sp>
         <p:nvSpPr>
-          <p:cNvPr id="2" name="TextBox 1"/>
-          <p:cNvSpPr txBox="1"/>
-          <p:nvPr/>
-        </p:nvSpPr>
-        <p:spPr>
-          <a:xfrm>
-            <a:off x="548640" y="365760"/>
-            <a:ext cx="11094415" cy="822960"/>
-          </a:xfrm>
-          <a:prstGeom prst="rect">
-            <a:avLst/>
-          </a:prstGeom>
-          <a:noFill/>
-        </p:spPr>
-        <p:txBody>
-          <a:bodyPr wrap="none">
-            <a:spAutoFit/>
-          </a:bodyPr>
-          <a:lstStyle/>
-          <a:p>
-            <a:pPr>
-              <a:defRPr sz="3000" b="1">
-                <a:solidFill>
-                  <a:srgbClr val="003366"/>
-                </a:solidFill>
-                <a:latin typeface="Calibri"/>
-              </a:defRPr>
-            </a:pPr>
-            <a:r>
-              <a:t>one-liner</a:t>
-            </a:r>
+          <p:cNvPr id="2" name="Rectangle 1"/>
+          <p:cNvSpPr/>
+          <p:nvPr/>
+        </p:nvSpPr>
+        <p:spPr>
+          <a:xfrm>
+            <a:off x="0" y="0"/>
+            <a:ext cx="12191695" cy="6858000"/>
+          </a:xfrm>
+          <a:prstGeom prst="rect">
+            <a:avLst/>
+          </a:prstGeom>
+          <a:solidFill>
+            <a:srgbClr val="2A78D6"/>
+          </a:solidFill>
+          <a:ln>
+            <a:noFill/>
+          </a:ln>
+          <a:effectLst/>
+        </p:spPr>
+        <p:style>
+          <a:lnRef idx="1">
+            <a:schemeClr val="accent1"/>
+          </a:lnRef>
+          <a:fillRef idx="3">
+            <a:schemeClr val="accent1"/>
+          </a:fillRef>
+          <a:effectRef idx="2">
+            <a:schemeClr val="accent1"/>
+          </a:effectRef>
+          <a:fontRef idx="minor">
+            <a:schemeClr val="lt1"/>
+          </a:fontRef>
+        </p:style>
+        <p:txBody>
+          <a:bodyPr rtlCol="0" anchor="ctr"/>
+          <a:lstStyle/>
+          <a:p>
+            <a:pPr algn="ctr"/>
           </a:p>
         </p:txBody>
       </p:sp>
@@ -3205,8 +4776,8 @@
         </p:nvSpPr>
         <p:spPr>
           <a:xfrm>
-            <a:off x="548640" y="1371600"/>
-            <a:ext cx="11094415" cy="5029200"/>
+            <a:off x="640080" y="2011680"/>
+            <a:ext cx="2286000" cy="1280160"/>
           </a:xfrm>
           <a:prstGeom prst="rect">
             <a:avLst/>
@@ -3220,15 +4791,167 @@
           <a:lstStyle/>
           <a:p>
             <a:pPr>
-              <a:defRPr sz="2000">
-                <a:solidFill>
-                  <a:srgbClr val="333333"/>
-                </a:solidFill>
-                <a:latin typeface="Calibri"/>
+              <a:defRPr sz="8000" b="1">
+                <a:solidFill>
+                  <a:srgbClr val="EDA100"/>
+                </a:solidFill>
+                <a:latin typeface="Helvetica Neue"/>
               </a:defRPr>
             </a:pPr>
             <a:r>
-              <a:t>Evermon reads a shipping-documentation inbox, matches SI against draft BL by meaning (not header text), flags the seven fields that actually matter, and escalates to a human with a stated reason when it can't decide.</a:t>
+              <a:t>01</a:t>
+            </a:r>
+          </a:p>
+        </p:txBody>
+      </p:sp>
+      <p:sp>
+        <p:nvSpPr>
+          <p:cNvPr id="4" name="TextBox 3"/>
+          <p:cNvSpPr txBox="1"/>
+          <p:nvPr/>
+        </p:nvSpPr>
+        <p:spPr>
+          <a:xfrm>
+            <a:off x="640080" y="3200400"/>
+            <a:ext cx="10911535" cy="1188720"/>
+          </a:xfrm>
+          <a:prstGeom prst="rect">
+            <a:avLst/>
+          </a:prstGeom>
+          <a:noFill/>
+        </p:spPr>
+        <p:txBody>
+          <a:bodyPr wrap="square">
+            <a:spAutoFit/>
+          </a:bodyPr>
+          <a:lstStyle/>
+          <a:p>
+            <a:pPr>
+              <a:defRPr sz="4000" b="1">
+                <a:solidFill>
+                  <a:srgbClr val="FFFFFF"/>
+                </a:solidFill>
+                <a:latin typeface="Helvetica Neue"/>
+              </a:defRPr>
+            </a:pPr>
+            <a:r>
+              <a:t>The Problem</a:t>
+            </a:r>
+          </a:p>
+        </p:txBody>
+      </p:sp>
+      <p:sp>
+        <p:nvSpPr>
+          <p:cNvPr id="5" name="Rectangle 4"/>
+          <p:cNvSpPr/>
+          <p:nvPr/>
+        </p:nvSpPr>
+        <p:spPr>
+          <a:xfrm>
+            <a:off x="0" y="6803136"/>
+            <a:ext cx="12191695" cy="54864"/>
+          </a:xfrm>
+          <a:prstGeom prst="rect">
+            <a:avLst/>
+          </a:prstGeom>
+          <a:solidFill>
+            <a:srgbClr val="EDA100"/>
+          </a:solidFill>
+          <a:ln>
+            <a:noFill/>
+          </a:ln>
+          <a:effectLst/>
+        </p:spPr>
+        <p:style>
+          <a:lnRef idx="1">
+            <a:schemeClr val="accent1"/>
+          </a:lnRef>
+          <a:fillRef idx="3">
+            <a:schemeClr val="accent1"/>
+          </a:fillRef>
+          <a:effectRef idx="2">
+            <a:schemeClr val="accent1"/>
+          </a:effectRef>
+          <a:fontRef idx="minor">
+            <a:schemeClr val="lt1"/>
+          </a:fontRef>
+        </p:style>
+        <p:txBody>
+          <a:bodyPr rtlCol="0" anchor="ctr"/>
+          <a:lstStyle/>
+          <a:p>
+            <a:pPr algn="ctr"/>
+          </a:p>
+        </p:txBody>
+      </p:sp>
+      <p:sp>
+        <p:nvSpPr>
+          <p:cNvPr id="6" name="TextBox 5"/>
+          <p:cNvSpPr txBox="1"/>
+          <p:nvPr/>
+        </p:nvSpPr>
+        <p:spPr>
+          <a:xfrm>
+            <a:off x="640080" y="6473952"/>
+            <a:ext cx="7315200" cy="274320"/>
+          </a:xfrm>
+          <a:prstGeom prst="rect">
+            <a:avLst/>
+          </a:prstGeom>
+          <a:noFill/>
+        </p:spPr>
+        <p:txBody>
+          <a:bodyPr wrap="square">
+            <a:spAutoFit/>
+          </a:bodyPr>
+          <a:lstStyle/>
+          <a:p>
+            <a:pPr>
+              <a:defRPr sz="1000" b="0">
+                <a:solidFill>
+                  <a:srgbClr val="52514E"/>
+                </a:solidFill>
+                <a:latin typeface="Helvetica Neue"/>
+              </a:defRPr>
+            </a:pPr>
+            <a:r>
+              <a:t>Evermon — Averis × Monash Hackathon 2026</a:t>
+            </a:r>
+          </a:p>
+        </p:txBody>
+      </p:sp>
+      <p:sp>
+        <p:nvSpPr>
+          <p:cNvPr id="7" name="TextBox 6"/>
+          <p:cNvSpPr txBox="1"/>
+          <p:nvPr/>
+        </p:nvSpPr>
+        <p:spPr>
+          <a:xfrm>
+            <a:off x="11277295" y="6473952"/>
+            <a:ext cx="548640" cy="274320"/>
+          </a:xfrm>
+          <a:prstGeom prst="rect">
+            <a:avLst/>
+          </a:prstGeom>
+          <a:noFill/>
+        </p:spPr>
+        <p:txBody>
+          <a:bodyPr wrap="square">
+            <a:spAutoFit/>
+          </a:bodyPr>
+          <a:lstStyle/>
+          <a:p>
+            <a:pPr algn="r">
+              <a:defRPr sz="1000" b="1">
+                <a:solidFill>
+                  <a:srgbClr val="2A78D6"/>
+                </a:solidFill>
+                <a:latin typeface="Helvetica Neue"/>
+              </a:defRPr>
+            </a:pPr>
+            <a:r>
+              <a:t>2</a:t>
             </a:r>
           </a:p>
         </p:txBody>
@@ -3253,37 +4976,45 @@
       <p:grpSpPr/>
       <p:sp>
         <p:nvSpPr>
-          <p:cNvPr id="2" name="TextBox 1"/>
-          <p:cNvSpPr txBox="1"/>
-          <p:nvPr/>
-        </p:nvSpPr>
-        <p:spPr>
-          <a:xfrm>
-            <a:off x="548640" y="365760"/>
-            <a:ext cx="11094415" cy="822960"/>
-          </a:xfrm>
-          <a:prstGeom prst="rect">
-            <a:avLst/>
-          </a:prstGeom>
-          <a:noFill/>
-        </p:spPr>
-        <p:txBody>
-          <a:bodyPr wrap="none">
-            <a:spAutoFit/>
-          </a:bodyPr>
-          <a:lstStyle/>
-          <a:p>
-            <a:pPr>
-              <a:defRPr sz="3000" b="1">
-                <a:solidFill>
-                  <a:srgbClr val="003366"/>
-                </a:solidFill>
-                <a:latin typeface="Calibri"/>
-              </a:defRPr>
-            </a:pPr>
-            <a:r>
-              <a:t>problem</a:t>
-            </a:r>
+          <p:cNvPr id="2" name="Rectangle 1"/>
+          <p:cNvSpPr/>
+          <p:nvPr/>
+        </p:nvSpPr>
+        <p:spPr>
+          <a:xfrm>
+            <a:off x="0" y="0"/>
+            <a:ext cx="12191695" cy="1188720"/>
+          </a:xfrm>
+          <a:prstGeom prst="rect">
+            <a:avLst/>
+          </a:prstGeom>
+          <a:solidFill>
+            <a:srgbClr val="2A78D6"/>
+          </a:solidFill>
+          <a:ln>
+            <a:noFill/>
+          </a:ln>
+          <a:effectLst/>
+        </p:spPr>
+        <p:style>
+          <a:lnRef idx="1">
+            <a:schemeClr val="accent1"/>
+          </a:lnRef>
+          <a:fillRef idx="3">
+            <a:schemeClr val="accent1"/>
+          </a:fillRef>
+          <a:effectRef idx="2">
+            <a:schemeClr val="accent1"/>
+          </a:effectRef>
+          <a:fontRef idx="minor">
+            <a:schemeClr val="lt1"/>
+          </a:fontRef>
+        </p:style>
+        <p:txBody>
+          <a:bodyPr rtlCol="0" anchor="ctr"/>
+          <a:lstStyle/>
+          <a:p>
+            <a:pPr algn="ctr"/>
           </a:p>
         </p:txBody>
       </p:sp>
@@ -3295,8 +5026,8 @@
         </p:nvSpPr>
         <p:spPr>
           <a:xfrm>
-            <a:off x="548640" y="1371600"/>
-            <a:ext cx="11094415" cy="5029200"/>
+            <a:off x="640080" y="274320"/>
+            <a:ext cx="10911535" cy="731520"/>
           </a:xfrm>
           <a:prstGeom prst="rect">
             <a:avLst/>
@@ -3310,15 +5041,202 @@
           <a:lstStyle/>
           <a:p>
             <a:pPr>
-              <a:defRPr sz="2000">
-                <a:solidFill>
-                  <a:srgbClr val="333333"/>
-                </a:solidFill>
-                <a:latin typeface="Calibri"/>
+              <a:defRPr sz="2800" b="1">
+                <a:solidFill>
+                  <a:srgbClr val="FFFFFF"/>
+                </a:solidFill>
+                <a:latin typeface="Helvetica Neue"/>
               </a:defRPr>
             </a:pPr>
             <a:r>
-              <a:t>Clerks manually cross-check SI vs BL — shipper, consignee, notify party, load/discharge port, container count, gross weight — across documents that never use the same labels ("Port of Loading" vs "Load Port", units hidden in a mixed-language gloss). Slow, and a missed mismatch puts the wrong consignee on a negotiable document. This is real and it's the honest problem — don't inflate it further.</a:t>
+              <a:t>Clerks manually cross-check SI vs BL</a:t>
+            </a:r>
+          </a:p>
+        </p:txBody>
+      </p:sp>
+      <p:sp>
+        <p:nvSpPr>
+          <p:cNvPr id="4" name="TextBox 3"/>
+          <p:cNvSpPr txBox="1"/>
+          <p:nvPr/>
+        </p:nvSpPr>
+        <p:spPr>
+          <a:xfrm>
+            <a:off x="640080" y="1554480"/>
+            <a:ext cx="10911535" cy="4572000"/>
+          </a:xfrm>
+          <a:prstGeom prst="rect">
+            <a:avLst/>
+          </a:prstGeom>
+          <a:noFill/>
+        </p:spPr>
+        <p:txBody>
+          <a:bodyPr wrap="square">
+            <a:spAutoFit/>
+          </a:bodyPr>
+          <a:lstStyle/>
+          <a:p>
+            <a:pPr>
+              <a:spcAft>
+                <a:spcPts val="1600"/>
+              </a:spcAft>
+              <a:defRPr sz="1800" b="0">
+                <a:solidFill>
+                  <a:srgbClr val="0B0B0B"/>
+                </a:solidFill>
+                <a:latin typeface="Helvetica Neue"/>
+              </a:defRPr>
+            </a:pPr>
+            <a:r>
+              <a:t>▸  Seven fields, by hand: shipper, consignee, notify party, load/discharge port, container count, gross weight.</a:t>
+            </a:r>
+          </a:p>
+          <a:p>
+            <a:pPr>
+              <a:spcAft>
+                <a:spcPts val="1600"/>
+              </a:spcAft>
+              <a:defRPr sz="1800" b="0">
+                <a:solidFill>
+                  <a:srgbClr val="0B0B0B"/>
+                </a:solidFill>
+                <a:latin typeface="Helvetica Neue"/>
+              </a:defRPr>
+            </a:pPr>
+            <a:r>
+              <a:t>▸  Documents never use the same labels — "Port of Loading" vs "Load Port".</a:t>
+            </a:r>
+          </a:p>
+          <a:p>
+            <a:pPr>
+              <a:spcAft>
+                <a:spcPts val="1600"/>
+              </a:spcAft>
+              <a:defRPr sz="1800" b="0">
+                <a:solidFill>
+                  <a:srgbClr val="0B0B0B"/>
+                </a:solidFill>
+                <a:latin typeface="Helvetica Neue"/>
+              </a:defRPr>
+            </a:pPr>
+            <a:r>
+              <a:t>▸  A missed mismatch puts the wrong consignee on a negotiable shipping document.</a:t>
+            </a:r>
+          </a:p>
+        </p:txBody>
+      </p:sp>
+      <p:sp>
+        <p:nvSpPr>
+          <p:cNvPr id="5" name="Rectangle 4"/>
+          <p:cNvSpPr/>
+          <p:nvPr/>
+        </p:nvSpPr>
+        <p:spPr>
+          <a:xfrm>
+            <a:off x="0" y="6803136"/>
+            <a:ext cx="12191695" cy="54864"/>
+          </a:xfrm>
+          <a:prstGeom prst="rect">
+            <a:avLst/>
+          </a:prstGeom>
+          <a:solidFill>
+            <a:srgbClr val="EDA100"/>
+          </a:solidFill>
+          <a:ln>
+            <a:noFill/>
+          </a:ln>
+          <a:effectLst/>
+        </p:spPr>
+        <p:style>
+          <a:lnRef idx="1">
+            <a:schemeClr val="accent1"/>
+          </a:lnRef>
+          <a:fillRef idx="3">
+            <a:schemeClr val="accent1"/>
+          </a:fillRef>
+          <a:effectRef idx="2">
+            <a:schemeClr val="accent1"/>
+          </a:effectRef>
+          <a:fontRef idx="minor">
+            <a:schemeClr val="lt1"/>
+          </a:fontRef>
+        </p:style>
+        <p:txBody>
+          <a:bodyPr rtlCol="0" anchor="ctr"/>
+          <a:lstStyle/>
+          <a:p>
+            <a:pPr algn="ctr"/>
+          </a:p>
+        </p:txBody>
+      </p:sp>
+      <p:sp>
+        <p:nvSpPr>
+          <p:cNvPr id="6" name="TextBox 5"/>
+          <p:cNvSpPr txBox="1"/>
+          <p:nvPr/>
+        </p:nvSpPr>
+        <p:spPr>
+          <a:xfrm>
+            <a:off x="640080" y="6473952"/>
+            <a:ext cx="7315200" cy="274320"/>
+          </a:xfrm>
+          <a:prstGeom prst="rect">
+            <a:avLst/>
+          </a:prstGeom>
+          <a:noFill/>
+        </p:spPr>
+        <p:txBody>
+          <a:bodyPr wrap="square">
+            <a:spAutoFit/>
+          </a:bodyPr>
+          <a:lstStyle/>
+          <a:p>
+            <a:pPr>
+              <a:defRPr sz="1000" b="0">
+                <a:solidFill>
+                  <a:srgbClr val="52514E"/>
+                </a:solidFill>
+                <a:latin typeface="Helvetica Neue"/>
+              </a:defRPr>
+            </a:pPr>
+            <a:r>
+              <a:t>Evermon — Averis × Monash Hackathon 2026</a:t>
+            </a:r>
+          </a:p>
+        </p:txBody>
+      </p:sp>
+      <p:sp>
+        <p:nvSpPr>
+          <p:cNvPr id="7" name="TextBox 6"/>
+          <p:cNvSpPr txBox="1"/>
+          <p:nvPr/>
+        </p:nvSpPr>
+        <p:spPr>
+          <a:xfrm>
+            <a:off x="11277295" y="6473952"/>
+            <a:ext cx="548640" cy="274320"/>
+          </a:xfrm>
+          <a:prstGeom prst="rect">
+            <a:avLst/>
+          </a:prstGeom>
+          <a:noFill/>
+        </p:spPr>
+        <p:txBody>
+          <a:bodyPr wrap="square">
+            <a:spAutoFit/>
+          </a:bodyPr>
+          <a:lstStyle/>
+          <a:p>
+            <a:pPr algn="r">
+              <a:defRPr sz="1000" b="1">
+                <a:solidFill>
+                  <a:srgbClr val="2A78D6"/>
+                </a:solidFill>
+                <a:latin typeface="Helvetica Neue"/>
+              </a:defRPr>
+            </a:pPr>
+            <a:r>
+              <a:t>3</a:t>
             </a:r>
           </a:p>
         </p:txBody>
@@ -3343,37 +5261,45 @@
       <p:grpSpPr/>
       <p:sp>
         <p:nvSpPr>
-          <p:cNvPr id="2" name="TextBox 1"/>
-          <p:cNvSpPr txBox="1"/>
-          <p:nvPr/>
-        </p:nvSpPr>
-        <p:spPr>
-          <a:xfrm>
-            <a:off x="548640" y="365760"/>
-            <a:ext cx="11094415" cy="822960"/>
-          </a:xfrm>
-          <a:prstGeom prst="rect">
-            <a:avLst/>
-          </a:prstGeom>
-          <a:noFill/>
-        </p:spPr>
-        <p:txBody>
-          <a:bodyPr wrap="none">
-            <a:spAutoFit/>
-          </a:bodyPr>
-          <a:lstStyle/>
-          <a:p>
-            <a:pPr>
-              <a:defRPr sz="3000" b="1">
-                <a:solidFill>
-                  <a:srgbClr val="003366"/>
-                </a:solidFill>
-                <a:latin typeface="Calibri"/>
-              </a:defRPr>
-            </a:pPr>
-            <a:r>
-              <a:t>why this is not a wrapper / chatbot / dashboard</a:t>
-            </a:r>
+          <p:cNvPr id="2" name="Rectangle 1"/>
+          <p:cNvSpPr/>
+          <p:nvPr/>
+        </p:nvSpPr>
+        <p:spPr>
+          <a:xfrm>
+            <a:off x="0" y="0"/>
+            <a:ext cx="12191695" cy="6858000"/>
+          </a:xfrm>
+          <a:prstGeom prst="rect">
+            <a:avLst/>
+          </a:prstGeom>
+          <a:solidFill>
+            <a:srgbClr val="2A78D6"/>
+          </a:solidFill>
+          <a:ln>
+            <a:noFill/>
+          </a:ln>
+          <a:effectLst/>
+        </p:spPr>
+        <p:style>
+          <a:lnRef idx="1">
+            <a:schemeClr val="accent1"/>
+          </a:lnRef>
+          <a:fillRef idx="3">
+            <a:schemeClr val="accent1"/>
+          </a:fillRef>
+          <a:effectRef idx="2">
+            <a:schemeClr val="accent1"/>
+          </a:effectRef>
+          <a:fontRef idx="minor">
+            <a:schemeClr val="lt1"/>
+          </a:fontRef>
+        </p:style>
+        <p:txBody>
+          <a:bodyPr rtlCol="0" anchor="ctr"/>
+          <a:lstStyle/>
+          <a:p>
+            <a:pPr algn="ctr"/>
           </a:p>
         </p:txBody>
       </p:sp>
@@ -3385,8 +5311,8 @@
         </p:nvSpPr>
         <p:spPr>
           <a:xfrm>
-            <a:off x="548640" y="1371600"/>
-            <a:ext cx="11094415" cy="5029200"/>
+            <a:off x="640080" y="2011680"/>
+            <a:ext cx="2286000" cy="1280160"/>
           </a:xfrm>
           <a:prstGeom prst="rect">
             <a:avLst/>
@@ -3400,15 +5326,167 @@
           <a:lstStyle/>
           <a:p>
             <a:pPr>
-              <a:defRPr sz="2000">
-                <a:solidFill>
-                  <a:srgbClr val="333333"/>
-                </a:solidFill>
-                <a:latin typeface="Calibri"/>
+              <a:defRPr sz="8000" b="1">
+                <a:solidFill>
+                  <a:srgbClr val="EDA100"/>
+                </a:solidFill>
+                <a:latin typeface="Helvetica Neue"/>
               </a:defRPr>
             </a:pPr>
             <a:r>
-              <a:t>The alias-table field alignment (`dock/fields.py`) and the four-reason escalation precedence (`dock/review.py`) are the product — a judge calling GPT with "compare these two documents" gets inconsistent field matching and no auditable escalation policy. **But be honest**: if extraction and comparison are just LLM calls with a prompt, this is a thin wrapper with good scaffolding around it. The pitch only survives if you can show the alias table and comparison logic are deterministic/rule-based (not just prompted), and that escalation reasons are fixed, not model-improvised. If any of that is LLM-guessed under the hood, say so on stage before a judge finds it — don't let them discover it.</a:t>
+              <a:t>02</a:t>
+            </a:r>
+          </a:p>
+        </p:txBody>
+      </p:sp>
+      <p:sp>
+        <p:nvSpPr>
+          <p:cNvPr id="4" name="TextBox 3"/>
+          <p:cNvSpPr txBox="1"/>
+          <p:nvPr/>
+        </p:nvSpPr>
+        <p:spPr>
+          <a:xfrm>
+            <a:off x="640080" y="3200400"/>
+            <a:ext cx="10911535" cy="1188720"/>
+          </a:xfrm>
+          <a:prstGeom prst="rect">
+            <a:avLst/>
+          </a:prstGeom>
+          <a:noFill/>
+        </p:spPr>
+        <p:txBody>
+          <a:bodyPr wrap="square">
+            <a:spAutoFit/>
+          </a:bodyPr>
+          <a:lstStyle/>
+          <a:p>
+            <a:pPr>
+              <a:defRPr sz="4000" b="1">
+                <a:solidFill>
+                  <a:srgbClr val="FFFFFF"/>
+                </a:solidFill>
+                <a:latin typeface="Helvetica Neue"/>
+              </a:defRPr>
+            </a:pPr>
+            <a:r>
+              <a:t>Why This Isn't a Wrapper</a:t>
+            </a:r>
+          </a:p>
+        </p:txBody>
+      </p:sp>
+      <p:sp>
+        <p:nvSpPr>
+          <p:cNvPr id="5" name="Rectangle 4"/>
+          <p:cNvSpPr/>
+          <p:nvPr/>
+        </p:nvSpPr>
+        <p:spPr>
+          <a:xfrm>
+            <a:off x="0" y="6803136"/>
+            <a:ext cx="12191695" cy="54864"/>
+          </a:xfrm>
+          <a:prstGeom prst="rect">
+            <a:avLst/>
+          </a:prstGeom>
+          <a:solidFill>
+            <a:srgbClr val="EDA100"/>
+          </a:solidFill>
+          <a:ln>
+            <a:noFill/>
+          </a:ln>
+          <a:effectLst/>
+        </p:spPr>
+        <p:style>
+          <a:lnRef idx="1">
+            <a:schemeClr val="accent1"/>
+          </a:lnRef>
+          <a:fillRef idx="3">
+            <a:schemeClr val="accent1"/>
+          </a:fillRef>
+          <a:effectRef idx="2">
+            <a:schemeClr val="accent1"/>
+          </a:effectRef>
+          <a:fontRef idx="minor">
+            <a:schemeClr val="lt1"/>
+          </a:fontRef>
+        </p:style>
+        <p:txBody>
+          <a:bodyPr rtlCol="0" anchor="ctr"/>
+          <a:lstStyle/>
+          <a:p>
+            <a:pPr algn="ctr"/>
+          </a:p>
+        </p:txBody>
+      </p:sp>
+      <p:sp>
+        <p:nvSpPr>
+          <p:cNvPr id="6" name="TextBox 5"/>
+          <p:cNvSpPr txBox="1"/>
+          <p:nvPr/>
+        </p:nvSpPr>
+        <p:spPr>
+          <a:xfrm>
+            <a:off x="640080" y="6473952"/>
+            <a:ext cx="7315200" cy="274320"/>
+          </a:xfrm>
+          <a:prstGeom prst="rect">
+            <a:avLst/>
+          </a:prstGeom>
+          <a:noFill/>
+        </p:spPr>
+        <p:txBody>
+          <a:bodyPr wrap="square">
+            <a:spAutoFit/>
+          </a:bodyPr>
+          <a:lstStyle/>
+          <a:p>
+            <a:pPr>
+              <a:defRPr sz="1000" b="0">
+                <a:solidFill>
+                  <a:srgbClr val="52514E"/>
+                </a:solidFill>
+                <a:latin typeface="Helvetica Neue"/>
+              </a:defRPr>
+            </a:pPr>
+            <a:r>
+              <a:t>Evermon — Averis × Monash Hackathon 2026</a:t>
+            </a:r>
+          </a:p>
+        </p:txBody>
+      </p:sp>
+      <p:sp>
+        <p:nvSpPr>
+          <p:cNvPr id="7" name="TextBox 6"/>
+          <p:cNvSpPr txBox="1"/>
+          <p:nvPr/>
+        </p:nvSpPr>
+        <p:spPr>
+          <a:xfrm>
+            <a:off x="11277295" y="6473952"/>
+            <a:ext cx="548640" cy="274320"/>
+          </a:xfrm>
+          <a:prstGeom prst="rect">
+            <a:avLst/>
+          </a:prstGeom>
+          <a:noFill/>
+        </p:spPr>
+        <p:txBody>
+          <a:bodyPr wrap="square">
+            <a:spAutoFit/>
+          </a:bodyPr>
+          <a:lstStyle/>
+          <a:p>
+            <a:pPr algn="r">
+              <a:defRPr sz="1000" b="1">
+                <a:solidFill>
+                  <a:srgbClr val="2A78D6"/>
+                </a:solidFill>
+                <a:latin typeface="Helvetica Neue"/>
+              </a:defRPr>
+            </a:pPr>
+            <a:r>
+              <a:t>4</a:t>
             </a:r>
           </a:p>
         </p:txBody>
@@ -3433,37 +5511,45 @@
       <p:grpSpPr/>
       <p:sp>
         <p:nvSpPr>
-          <p:cNvPr id="2" name="TextBox 1"/>
-          <p:cNvSpPr txBox="1"/>
-          <p:nvPr/>
-        </p:nvSpPr>
-        <p:spPr>
-          <a:xfrm>
-            <a:off x="548640" y="365760"/>
-            <a:ext cx="11094415" cy="822960"/>
-          </a:xfrm>
-          <a:prstGeom prst="rect">
-            <a:avLst/>
-          </a:prstGeom>
-          <a:noFill/>
-        </p:spPr>
-        <p:txBody>
-          <a:bodyPr wrap="none">
-            <a:spAutoFit/>
-          </a:bodyPr>
-          <a:lstStyle/>
-          <a:p>
-            <a:pPr>
-              <a:defRPr sz="3000" b="1">
-                <a:solidFill>
-                  <a:srgbClr val="003366"/>
-                </a:solidFill>
-                <a:latin typeface="Calibri"/>
-              </a:defRPr>
-            </a:pPr>
-            <a:r>
-              <a:t>market - who pays</a:t>
-            </a:r>
+          <p:cNvPr id="2" name="Rectangle 1"/>
+          <p:cNvSpPr/>
+          <p:nvPr/>
+        </p:nvSpPr>
+        <p:spPr>
+          <a:xfrm>
+            <a:off x="0" y="0"/>
+            <a:ext cx="12191695" cy="1188720"/>
+          </a:xfrm>
+          <a:prstGeom prst="rect">
+            <a:avLst/>
+          </a:prstGeom>
+          <a:solidFill>
+            <a:srgbClr val="2A78D6"/>
+          </a:solidFill>
+          <a:ln>
+            <a:noFill/>
+          </a:ln>
+          <a:effectLst/>
+        </p:spPr>
+        <p:style>
+          <a:lnRef idx="1">
+            <a:schemeClr val="accent1"/>
+          </a:lnRef>
+          <a:fillRef idx="3">
+            <a:schemeClr val="accent1"/>
+          </a:fillRef>
+          <a:effectRef idx="2">
+            <a:schemeClr val="accent1"/>
+          </a:effectRef>
+          <a:fontRef idx="minor">
+            <a:schemeClr val="lt1"/>
+          </a:fontRef>
+        </p:style>
+        <p:txBody>
+          <a:bodyPr rtlCol="0" anchor="ctr"/>
+          <a:lstStyle/>
+          <a:p>
+            <a:pPr algn="ctr"/>
           </a:p>
         </p:txBody>
       </p:sp>
@@ -3475,8 +5561,8 @@
         </p:nvSpPr>
         <p:spPr>
           <a:xfrm>
-            <a:off x="548640" y="1371600"/>
-            <a:ext cx="11094415" cy="5029200"/>
+            <a:off x="640080" y="274320"/>
+            <a:ext cx="10911535" cy="731520"/>
           </a:xfrm>
           <a:prstGeom prst="rect">
             <a:avLst/>
@@ -3490,15 +5576,202 @@
           <a:lstStyle/>
           <a:p>
             <a:pPr>
-              <a:defRPr sz="2000">
-                <a:solidFill>
-                  <a:srgbClr val="333333"/>
-                </a:solidFill>
-                <a:latin typeface="Calibri"/>
+              <a:defRPr sz="2800" b="1">
+                <a:solidFill>
+                  <a:srgbClr val="FFFFFF"/>
+                </a:solidFill>
+                <a:latin typeface="Helvetica Neue"/>
               </a:defRPr>
             </a:pPr>
             <a:r>
-              <a:t>Freight forwarders and shipping-line back offices — the buyer is the ops manager who owns error/rework cost and demurrage exposure, not the individual clerk. This is a real B2B wedge but it's crowded (document-matching-for-logistics is a known SaaS category); you need one sharp number — clerk-hours saved per 100 emails, or mismatch-catch rate vs. manual — or this reads as "another OCR-plus-rules tool."</a:t>
+              <a:t>Rule-based, not prompted</a:t>
+            </a:r>
+          </a:p>
+        </p:txBody>
+      </p:sp>
+      <p:sp>
+        <p:nvSpPr>
+          <p:cNvPr id="4" name="TextBox 3"/>
+          <p:cNvSpPr txBox="1"/>
+          <p:nvPr/>
+        </p:nvSpPr>
+        <p:spPr>
+          <a:xfrm>
+            <a:off x="640080" y="1554480"/>
+            <a:ext cx="10911535" cy="4572000"/>
+          </a:xfrm>
+          <a:prstGeom prst="rect">
+            <a:avLst/>
+          </a:prstGeom>
+          <a:noFill/>
+        </p:spPr>
+        <p:txBody>
+          <a:bodyPr wrap="square">
+            <a:spAutoFit/>
+          </a:bodyPr>
+          <a:lstStyle/>
+          <a:p>
+            <a:pPr>
+              <a:spcAft>
+                <a:spcPts val="1600"/>
+              </a:spcAft>
+              <a:defRPr sz="1800" b="0">
+                <a:solidFill>
+                  <a:srgbClr val="0B0B0B"/>
+                </a:solidFill>
+                <a:latin typeface="Helvetica Neue"/>
+              </a:defRPr>
+            </a:pPr>
+            <a:r>
+              <a:t>▸  Alias-table field alignment (dock/fields.py) and four-reason escalation precedence (dock/review.py) are the product.</a:t>
+            </a:r>
+          </a:p>
+          <a:p>
+            <a:pPr>
+              <a:spcAft>
+                <a:spcPts val="1600"/>
+              </a:spcAft>
+              <a:defRPr sz="1800" b="0">
+                <a:solidFill>
+                  <a:srgbClr val="0B0B0B"/>
+                </a:solidFill>
+                <a:latin typeface="Helvetica Neue"/>
+              </a:defRPr>
+            </a:pPr>
+            <a:r>
+              <a:t>▸  An LLM given "compare these two documents" gets inconsistent field matching and no auditable policy.</a:t>
+            </a:r>
+          </a:p>
+          <a:p>
+            <a:pPr>
+              <a:spcAft>
+                <a:spcPts val="1600"/>
+              </a:spcAft>
+              <a:defRPr sz="1800" b="0">
+                <a:solidFill>
+                  <a:srgbClr val="0B0B0B"/>
+                </a:solidFill>
+                <a:latin typeface="Helvetica Neue"/>
+              </a:defRPr>
+            </a:pPr>
+            <a:r>
+              <a:t>▸  Escalation reasons are fixed, never model-improvised — that's the pitch that survives a technical judge's follow-up.</a:t>
+            </a:r>
+          </a:p>
+        </p:txBody>
+      </p:sp>
+      <p:sp>
+        <p:nvSpPr>
+          <p:cNvPr id="5" name="Rectangle 4"/>
+          <p:cNvSpPr/>
+          <p:nvPr/>
+        </p:nvSpPr>
+        <p:spPr>
+          <a:xfrm>
+            <a:off x="0" y="6803136"/>
+            <a:ext cx="12191695" cy="54864"/>
+          </a:xfrm>
+          <a:prstGeom prst="rect">
+            <a:avLst/>
+          </a:prstGeom>
+          <a:solidFill>
+            <a:srgbClr val="EDA100"/>
+          </a:solidFill>
+          <a:ln>
+            <a:noFill/>
+          </a:ln>
+          <a:effectLst/>
+        </p:spPr>
+        <p:style>
+          <a:lnRef idx="1">
+            <a:schemeClr val="accent1"/>
+          </a:lnRef>
+          <a:fillRef idx="3">
+            <a:schemeClr val="accent1"/>
+          </a:fillRef>
+          <a:effectRef idx="2">
+            <a:schemeClr val="accent1"/>
+          </a:effectRef>
+          <a:fontRef idx="minor">
+            <a:schemeClr val="lt1"/>
+          </a:fontRef>
+        </p:style>
+        <p:txBody>
+          <a:bodyPr rtlCol="0" anchor="ctr"/>
+          <a:lstStyle/>
+          <a:p>
+            <a:pPr algn="ctr"/>
+          </a:p>
+        </p:txBody>
+      </p:sp>
+      <p:sp>
+        <p:nvSpPr>
+          <p:cNvPr id="6" name="TextBox 5"/>
+          <p:cNvSpPr txBox="1"/>
+          <p:nvPr/>
+        </p:nvSpPr>
+        <p:spPr>
+          <a:xfrm>
+            <a:off x="640080" y="6473952"/>
+            <a:ext cx="7315200" cy="274320"/>
+          </a:xfrm>
+          <a:prstGeom prst="rect">
+            <a:avLst/>
+          </a:prstGeom>
+          <a:noFill/>
+        </p:spPr>
+        <p:txBody>
+          <a:bodyPr wrap="square">
+            <a:spAutoFit/>
+          </a:bodyPr>
+          <a:lstStyle/>
+          <a:p>
+            <a:pPr>
+              <a:defRPr sz="1000" b="0">
+                <a:solidFill>
+                  <a:srgbClr val="52514E"/>
+                </a:solidFill>
+                <a:latin typeface="Helvetica Neue"/>
+              </a:defRPr>
+            </a:pPr>
+            <a:r>
+              <a:t>Evermon — Averis × Monash Hackathon 2026</a:t>
+            </a:r>
+          </a:p>
+        </p:txBody>
+      </p:sp>
+      <p:sp>
+        <p:nvSpPr>
+          <p:cNvPr id="7" name="TextBox 6"/>
+          <p:cNvSpPr txBox="1"/>
+          <p:nvPr/>
+        </p:nvSpPr>
+        <p:spPr>
+          <a:xfrm>
+            <a:off x="11277295" y="6473952"/>
+            <a:ext cx="548640" cy="274320"/>
+          </a:xfrm>
+          <a:prstGeom prst="rect">
+            <a:avLst/>
+          </a:prstGeom>
+          <a:noFill/>
+        </p:spPr>
+        <p:txBody>
+          <a:bodyPr wrap="square">
+            <a:spAutoFit/>
+          </a:bodyPr>
+          <a:lstStyle/>
+          <a:p>
+            <a:pPr algn="r">
+              <a:defRPr sz="1000" b="1">
+                <a:solidFill>
+                  <a:srgbClr val="2A78D6"/>
+                </a:solidFill>
+                <a:latin typeface="Helvetica Neue"/>
+              </a:defRPr>
+            </a:pPr>
+            <a:r>
+              <a:t>5</a:t>
             </a:r>
           </a:p>
         </p:txBody>
@@ -3523,37 +5796,45 @@
       <p:grpSpPr/>
       <p:sp>
         <p:nvSpPr>
-          <p:cNvPr id="2" name="TextBox 1"/>
-          <p:cNvSpPr txBox="1"/>
-          <p:nvPr/>
-        </p:nvSpPr>
-        <p:spPr>
-          <a:xfrm>
-            <a:off x="548640" y="365760"/>
-            <a:ext cx="11094415" cy="822960"/>
-          </a:xfrm>
-          <a:prstGeom prst="rect">
-            <a:avLst/>
-          </a:prstGeom>
-          <a:noFill/>
-        </p:spPr>
-        <p:txBody>
-          <a:bodyPr wrap="none">
-            <a:spAutoFit/>
-          </a:bodyPr>
-          <a:lstStyle/>
-          <a:p>
-            <a:pPr>
-              <a:defRPr sz="3000" b="1">
-                <a:solidFill>
-                  <a:srgbClr val="003366"/>
-                </a:solidFill>
-                <a:latin typeface="Calibri"/>
-              </a:defRPr>
-            </a:pPr>
-            <a:r>
-              <a:t>open-source strategy</a:t>
-            </a:r>
+          <p:cNvPr id="2" name="Rectangle 1"/>
+          <p:cNvSpPr/>
+          <p:nvPr/>
+        </p:nvSpPr>
+        <p:spPr>
+          <a:xfrm>
+            <a:off x="0" y="0"/>
+            <a:ext cx="12191695" cy="6858000"/>
+          </a:xfrm>
+          <a:prstGeom prst="rect">
+            <a:avLst/>
+          </a:prstGeom>
+          <a:solidFill>
+            <a:srgbClr val="2A78D6"/>
+          </a:solidFill>
+          <a:ln>
+            <a:noFill/>
+          </a:ln>
+          <a:effectLst/>
+        </p:spPr>
+        <p:style>
+          <a:lnRef idx="1">
+            <a:schemeClr val="accent1"/>
+          </a:lnRef>
+          <a:fillRef idx="3">
+            <a:schemeClr val="accent1"/>
+          </a:fillRef>
+          <a:effectRef idx="2">
+            <a:schemeClr val="accent1"/>
+          </a:effectRef>
+          <a:fontRef idx="minor">
+            <a:schemeClr val="lt1"/>
+          </a:fontRef>
+        </p:style>
+        <p:txBody>
+          <a:bodyPr rtlCol="0" anchor="ctr"/>
+          <a:lstStyle/>
+          <a:p>
+            <a:pPr algn="ctr"/>
           </a:p>
         </p:txBody>
       </p:sp>
@@ -3565,8 +5846,8 @@
         </p:nvSpPr>
         <p:spPr>
           <a:xfrm>
-            <a:off x="548640" y="1371600"/>
-            <a:ext cx="11094415" cy="5029200"/>
+            <a:off x="640080" y="2011680"/>
+            <a:ext cx="2286000" cy="1280160"/>
           </a:xfrm>
           <a:prstGeom prst="rect">
             <a:avLst/>
@@ -3580,15 +5861,167 @@
           <a:lstStyle/>
           <a:p>
             <a:pPr>
-              <a:defRPr sz="2000">
-                <a:solidFill>
-                  <a:srgbClr val="333333"/>
-                </a:solidFill>
-                <a:latin typeface="Calibri"/>
+              <a:defRPr sz="8000" b="1">
+                <a:solidFill>
+                  <a:srgbClr val="EDA100"/>
+                </a:solidFill>
+                <a:latin typeface="Helvetica Neue"/>
               </a:defRPr>
             </a:pPr>
             <a:r>
-              <a:t>Ship the classification rules, alias table, and escalation-reason logic open (`dock/classify.py`, `dock/fields.py`, `dock/review.py`) — that's the trust argument: a clerk-facing tool that flags negotiable-document errors needs to be auditable, not a black box. Keep document parsing robustness (edge-case PDF/XLSX handling) and any fine-tuned extraction model closed, since that's the maintenance moat, not the IP moat. Don't oversell "open source" as a differentiator here — judges will ask what's actually proprietary, and "the loader" isn't a good answer.</a:t>
+              <a:t>03</a:t>
+            </a:r>
+          </a:p>
+        </p:txBody>
+      </p:sp>
+      <p:sp>
+        <p:nvSpPr>
+          <p:cNvPr id="4" name="TextBox 3"/>
+          <p:cNvSpPr txBox="1"/>
+          <p:nvPr/>
+        </p:nvSpPr>
+        <p:spPr>
+          <a:xfrm>
+            <a:off x="640080" y="3200400"/>
+            <a:ext cx="10911535" cy="1188720"/>
+          </a:xfrm>
+          <a:prstGeom prst="rect">
+            <a:avLst/>
+          </a:prstGeom>
+          <a:noFill/>
+        </p:spPr>
+        <p:txBody>
+          <a:bodyPr wrap="square">
+            <a:spAutoFit/>
+          </a:bodyPr>
+          <a:lstStyle/>
+          <a:p>
+            <a:pPr>
+              <a:defRPr sz="4000" b="1">
+                <a:solidFill>
+                  <a:srgbClr val="FFFFFF"/>
+                </a:solidFill>
+                <a:latin typeface="Helvetica Neue"/>
+              </a:defRPr>
+            </a:pPr>
+            <a:r>
+              <a:t>Market — Who Pays</a:t>
+            </a:r>
+          </a:p>
+        </p:txBody>
+      </p:sp>
+      <p:sp>
+        <p:nvSpPr>
+          <p:cNvPr id="5" name="Rectangle 4"/>
+          <p:cNvSpPr/>
+          <p:nvPr/>
+        </p:nvSpPr>
+        <p:spPr>
+          <a:xfrm>
+            <a:off x="0" y="6803136"/>
+            <a:ext cx="12191695" cy="54864"/>
+          </a:xfrm>
+          <a:prstGeom prst="rect">
+            <a:avLst/>
+          </a:prstGeom>
+          <a:solidFill>
+            <a:srgbClr val="EDA100"/>
+          </a:solidFill>
+          <a:ln>
+            <a:noFill/>
+          </a:ln>
+          <a:effectLst/>
+        </p:spPr>
+        <p:style>
+          <a:lnRef idx="1">
+            <a:schemeClr val="accent1"/>
+          </a:lnRef>
+          <a:fillRef idx="3">
+            <a:schemeClr val="accent1"/>
+          </a:fillRef>
+          <a:effectRef idx="2">
+            <a:schemeClr val="accent1"/>
+          </a:effectRef>
+          <a:fontRef idx="minor">
+            <a:schemeClr val="lt1"/>
+          </a:fontRef>
+        </p:style>
+        <p:txBody>
+          <a:bodyPr rtlCol="0" anchor="ctr"/>
+          <a:lstStyle/>
+          <a:p>
+            <a:pPr algn="ctr"/>
+          </a:p>
+        </p:txBody>
+      </p:sp>
+      <p:sp>
+        <p:nvSpPr>
+          <p:cNvPr id="6" name="TextBox 5"/>
+          <p:cNvSpPr txBox="1"/>
+          <p:nvPr/>
+        </p:nvSpPr>
+        <p:spPr>
+          <a:xfrm>
+            <a:off x="640080" y="6473952"/>
+            <a:ext cx="7315200" cy="274320"/>
+          </a:xfrm>
+          <a:prstGeom prst="rect">
+            <a:avLst/>
+          </a:prstGeom>
+          <a:noFill/>
+        </p:spPr>
+        <p:txBody>
+          <a:bodyPr wrap="square">
+            <a:spAutoFit/>
+          </a:bodyPr>
+          <a:lstStyle/>
+          <a:p>
+            <a:pPr>
+              <a:defRPr sz="1000" b="0">
+                <a:solidFill>
+                  <a:srgbClr val="52514E"/>
+                </a:solidFill>
+                <a:latin typeface="Helvetica Neue"/>
+              </a:defRPr>
+            </a:pPr>
+            <a:r>
+              <a:t>Evermon — Averis × Monash Hackathon 2026</a:t>
+            </a:r>
+          </a:p>
+        </p:txBody>
+      </p:sp>
+      <p:sp>
+        <p:nvSpPr>
+          <p:cNvPr id="7" name="TextBox 6"/>
+          <p:cNvSpPr txBox="1"/>
+          <p:nvPr/>
+        </p:nvSpPr>
+        <p:spPr>
+          <a:xfrm>
+            <a:off x="11277295" y="6473952"/>
+            <a:ext cx="548640" cy="274320"/>
+          </a:xfrm>
+          <a:prstGeom prst="rect">
+            <a:avLst/>
+          </a:prstGeom>
+          <a:noFill/>
+        </p:spPr>
+        <p:txBody>
+          <a:bodyPr wrap="square">
+            <a:spAutoFit/>
+          </a:bodyPr>
+          <a:lstStyle/>
+          <a:p>
+            <a:pPr algn="r">
+              <a:defRPr sz="1000" b="1">
+                <a:solidFill>
+                  <a:srgbClr val="2A78D6"/>
+                </a:solidFill>
+                <a:latin typeface="Helvetica Neue"/>
+              </a:defRPr>
+            </a:pPr>
+            <a:r>
+              <a:t>6</a:t>
             </a:r>
           </a:p>
         </p:txBody>
@@ -3613,37 +6046,45 @@
       <p:grpSpPr/>
       <p:sp>
         <p:nvSpPr>
-          <p:cNvPr id="2" name="TextBox 1"/>
-          <p:cNvSpPr txBox="1"/>
-          <p:nvPr/>
-        </p:nvSpPr>
-        <p:spPr>
-          <a:xfrm>
-            <a:off x="548640" y="365760"/>
-            <a:ext cx="11094415" cy="822960"/>
-          </a:xfrm>
-          <a:prstGeom prst="rect">
-            <a:avLst/>
-          </a:prstGeom>
-          <a:noFill/>
-        </p:spPr>
-        <p:txBody>
-          <a:bodyPr wrap="none">
-            <a:spAutoFit/>
-          </a:bodyPr>
-          <a:lstStyle/>
-          <a:p>
-            <a:pPr>
-              <a:defRPr sz="3000" b="1">
-                <a:solidFill>
-                  <a:srgbClr val="003366"/>
-                </a:solidFill>
-                <a:latin typeface="Calibri"/>
-              </a:defRPr>
-            </a:pPr>
-            <a:r>
-              <a:t>demo script (3 bullet steps, under 2 minutes)</a:t>
-            </a:r>
+          <p:cNvPr id="2" name="Rectangle 1"/>
+          <p:cNvSpPr/>
+          <p:nvPr/>
+        </p:nvSpPr>
+        <p:spPr>
+          <a:xfrm>
+            <a:off x="0" y="0"/>
+            <a:ext cx="12191695" cy="1188720"/>
+          </a:xfrm>
+          <a:prstGeom prst="rect">
+            <a:avLst/>
+          </a:prstGeom>
+          <a:solidFill>
+            <a:srgbClr val="2A78D6"/>
+          </a:solidFill>
+          <a:ln>
+            <a:noFill/>
+          </a:ln>
+          <a:effectLst/>
+        </p:spPr>
+        <p:style>
+          <a:lnRef idx="1">
+            <a:schemeClr val="accent1"/>
+          </a:lnRef>
+          <a:fillRef idx="3">
+            <a:schemeClr val="accent1"/>
+          </a:fillRef>
+          <a:effectRef idx="2">
+            <a:schemeClr val="accent1"/>
+          </a:effectRef>
+          <a:fontRef idx="minor">
+            <a:schemeClr val="lt1"/>
+          </a:fontRef>
+        </p:style>
+        <p:txBody>
+          <a:bodyPr rtlCol="0" anchor="ctr"/>
+          <a:lstStyle/>
+          <a:p>
+            <a:pPr algn="ctr"/>
           </a:p>
         </p:txBody>
       </p:sp>
@@ -3655,8 +6096,8 @@
         </p:nvSpPr>
         <p:spPr>
           <a:xfrm>
-            <a:off x="548640" y="1371600"/>
-            <a:ext cx="11094415" cy="5029200"/>
+            <a:off x="640080" y="274320"/>
+            <a:ext cx="10911535" cy="731520"/>
           </a:xfrm>
           <a:prstGeom prst="rect">
             <a:avLst/>
@@ -3670,54 +6111,705 @@
           <a:lstStyle/>
           <a:p>
             <a:pPr>
-              <a:defRPr sz="2000">
-                <a:solidFill>
-                  <a:srgbClr val="333333"/>
-                </a:solidFill>
-                <a:latin typeface="Calibri"/>
+              <a:defRPr sz="2800" b="1">
+                <a:solidFill>
+                  <a:srgbClr val="FFFFFF"/>
+                </a:solidFill>
+                <a:latin typeface="Helvetica Neue"/>
               </a:defRPr>
             </a:pPr>
             <a:r>
-              <a:t>1. Drop three real emails into the inbox (a spam/broadcast, an invoice chase, an SI+draft-BL pair) — show classify.py sorting them correctly in one pass.</a:t>
-            </a:r>
-          </a:p>
+              <a:t>Freight forwarders &amp; shipping-line back offices</a:t>
+            </a:r>
+          </a:p>
+        </p:txBody>
+      </p:sp>
+      <p:sp>
+        <p:nvSpPr>
+          <p:cNvPr id="4" name="TextBox 3"/>
+          <p:cNvSpPr txBox="1"/>
+          <p:nvPr/>
+        </p:nvSpPr>
+        <p:spPr>
+          <a:xfrm>
+            <a:off x="640080" y="1554480"/>
+            <a:ext cx="10911535" cy="4572000"/>
+          </a:xfrm>
+          <a:prstGeom prst="rect">
+            <a:avLst/>
+          </a:prstGeom>
+          <a:noFill/>
+        </p:spPr>
+        <p:txBody>
+          <a:bodyPr wrap="square">
+            <a:spAutoFit/>
+          </a:bodyPr>
+          <a:lstStyle/>
           <a:p>
             <a:pPr>
-              <a:defRPr sz="2000">
-                <a:solidFill>
-                  <a:srgbClr val="333333"/>
-                </a:solidFill>
-                <a:latin typeface="Calibri"/>
+              <a:spcAft>
+                <a:spcPts val="1600"/>
+              </a:spcAft>
+              <a:defRPr sz="1800" b="0">
+                <a:solidFill>
+                  <a:srgbClr val="0B0B0B"/>
+                </a:solidFill>
+                <a:latin typeface="Helvetica Neue"/>
               </a:defRPr>
             </a:pPr>
             <a:r>
-              <a:t>2. Run the SI/BL pair with a deliberately relabeled field ("Load Port" vs "Port of Loading", mixed-language weight unit) — show it aligns and flags a real mismatch, not a label mismatch.</a:t>
+              <a:t>▸  Buyer: the ops manager who owns error/rework cost and demurrage exposure — not the individual clerk.</a:t>
             </a:r>
           </a:p>
           <a:p>
             <a:pPr>
-              <a:defRPr sz="2000">
-                <a:solidFill>
-                  <a:srgbClr val="333333"/>
-                </a:solidFill>
-                <a:latin typeface="Calibri"/>
+              <a:spcAft>
+                <a:spcPts val="1600"/>
+              </a:spcAft>
+              <a:defRPr sz="1800" b="0">
+                <a:solidFill>
+                  <a:srgbClr val="0B0B0B"/>
+                </a:solidFill>
+                <a:latin typeface="Helvetica Neue"/>
               </a:defRPr>
             </a:pPr>
             <a:r>
-              <a:t>3. Run a case with a missing/unreadable attachment — show it escalates to NEEDS_REVIEW with the specific stated reason, not a guess.</a:t>
-            </a:r>
-          </a:p>
+              <a:t>▸  Real B2B wedge, but a crowded category — needs one sharp number, e.g. clerk-hours saved per 100 emails.</a:t>
+            </a:r>
+          </a:p>
+        </p:txBody>
+      </p:sp>
+      <p:sp>
+        <p:nvSpPr>
+          <p:cNvPr id="5" name="Rectangle 4"/>
+          <p:cNvSpPr/>
+          <p:nvPr/>
+        </p:nvSpPr>
+        <p:spPr>
+          <a:xfrm>
+            <a:off x="0" y="6803136"/>
+            <a:ext cx="12191695" cy="54864"/>
+          </a:xfrm>
+          <a:prstGeom prst="rect">
+            <a:avLst/>
+          </a:prstGeom>
+          <a:solidFill>
+            <a:srgbClr val="EDA100"/>
+          </a:solidFill>
+          <a:ln>
+            <a:noFill/>
+          </a:ln>
+          <a:effectLst/>
+        </p:spPr>
+        <p:style>
+          <a:lnRef idx="1">
+            <a:schemeClr val="accent1"/>
+          </a:lnRef>
+          <a:fillRef idx="3">
+            <a:schemeClr val="accent1"/>
+          </a:fillRef>
+          <a:effectRef idx="2">
+            <a:schemeClr val="accent1"/>
+          </a:effectRef>
+          <a:fontRef idx="minor">
+            <a:schemeClr val="lt1"/>
+          </a:fontRef>
+        </p:style>
+        <p:txBody>
+          <a:bodyPr rtlCol="0" anchor="ctr"/>
+          <a:lstStyle/>
+          <a:p>
+            <a:pPr algn="ctr"/>
+          </a:p>
+        </p:txBody>
+      </p:sp>
+      <p:sp>
+        <p:nvSpPr>
+          <p:cNvPr id="6" name="TextBox 5"/>
+          <p:cNvSpPr txBox="1"/>
+          <p:nvPr/>
+        </p:nvSpPr>
+        <p:spPr>
+          <a:xfrm>
+            <a:off x="640080" y="6473952"/>
+            <a:ext cx="7315200" cy="274320"/>
+          </a:xfrm>
+          <a:prstGeom prst="rect">
+            <a:avLst/>
+          </a:prstGeom>
+          <a:noFill/>
+        </p:spPr>
+        <p:txBody>
+          <a:bodyPr wrap="square">
+            <a:spAutoFit/>
+          </a:bodyPr>
+          <a:lstStyle/>
           <a:p>
             <a:pPr>
-              <a:defRPr sz="2000">
-                <a:solidFill>
-                  <a:srgbClr val="333333"/>
-                </a:solidFill>
-                <a:latin typeface="Calibri"/>
+              <a:defRPr sz="1000" b="0">
+                <a:solidFill>
+                  <a:srgbClr val="52514E"/>
+                </a:solidFill>
+                <a:latin typeface="Helvetica Neue"/>
               </a:defRPr>
             </a:pPr>
             <a:r>
-              <a:t>**Cut before the pitch**: any claim of "AI-powered" without naming what's deterministic vs. model-driven — that's the first thing a technical judge will probe, and a vague answer kills the credibility this pitch depends on.</a:t>
+              <a:t>Evermon — Averis × Monash Hackathon 2026</a:t>
+            </a:r>
+          </a:p>
+        </p:txBody>
+      </p:sp>
+      <p:sp>
+        <p:nvSpPr>
+          <p:cNvPr id="7" name="TextBox 6"/>
+          <p:cNvSpPr txBox="1"/>
+          <p:nvPr/>
+        </p:nvSpPr>
+        <p:spPr>
+          <a:xfrm>
+            <a:off x="11277295" y="6473952"/>
+            <a:ext cx="548640" cy="274320"/>
+          </a:xfrm>
+          <a:prstGeom prst="rect">
+            <a:avLst/>
+          </a:prstGeom>
+          <a:noFill/>
+        </p:spPr>
+        <p:txBody>
+          <a:bodyPr wrap="square">
+            <a:spAutoFit/>
+          </a:bodyPr>
+          <a:lstStyle/>
+          <a:p>
+            <a:pPr algn="r">
+              <a:defRPr sz="1000" b="1">
+                <a:solidFill>
+                  <a:srgbClr val="2A78D6"/>
+                </a:solidFill>
+                <a:latin typeface="Helvetica Neue"/>
+              </a:defRPr>
+            </a:pPr>
+            <a:r>
+              <a:t>7</a:t>
+            </a:r>
+          </a:p>
+        </p:txBody>
+      </p:sp>
+    </p:spTree>
+  </p:cSld>
+  <p:clrMapOvr>
+    <a:masterClrMapping/>
+  </p:clrMapOvr>
+</p:sld>
+</file>
+
+<file path=ppt/slides/slide8.xml><?xml version="1.0" encoding="utf-8"?>
+<p:sld xmlns:a="http://schemas.openxmlformats.org/drawingml/2006/main" xmlns:p="http://schemas.openxmlformats.org/presentationml/2006/main" xmlns:r="http://schemas.openxmlformats.org/officeDocument/2006/relationships">
+  <p:cSld>
+    <p:spTree>
+      <p:nvGrpSpPr>
+        <p:cNvPr id="1" name=""/>
+        <p:cNvGrpSpPr/>
+        <p:nvPr/>
+      </p:nvGrpSpPr>
+      <p:grpSpPr/>
+      <p:sp>
+        <p:nvSpPr>
+          <p:cNvPr id="2" name="Rectangle 1"/>
+          <p:cNvSpPr/>
+          <p:nvPr/>
+        </p:nvSpPr>
+        <p:spPr>
+          <a:xfrm>
+            <a:off x="0" y="0"/>
+            <a:ext cx="12191695" cy="6858000"/>
+          </a:xfrm>
+          <a:prstGeom prst="rect">
+            <a:avLst/>
+          </a:prstGeom>
+          <a:solidFill>
+            <a:srgbClr val="2A78D6"/>
+          </a:solidFill>
+          <a:ln>
+            <a:noFill/>
+          </a:ln>
+          <a:effectLst/>
+        </p:spPr>
+        <p:style>
+          <a:lnRef idx="1">
+            <a:schemeClr val="accent1"/>
+          </a:lnRef>
+          <a:fillRef idx="3">
+            <a:schemeClr val="accent1"/>
+          </a:fillRef>
+          <a:effectRef idx="2">
+            <a:schemeClr val="accent1"/>
+          </a:effectRef>
+          <a:fontRef idx="minor">
+            <a:schemeClr val="lt1"/>
+          </a:fontRef>
+        </p:style>
+        <p:txBody>
+          <a:bodyPr rtlCol="0" anchor="ctr"/>
+          <a:lstStyle/>
+          <a:p>
+            <a:pPr algn="ctr"/>
+          </a:p>
+        </p:txBody>
+      </p:sp>
+      <p:sp>
+        <p:nvSpPr>
+          <p:cNvPr id="3" name="TextBox 2"/>
+          <p:cNvSpPr txBox="1"/>
+          <p:nvPr/>
+        </p:nvSpPr>
+        <p:spPr>
+          <a:xfrm>
+            <a:off x="640080" y="2011680"/>
+            <a:ext cx="2286000" cy="1280160"/>
+          </a:xfrm>
+          <a:prstGeom prst="rect">
+            <a:avLst/>
+          </a:prstGeom>
+          <a:noFill/>
+        </p:spPr>
+        <p:txBody>
+          <a:bodyPr wrap="square">
+            <a:spAutoFit/>
+          </a:bodyPr>
+          <a:lstStyle/>
+          <a:p>
+            <a:pPr>
+              <a:defRPr sz="8000" b="1">
+                <a:solidFill>
+                  <a:srgbClr val="EDA100"/>
+                </a:solidFill>
+                <a:latin typeface="Helvetica Neue"/>
+              </a:defRPr>
+            </a:pPr>
+            <a:r>
+              <a:t>04</a:t>
+            </a:r>
+          </a:p>
+        </p:txBody>
+      </p:sp>
+      <p:sp>
+        <p:nvSpPr>
+          <p:cNvPr id="4" name="TextBox 3"/>
+          <p:cNvSpPr txBox="1"/>
+          <p:nvPr/>
+        </p:nvSpPr>
+        <p:spPr>
+          <a:xfrm>
+            <a:off x="640080" y="3200400"/>
+            <a:ext cx="10911535" cy="1188720"/>
+          </a:xfrm>
+          <a:prstGeom prst="rect">
+            <a:avLst/>
+          </a:prstGeom>
+          <a:noFill/>
+        </p:spPr>
+        <p:txBody>
+          <a:bodyPr wrap="square">
+            <a:spAutoFit/>
+          </a:bodyPr>
+          <a:lstStyle/>
+          <a:p>
+            <a:pPr>
+              <a:defRPr sz="4000" b="1">
+                <a:solidFill>
+                  <a:srgbClr val="FFFFFF"/>
+                </a:solidFill>
+                <a:latin typeface="Helvetica Neue"/>
+              </a:defRPr>
+            </a:pPr>
+            <a:r>
+              <a:t>Open-Source Strategy</a:t>
+            </a:r>
+          </a:p>
+        </p:txBody>
+      </p:sp>
+      <p:sp>
+        <p:nvSpPr>
+          <p:cNvPr id="5" name="Rectangle 4"/>
+          <p:cNvSpPr/>
+          <p:nvPr/>
+        </p:nvSpPr>
+        <p:spPr>
+          <a:xfrm>
+            <a:off x="0" y="6803136"/>
+            <a:ext cx="12191695" cy="54864"/>
+          </a:xfrm>
+          <a:prstGeom prst="rect">
+            <a:avLst/>
+          </a:prstGeom>
+          <a:solidFill>
+            <a:srgbClr val="EDA100"/>
+          </a:solidFill>
+          <a:ln>
+            <a:noFill/>
+          </a:ln>
+          <a:effectLst/>
+        </p:spPr>
+        <p:style>
+          <a:lnRef idx="1">
+            <a:schemeClr val="accent1"/>
+          </a:lnRef>
+          <a:fillRef idx="3">
+            <a:schemeClr val="accent1"/>
+          </a:fillRef>
+          <a:effectRef idx="2">
+            <a:schemeClr val="accent1"/>
+          </a:effectRef>
+          <a:fontRef idx="minor">
+            <a:schemeClr val="lt1"/>
+          </a:fontRef>
+        </p:style>
+        <p:txBody>
+          <a:bodyPr rtlCol="0" anchor="ctr"/>
+          <a:lstStyle/>
+          <a:p>
+            <a:pPr algn="ctr"/>
+          </a:p>
+        </p:txBody>
+      </p:sp>
+      <p:sp>
+        <p:nvSpPr>
+          <p:cNvPr id="6" name="TextBox 5"/>
+          <p:cNvSpPr txBox="1"/>
+          <p:nvPr/>
+        </p:nvSpPr>
+        <p:spPr>
+          <a:xfrm>
+            <a:off x="640080" y="6473952"/>
+            <a:ext cx="7315200" cy="274320"/>
+          </a:xfrm>
+          <a:prstGeom prst="rect">
+            <a:avLst/>
+          </a:prstGeom>
+          <a:noFill/>
+        </p:spPr>
+        <p:txBody>
+          <a:bodyPr wrap="square">
+            <a:spAutoFit/>
+          </a:bodyPr>
+          <a:lstStyle/>
+          <a:p>
+            <a:pPr>
+              <a:defRPr sz="1000" b="0">
+                <a:solidFill>
+                  <a:srgbClr val="52514E"/>
+                </a:solidFill>
+                <a:latin typeface="Helvetica Neue"/>
+              </a:defRPr>
+            </a:pPr>
+            <a:r>
+              <a:t>Evermon — Averis × Monash Hackathon 2026</a:t>
+            </a:r>
+          </a:p>
+        </p:txBody>
+      </p:sp>
+      <p:sp>
+        <p:nvSpPr>
+          <p:cNvPr id="7" name="TextBox 6"/>
+          <p:cNvSpPr txBox="1"/>
+          <p:nvPr/>
+        </p:nvSpPr>
+        <p:spPr>
+          <a:xfrm>
+            <a:off x="11277295" y="6473952"/>
+            <a:ext cx="548640" cy="274320"/>
+          </a:xfrm>
+          <a:prstGeom prst="rect">
+            <a:avLst/>
+          </a:prstGeom>
+          <a:noFill/>
+        </p:spPr>
+        <p:txBody>
+          <a:bodyPr wrap="square">
+            <a:spAutoFit/>
+          </a:bodyPr>
+          <a:lstStyle/>
+          <a:p>
+            <a:pPr algn="r">
+              <a:defRPr sz="1000" b="1">
+                <a:solidFill>
+                  <a:srgbClr val="2A78D6"/>
+                </a:solidFill>
+                <a:latin typeface="Helvetica Neue"/>
+              </a:defRPr>
+            </a:pPr>
+            <a:r>
+              <a:t>8</a:t>
+            </a:r>
+          </a:p>
+        </p:txBody>
+      </p:sp>
+    </p:spTree>
+  </p:cSld>
+  <p:clrMapOvr>
+    <a:masterClrMapping/>
+  </p:clrMapOvr>
+</p:sld>
+</file>
+
+<file path=ppt/slides/slide9.xml><?xml version="1.0" encoding="utf-8"?>
+<p:sld xmlns:a="http://schemas.openxmlformats.org/drawingml/2006/main" xmlns:p="http://schemas.openxmlformats.org/presentationml/2006/main" xmlns:r="http://schemas.openxmlformats.org/officeDocument/2006/relationships">
+  <p:cSld>
+    <p:spTree>
+      <p:nvGrpSpPr>
+        <p:cNvPr id="1" name=""/>
+        <p:cNvGrpSpPr/>
+        <p:nvPr/>
+      </p:nvGrpSpPr>
+      <p:grpSpPr/>
+      <p:sp>
+        <p:nvSpPr>
+          <p:cNvPr id="2" name="Rectangle 1"/>
+          <p:cNvSpPr/>
+          <p:nvPr/>
+        </p:nvSpPr>
+        <p:spPr>
+          <a:xfrm>
+            <a:off x="0" y="0"/>
+            <a:ext cx="12191695" cy="1188720"/>
+          </a:xfrm>
+          <a:prstGeom prst="rect">
+            <a:avLst/>
+          </a:prstGeom>
+          <a:solidFill>
+            <a:srgbClr val="2A78D6"/>
+          </a:solidFill>
+          <a:ln>
+            <a:noFill/>
+          </a:ln>
+          <a:effectLst/>
+        </p:spPr>
+        <p:style>
+          <a:lnRef idx="1">
+            <a:schemeClr val="accent1"/>
+          </a:lnRef>
+          <a:fillRef idx="3">
+            <a:schemeClr val="accent1"/>
+          </a:fillRef>
+          <a:effectRef idx="2">
+            <a:schemeClr val="accent1"/>
+          </a:effectRef>
+          <a:fontRef idx="minor">
+            <a:schemeClr val="lt1"/>
+          </a:fontRef>
+        </p:style>
+        <p:txBody>
+          <a:bodyPr rtlCol="0" anchor="ctr"/>
+          <a:lstStyle/>
+          <a:p>
+            <a:pPr algn="ctr"/>
+          </a:p>
+        </p:txBody>
+      </p:sp>
+      <p:sp>
+        <p:nvSpPr>
+          <p:cNvPr id="3" name="TextBox 2"/>
+          <p:cNvSpPr txBox="1"/>
+          <p:nvPr/>
+        </p:nvSpPr>
+        <p:spPr>
+          <a:xfrm>
+            <a:off x="640080" y="274320"/>
+            <a:ext cx="10911535" cy="731520"/>
+          </a:xfrm>
+          <a:prstGeom prst="rect">
+            <a:avLst/>
+          </a:prstGeom>
+          <a:noFill/>
+        </p:spPr>
+        <p:txBody>
+          <a:bodyPr wrap="square">
+            <a:spAutoFit/>
+          </a:bodyPr>
+          <a:lstStyle/>
+          <a:p>
+            <a:pPr>
+              <a:defRPr sz="2800" b="1">
+                <a:solidFill>
+                  <a:srgbClr val="FFFFFF"/>
+                </a:solidFill>
+                <a:latin typeface="Helvetica Neue"/>
+              </a:defRPr>
+            </a:pPr>
+            <a:r>
+              <a:t>Ship the trust layer, keep the moat</a:t>
+            </a:r>
+          </a:p>
+        </p:txBody>
+      </p:sp>
+      <p:sp>
+        <p:nvSpPr>
+          <p:cNvPr id="4" name="TextBox 3"/>
+          <p:cNvSpPr txBox="1"/>
+          <p:nvPr/>
+        </p:nvSpPr>
+        <p:spPr>
+          <a:xfrm>
+            <a:off x="640080" y="1554480"/>
+            <a:ext cx="10911535" cy="4572000"/>
+          </a:xfrm>
+          <a:prstGeom prst="rect">
+            <a:avLst/>
+          </a:prstGeom>
+          <a:noFill/>
+        </p:spPr>
+        <p:txBody>
+          <a:bodyPr wrap="square">
+            <a:spAutoFit/>
+          </a:bodyPr>
+          <a:lstStyle/>
+          <a:p>
+            <a:pPr>
+              <a:spcAft>
+                <a:spcPts val="1600"/>
+              </a:spcAft>
+              <a:defRPr sz="1800" b="0">
+                <a:solidFill>
+                  <a:srgbClr val="0B0B0B"/>
+                </a:solidFill>
+                <a:latin typeface="Helvetica Neue"/>
+              </a:defRPr>
+            </a:pPr>
+            <a:r>
+              <a:t>▸  Open: classification rules, alias table, escalation logic (dock/classify.py, fields.py, review.py) — auditability is the trust argument.</a:t>
+            </a:r>
+          </a:p>
+          <a:p>
+            <a:pPr>
+              <a:spcAft>
+                <a:spcPts val="1600"/>
+              </a:spcAft>
+              <a:defRPr sz="1800" b="0">
+                <a:solidFill>
+                  <a:srgbClr val="0B0B0B"/>
+                </a:solidFill>
+                <a:latin typeface="Helvetica Neue"/>
+              </a:defRPr>
+            </a:pPr>
+            <a:r>
+              <a:t>▸  Closed: document-parsing edge cases and any fine-tuned extraction — the maintenance moat, not "the loader".</a:t>
+            </a:r>
+          </a:p>
+        </p:txBody>
+      </p:sp>
+      <p:sp>
+        <p:nvSpPr>
+          <p:cNvPr id="5" name="Rectangle 4"/>
+          <p:cNvSpPr/>
+          <p:nvPr/>
+        </p:nvSpPr>
+        <p:spPr>
+          <a:xfrm>
+            <a:off x="0" y="6803136"/>
+            <a:ext cx="12191695" cy="54864"/>
+          </a:xfrm>
+          <a:prstGeom prst="rect">
+            <a:avLst/>
+          </a:prstGeom>
+          <a:solidFill>
+            <a:srgbClr val="EDA100"/>
+          </a:solidFill>
+          <a:ln>
+            <a:noFill/>
+          </a:ln>
+          <a:effectLst/>
+        </p:spPr>
+        <p:style>
+          <a:lnRef idx="1">
+            <a:schemeClr val="accent1"/>
+          </a:lnRef>
+          <a:fillRef idx="3">
+            <a:schemeClr val="accent1"/>
+          </a:fillRef>
+          <a:effectRef idx="2">
+            <a:schemeClr val="accent1"/>
+          </a:effectRef>
+          <a:fontRef idx="minor">
+            <a:schemeClr val="lt1"/>
+          </a:fontRef>
+        </p:style>
+        <p:txBody>
+          <a:bodyPr rtlCol="0" anchor="ctr"/>
+          <a:lstStyle/>
+          <a:p>
+            <a:pPr algn="ctr"/>
+          </a:p>
+        </p:txBody>
+      </p:sp>
+      <p:sp>
+        <p:nvSpPr>
+          <p:cNvPr id="6" name="TextBox 5"/>
+          <p:cNvSpPr txBox="1"/>
+          <p:nvPr/>
+        </p:nvSpPr>
+        <p:spPr>
+          <a:xfrm>
+            <a:off x="640080" y="6473952"/>
+            <a:ext cx="7315200" cy="274320"/>
+          </a:xfrm>
+          <a:prstGeom prst="rect">
+            <a:avLst/>
+          </a:prstGeom>
+          <a:noFill/>
+        </p:spPr>
+        <p:txBody>
+          <a:bodyPr wrap="square">
+            <a:spAutoFit/>
+          </a:bodyPr>
+          <a:lstStyle/>
+          <a:p>
+            <a:pPr>
+              <a:defRPr sz="1000" b="0">
+                <a:solidFill>
+                  <a:srgbClr val="52514E"/>
+                </a:solidFill>
+                <a:latin typeface="Helvetica Neue"/>
+              </a:defRPr>
+            </a:pPr>
+            <a:r>
+              <a:t>Evermon — Averis × Monash Hackathon 2026</a:t>
+            </a:r>
+          </a:p>
+        </p:txBody>
+      </p:sp>
+      <p:sp>
+        <p:nvSpPr>
+          <p:cNvPr id="7" name="TextBox 6"/>
+          <p:cNvSpPr txBox="1"/>
+          <p:nvPr/>
+        </p:nvSpPr>
+        <p:spPr>
+          <a:xfrm>
+            <a:off x="11277295" y="6473952"/>
+            <a:ext cx="548640" cy="274320"/>
+          </a:xfrm>
+          <a:prstGeom prst="rect">
+            <a:avLst/>
+          </a:prstGeom>
+          <a:noFill/>
+        </p:spPr>
+        <p:txBody>
+          <a:bodyPr wrap="square">
+            <a:spAutoFit/>
+          </a:bodyPr>
+          <a:lstStyle/>
+          <a:p>
+            <a:pPr algn="r">
+              <a:defRPr sz="1000" b="1">
+                <a:solidFill>
+                  <a:srgbClr val="2A78D6"/>
+                </a:solidFill>
+                <a:latin typeface="Helvetica Neue"/>
+              </a:defRPr>
+            </a:pPr>
+            <a:r>
+              <a:t>9</a:t>
             </a:r>
           </a:p>
         </p:txBody>

</xml_diff>

<commit_message>
docs: add doc-requirement slides and links to the pitch deck
Four new sections (Technical Architecture, Implementation Details,
Challenges Faced, Future Roadmap) condensed from docs/DOCUMENTATION.md --
same content, not restated differently. All 21 slides stay under the
60-word density limit. Closing slide now links the demo video
(youtu.be/TE72CMXwmZ0) alongside the live prototype and repo -- plain
text links, nothing embedded.

Also: ignore Office's ~$*.pptx lock files, dropped again by whatever
auto-opens the deck.
</commit_message>
<xml_diff>
--- a/docs/AverisMonash2026.pptx
+++ b/docs/AverisMonash2026.pptx
@@ -18,6 +18,14 @@
     <p:sldId id="266" r:id="rId17"/>
     <p:sldId id="267" r:id="rId18"/>
     <p:sldId id="268" r:id="rId19"/>
+    <p:sldId id="269" r:id="rId20"/>
+    <p:sldId id="270" r:id="rId21"/>
+    <p:sldId id="271" r:id="rId22"/>
+    <p:sldId id="272" r:id="rId23"/>
+    <p:sldId id="273" r:id="rId24"/>
+    <p:sldId id="274" r:id="rId25"/>
+    <p:sldId id="275" r:id="rId26"/>
+    <p:sldId id="276" r:id="rId27"/>
   </p:sldIdLst>
   <p:sldSz cx="12191695" cy="6858000" type="screen4x3"/>
   <p:notesSz cx="6858000" cy="9144000"/>
@@ -4410,7 +4418,7 @@
             <a:avLst/>
           </a:prstGeom>
           <a:solidFill>
-            <a:srgbClr val="0D1B2A"/>
+            <a:srgbClr val="2A78D6"/>
           </a:solidFill>
           <a:ln>
             <a:noFill/>
@@ -4441,14 +4449,86 @@
       </p:sp>
       <p:sp>
         <p:nvSpPr>
-          <p:cNvPr id="3" name="Rectangle 2"/>
+          <p:cNvPr id="3" name="TextBox 2"/>
+          <p:cNvSpPr txBox="1"/>
+          <p:nvPr/>
+        </p:nvSpPr>
+        <p:spPr>
+          <a:xfrm>
+            <a:off x="640080" y="2011680"/>
+            <a:ext cx="2286000" cy="1280160"/>
+          </a:xfrm>
+          <a:prstGeom prst="rect">
+            <a:avLst/>
+          </a:prstGeom>
+          <a:noFill/>
+        </p:spPr>
+        <p:txBody>
+          <a:bodyPr wrap="square">
+            <a:spAutoFit/>
+          </a:bodyPr>
+          <a:lstStyle/>
+          <a:p>
+            <a:pPr>
+              <a:defRPr sz="8000" b="1">
+                <a:solidFill>
+                  <a:srgbClr val="EDA100"/>
+                </a:solidFill>
+                <a:latin typeface="Helvetica Neue"/>
+              </a:defRPr>
+            </a:pPr>
+            <a:r>
+              <a:t>06</a:t>
+            </a:r>
+          </a:p>
+        </p:txBody>
+      </p:sp>
+      <p:sp>
+        <p:nvSpPr>
+          <p:cNvPr id="4" name="TextBox 3"/>
+          <p:cNvSpPr txBox="1"/>
+          <p:nvPr/>
+        </p:nvSpPr>
+        <p:spPr>
+          <a:xfrm>
+            <a:off x="640080" y="3200400"/>
+            <a:ext cx="10911535" cy="1188720"/>
+          </a:xfrm>
+          <a:prstGeom prst="rect">
+            <a:avLst/>
+          </a:prstGeom>
+          <a:noFill/>
+        </p:spPr>
+        <p:txBody>
+          <a:bodyPr wrap="square">
+            <a:spAutoFit/>
+          </a:bodyPr>
+          <a:lstStyle/>
+          <a:p>
+            <a:pPr>
+              <a:defRPr sz="4000" b="1">
+                <a:solidFill>
+                  <a:srgbClr val="FFFFFF"/>
+                </a:solidFill>
+                <a:latin typeface="Helvetica Neue"/>
+              </a:defRPr>
+            </a:pPr>
+            <a:r>
+              <a:t>Technical Architecture</a:t>
+            </a:r>
+          </a:p>
+        </p:txBody>
+      </p:sp>
+      <p:sp>
+        <p:nvSpPr>
+          <p:cNvPr id="5" name="Rectangle 4"/>
           <p:cNvSpPr/>
           <p:nvPr/>
         </p:nvSpPr>
         <p:spPr>
           <a:xfrm>
-            <a:off x="0" y="0"/>
-            <a:ext cx="12191695" cy="109728"/>
+            <a:off x="0" y="6803136"/>
+            <a:ext cx="12191695" cy="54864"/>
           </a:xfrm>
           <a:prstGeom prst="rect">
             <a:avLst/>
@@ -4485,14 +4565,14 @@
       </p:sp>
       <p:sp>
         <p:nvSpPr>
-          <p:cNvPr id="4" name="TextBox 3"/>
+          <p:cNvPr id="6" name="TextBox 5"/>
           <p:cNvSpPr txBox="1"/>
           <p:nvPr/>
         </p:nvSpPr>
         <p:spPr>
           <a:xfrm>
-            <a:off x="640080" y="2103120"/>
-            <a:ext cx="10911535" cy="1097280"/>
+            <a:off x="640080" y="6473952"/>
+            <a:ext cx="7315200" cy="274320"/>
           </a:xfrm>
           <a:prstGeom prst="rect">
             <a:avLst/>
@@ -4506,29 +4586,29 @@
           <a:lstStyle/>
           <a:p>
             <a:pPr>
-              <a:defRPr sz="4800" b="1">
-                <a:solidFill>
-                  <a:srgbClr val="FFFFFF"/>
-                </a:solidFill>
-                <a:latin typeface="Helvetica Neue"/>
-              </a:defRPr>
-            </a:pPr>
-            <a:r>
-              <a:t>Try it yourself</a:t>
-            </a:r>
-          </a:p>
-        </p:txBody>
-      </p:sp>
-      <p:sp>
-        <p:nvSpPr>
-          <p:cNvPr id="5" name="TextBox 4"/>
+              <a:defRPr sz="1000" b="0">
+                <a:solidFill>
+                  <a:srgbClr val="52514E"/>
+                </a:solidFill>
+                <a:latin typeface="Helvetica Neue"/>
+              </a:defRPr>
+            </a:pPr>
+            <a:r>
+              <a:t>Evermon — Averis × Monash Hackathon 2026</a:t>
+            </a:r>
+          </a:p>
+        </p:txBody>
+      </p:sp>
+      <p:sp>
+        <p:nvSpPr>
+          <p:cNvPr id="7" name="TextBox 6"/>
           <p:cNvSpPr txBox="1"/>
           <p:nvPr/>
         </p:nvSpPr>
         <p:spPr>
           <a:xfrm>
-            <a:off x="640080" y="3383280"/>
-            <a:ext cx="10911535" cy="2286000"/>
+            <a:off x="11277295" y="6473952"/>
+            <a:ext cx="548640" cy="274320"/>
           </a:xfrm>
           <a:prstGeom prst="rect">
             <a:avLst/>
@@ -4541,58 +4621,192 @@
           </a:bodyPr>
           <a:lstStyle/>
           <a:p>
+            <a:pPr algn="r">
+              <a:defRPr sz="1000" b="1">
+                <a:solidFill>
+                  <a:srgbClr val="2A78D6"/>
+                </a:solidFill>
+                <a:latin typeface="Helvetica Neue"/>
+              </a:defRPr>
+            </a:pPr>
+            <a:r>
+              <a:t>13</a:t>
+            </a:r>
+          </a:p>
+        </p:txBody>
+      </p:sp>
+    </p:spTree>
+  </p:cSld>
+  <p:clrMapOvr>
+    <a:masterClrMapping/>
+  </p:clrMapOvr>
+</p:sld>
+</file>
+
+<file path=ppt/slides/slide14.xml><?xml version="1.0" encoding="utf-8"?>
+<p:sld xmlns:a="http://schemas.openxmlformats.org/drawingml/2006/main" xmlns:p="http://schemas.openxmlformats.org/presentationml/2006/main" xmlns:r="http://schemas.openxmlformats.org/officeDocument/2006/relationships">
+  <p:cSld>
+    <p:spTree>
+      <p:nvGrpSpPr>
+        <p:cNvPr id="1" name=""/>
+        <p:cNvGrpSpPr/>
+        <p:nvPr/>
+      </p:nvGrpSpPr>
+      <p:grpSpPr/>
+      <p:sp>
+        <p:nvSpPr>
+          <p:cNvPr id="2" name="Rectangle 1"/>
+          <p:cNvSpPr/>
+          <p:nvPr/>
+        </p:nvSpPr>
+        <p:spPr>
+          <a:xfrm>
+            <a:off x="0" y="0"/>
+            <a:ext cx="12191695" cy="1188720"/>
+          </a:xfrm>
+          <a:prstGeom prst="rect">
+            <a:avLst/>
+          </a:prstGeom>
+          <a:solidFill>
+            <a:srgbClr val="2A78D6"/>
+          </a:solidFill>
+          <a:ln>
+            <a:noFill/>
+          </a:ln>
+          <a:effectLst/>
+        </p:spPr>
+        <p:style>
+          <a:lnRef idx="1">
+            <a:schemeClr val="accent1"/>
+          </a:lnRef>
+          <a:fillRef idx="3">
+            <a:schemeClr val="accent1"/>
+          </a:fillRef>
+          <a:effectRef idx="2">
+            <a:schemeClr val="accent1"/>
+          </a:effectRef>
+          <a:fontRef idx="minor">
+            <a:schemeClr val="lt1"/>
+          </a:fontRef>
+        </p:style>
+        <p:txBody>
+          <a:bodyPr rtlCol="0" anchor="ctr"/>
+          <a:lstStyle/>
+          <a:p>
+            <a:pPr algn="ctr"/>
+          </a:p>
+        </p:txBody>
+      </p:sp>
+      <p:sp>
+        <p:nvSpPr>
+          <p:cNvPr id="3" name="TextBox 2"/>
+          <p:cNvSpPr txBox="1"/>
+          <p:nvPr/>
+        </p:nvSpPr>
+        <p:spPr>
+          <a:xfrm>
+            <a:off x="640080" y="274320"/>
+            <a:ext cx="10911535" cy="731520"/>
+          </a:xfrm>
+          <a:prstGeom prst="rect">
+            <a:avLst/>
+          </a:prstGeom>
+          <a:noFill/>
+        </p:spPr>
+        <p:txBody>
+          <a:bodyPr wrap="square">
+            <a:spAutoFit/>
+          </a:bodyPr>
+          <a:lstStyle/>
+          <a:p>
+            <a:pPr>
+              <a:defRPr sz="2800" b="1">
+                <a:solidFill>
+                  <a:srgbClr val="FFFFFF"/>
+                </a:solidFill>
+                <a:latin typeface="Helvetica Neue"/>
+              </a:defRPr>
+            </a:pPr>
+            <a:r>
+              <a:t>Three parts, one shared core</a:t>
+            </a:r>
+          </a:p>
+        </p:txBody>
+      </p:sp>
+      <p:sp>
+        <p:nvSpPr>
+          <p:cNvPr id="4" name="TextBox 3"/>
+          <p:cNvSpPr txBox="1"/>
+          <p:nvPr/>
+        </p:nvSpPr>
+        <p:spPr>
+          <a:xfrm>
+            <a:off x="640080" y="1554480"/>
+            <a:ext cx="10911535" cy="4572000"/>
+          </a:xfrm>
+          <a:prstGeom prst="rect">
+            <a:avLst/>
+          </a:prstGeom>
+          <a:noFill/>
+        </p:spPr>
+        <p:txBody>
+          <a:bodyPr wrap="square">
+            <a:spAutoFit/>
+          </a:bodyPr>
+          <a:lstStyle/>
+          <a:p>
             <a:pPr>
               <a:spcAft>
-                <a:spcPts val="1000"/>
+                <a:spcPts val="1600"/>
               </a:spcAft>
               <a:defRPr sz="1800" b="0">
                 <a:solidFill>
-                  <a:srgbClr val="C3C9D1"/>
-                </a:solidFill>
-                <a:latin typeface="Helvetica Neue"/>
-              </a:defRPr>
-            </a:pPr>
-            <a:r>
-              <a:t>Live prototype: evermon-demo.nazrijz336.workers.dev</a:t>
+                  <a:srgbClr val="0B0B0B"/>
+                </a:solidFill>
+                <a:latin typeface="Helvetica Neue"/>
+              </a:defRPr>
+            </a:pPr>
+            <a:r>
+              <a:t>▸  dock/: classify -&gt; extract -&gt; compare -&gt; escalate. Stdlib Python 3.11, the graded submission.</a:t>
             </a:r>
           </a:p>
           <a:p>
             <a:pPr>
               <a:spcAft>
-                <a:spcPts val="1000"/>
+                <a:spcPts val="1600"/>
               </a:spcAft>
               <a:defRPr sz="1800" b="0">
                 <a:solidFill>
-                  <a:srgbClr val="C3C9D1"/>
-                </a:solidFill>
-                <a:latin typeface="Helvetica Neue"/>
-              </a:defRPr>
-            </a:pPr>
-            <a:r>
-              <a:t>Source: github.com/ponli550/Evermon</a:t>
+                  <a:srgbClr val="0B0B0B"/>
+                </a:solidFill>
+                <a:latin typeface="Helvetica Neue"/>
+              </a:defRPr>
+            </a:pPr>
+            <a:r>
+              <a:t>▸  watch/: Go CLI + terminal dashboard, reuses dock.pipeline.decide() live — not a second implementation.</a:t>
             </a:r>
           </a:p>
           <a:p>
             <a:pPr>
               <a:spcAft>
-                <a:spcPts val="1000"/>
+                <a:spcPts val="1600"/>
               </a:spcAft>
               <a:defRPr sz="1800" b="0">
                 <a:solidFill>
-                  <a:srgbClr val="C3C9D1"/>
-                </a:solidFill>
-                <a:latin typeface="Helvetica Neue"/>
-              </a:defRPr>
-            </a:pPr>
-            <a:r>
-              <a:t>Thank you.</a:t>
-            </a:r>
-          </a:p>
-        </p:txBody>
-      </p:sp>
-      <p:sp>
-        <p:nvSpPr>
-          <p:cNvPr id="6" name="Rectangle 5"/>
+                  <a:srgbClr val="0B0B0B"/>
+                </a:solidFill>
+                <a:latin typeface="Helvetica Neue"/>
+              </a:defRPr>
+            </a:pPr>
+            <a:r>
+              <a:t>▸  web-demo/: static Cloudflare Worker, a parity-verified TypeScript port of just the comparison rules.</a:t>
+            </a:r>
+          </a:p>
+        </p:txBody>
+      </p:sp>
+      <p:sp>
+        <p:nvSpPr>
+          <p:cNvPr id="5" name="Rectangle 4"/>
           <p:cNvSpPr/>
           <p:nvPr/>
         </p:nvSpPr>
@@ -4636,7 +4850,7 @@
       </p:sp>
       <p:sp>
         <p:nvSpPr>
-          <p:cNvPr id="7" name="TextBox 6"/>
+          <p:cNvPr id="6" name="TextBox 5"/>
           <p:cNvSpPr txBox="1"/>
           <p:nvPr/>
         </p:nvSpPr>
@@ -4672,7 +4886,7 @@
       </p:sp>
       <p:sp>
         <p:nvSpPr>
-          <p:cNvPr id="8" name="TextBox 7"/>
+          <p:cNvPr id="7" name="TextBox 6"/>
           <p:cNvSpPr txBox="1"/>
           <p:nvPr/>
         </p:nvSpPr>
@@ -4701,7 +4915,1327 @@
               </a:defRPr>
             </a:pPr>
             <a:r>
-              <a:t>13</a:t>
+              <a:t>14</a:t>
+            </a:r>
+          </a:p>
+        </p:txBody>
+      </p:sp>
+    </p:spTree>
+  </p:cSld>
+  <p:clrMapOvr>
+    <a:masterClrMapping/>
+  </p:clrMapOvr>
+</p:sld>
+</file>
+
+<file path=ppt/slides/slide15.xml><?xml version="1.0" encoding="utf-8"?>
+<p:sld xmlns:a="http://schemas.openxmlformats.org/drawingml/2006/main" xmlns:p="http://schemas.openxmlformats.org/presentationml/2006/main" xmlns:r="http://schemas.openxmlformats.org/officeDocument/2006/relationships">
+  <p:cSld>
+    <p:spTree>
+      <p:nvGrpSpPr>
+        <p:cNvPr id="1" name=""/>
+        <p:cNvGrpSpPr/>
+        <p:nvPr/>
+      </p:nvGrpSpPr>
+      <p:grpSpPr/>
+      <p:sp>
+        <p:nvSpPr>
+          <p:cNvPr id="2" name="Rectangle 1"/>
+          <p:cNvSpPr/>
+          <p:nvPr/>
+        </p:nvSpPr>
+        <p:spPr>
+          <a:xfrm>
+            <a:off x="0" y="0"/>
+            <a:ext cx="12191695" cy="6858000"/>
+          </a:xfrm>
+          <a:prstGeom prst="rect">
+            <a:avLst/>
+          </a:prstGeom>
+          <a:solidFill>
+            <a:srgbClr val="2A78D6"/>
+          </a:solidFill>
+          <a:ln>
+            <a:noFill/>
+          </a:ln>
+          <a:effectLst/>
+        </p:spPr>
+        <p:style>
+          <a:lnRef idx="1">
+            <a:schemeClr val="accent1"/>
+          </a:lnRef>
+          <a:fillRef idx="3">
+            <a:schemeClr val="accent1"/>
+          </a:fillRef>
+          <a:effectRef idx="2">
+            <a:schemeClr val="accent1"/>
+          </a:effectRef>
+          <a:fontRef idx="minor">
+            <a:schemeClr val="lt1"/>
+          </a:fontRef>
+        </p:style>
+        <p:txBody>
+          <a:bodyPr rtlCol="0" anchor="ctr"/>
+          <a:lstStyle/>
+          <a:p>
+            <a:pPr algn="ctr"/>
+          </a:p>
+        </p:txBody>
+      </p:sp>
+      <p:sp>
+        <p:nvSpPr>
+          <p:cNvPr id="3" name="TextBox 2"/>
+          <p:cNvSpPr txBox="1"/>
+          <p:nvPr/>
+        </p:nvSpPr>
+        <p:spPr>
+          <a:xfrm>
+            <a:off x="640080" y="2011680"/>
+            <a:ext cx="2286000" cy="1280160"/>
+          </a:xfrm>
+          <a:prstGeom prst="rect">
+            <a:avLst/>
+          </a:prstGeom>
+          <a:noFill/>
+        </p:spPr>
+        <p:txBody>
+          <a:bodyPr wrap="square">
+            <a:spAutoFit/>
+          </a:bodyPr>
+          <a:lstStyle/>
+          <a:p>
+            <a:pPr>
+              <a:defRPr sz="8000" b="1">
+                <a:solidFill>
+                  <a:srgbClr val="EDA100"/>
+                </a:solidFill>
+                <a:latin typeface="Helvetica Neue"/>
+              </a:defRPr>
+            </a:pPr>
+            <a:r>
+              <a:t>07</a:t>
+            </a:r>
+          </a:p>
+        </p:txBody>
+      </p:sp>
+      <p:sp>
+        <p:nvSpPr>
+          <p:cNvPr id="4" name="TextBox 3"/>
+          <p:cNvSpPr txBox="1"/>
+          <p:nvPr/>
+        </p:nvSpPr>
+        <p:spPr>
+          <a:xfrm>
+            <a:off x="640080" y="3200400"/>
+            <a:ext cx="10911535" cy="1188720"/>
+          </a:xfrm>
+          <a:prstGeom prst="rect">
+            <a:avLst/>
+          </a:prstGeom>
+          <a:noFill/>
+        </p:spPr>
+        <p:txBody>
+          <a:bodyPr wrap="square">
+            <a:spAutoFit/>
+          </a:bodyPr>
+          <a:lstStyle/>
+          <a:p>
+            <a:pPr>
+              <a:defRPr sz="4000" b="1">
+                <a:solidFill>
+                  <a:srgbClr val="FFFFFF"/>
+                </a:solidFill>
+                <a:latin typeface="Helvetica Neue"/>
+              </a:defRPr>
+            </a:pPr>
+            <a:r>
+              <a:t>Implementation Details</a:t>
+            </a:r>
+          </a:p>
+        </p:txBody>
+      </p:sp>
+      <p:sp>
+        <p:nvSpPr>
+          <p:cNvPr id="5" name="Rectangle 4"/>
+          <p:cNvSpPr/>
+          <p:nvPr/>
+        </p:nvSpPr>
+        <p:spPr>
+          <a:xfrm>
+            <a:off x="0" y="6803136"/>
+            <a:ext cx="12191695" cy="54864"/>
+          </a:xfrm>
+          <a:prstGeom prst="rect">
+            <a:avLst/>
+          </a:prstGeom>
+          <a:solidFill>
+            <a:srgbClr val="EDA100"/>
+          </a:solidFill>
+          <a:ln>
+            <a:noFill/>
+          </a:ln>
+          <a:effectLst/>
+        </p:spPr>
+        <p:style>
+          <a:lnRef idx="1">
+            <a:schemeClr val="accent1"/>
+          </a:lnRef>
+          <a:fillRef idx="3">
+            <a:schemeClr val="accent1"/>
+          </a:fillRef>
+          <a:effectRef idx="2">
+            <a:schemeClr val="accent1"/>
+          </a:effectRef>
+          <a:fontRef idx="minor">
+            <a:schemeClr val="lt1"/>
+          </a:fontRef>
+        </p:style>
+        <p:txBody>
+          <a:bodyPr rtlCol="0" anchor="ctr"/>
+          <a:lstStyle/>
+          <a:p>
+            <a:pPr algn="ctr"/>
+          </a:p>
+        </p:txBody>
+      </p:sp>
+      <p:sp>
+        <p:nvSpPr>
+          <p:cNvPr id="6" name="TextBox 5"/>
+          <p:cNvSpPr txBox="1"/>
+          <p:nvPr/>
+        </p:nvSpPr>
+        <p:spPr>
+          <a:xfrm>
+            <a:off x="640080" y="6473952"/>
+            <a:ext cx="7315200" cy="274320"/>
+          </a:xfrm>
+          <a:prstGeom prst="rect">
+            <a:avLst/>
+          </a:prstGeom>
+          <a:noFill/>
+        </p:spPr>
+        <p:txBody>
+          <a:bodyPr wrap="square">
+            <a:spAutoFit/>
+          </a:bodyPr>
+          <a:lstStyle/>
+          <a:p>
+            <a:pPr>
+              <a:defRPr sz="1000" b="0">
+                <a:solidFill>
+                  <a:srgbClr val="52514E"/>
+                </a:solidFill>
+                <a:latin typeface="Helvetica Neue"/>
+              </a:defRPr>
+            </a:pPr>
+            <a:r>
+              <a:t>Evermon — Averis × Monash Hackathon 2026</a:t>
+            </a:r>
+          </a:p>
+        </p:txBody>
+      </p:sp>
+      <p:sp>
+        <p:nvSpPr>
+          <p:cNvPr id="7" name="TextBox 6"/>
+          <p:cNvSpPr txBox="1"/>
+          <p:nvPr/>
+        </p:nvSpPr>
+        <p:spPr>
+          <a:xfrm>
+            <a:off x="11277295" y="6473952"/>
+            <a:ext cx="548640" cy="274320"/>
+          </a:xfrm>
+          <a:prstGeom prst="rect">
+            <a:avLst/>
+          </a:prstGeom>
+          <a:noFill/>
+        </p:spPr>
+        <p:txBody>
+          <a:bodyPr wrap="square">
+            <a:spAutoFit/>
+          </a:bodyPr>
+          <a:lstStyle/>
+          <a:p>
+            <a:pPr algn="r">
+              <a:defRPr sz="1000" b="1">
+                <a:solidFill>
+                  <a:srgbClr val="2A78D6"/>
+                </a:solidFill>
+                <a:latin typeface="Helvetica Neue"/>
+              </a:defRPr>
+            </a:pPr>
+            <a:r>
+              <a:t>15</a:t>
+            </a:r>
+          </a:p>
+        </p:txBody>
+      </p:sp>
+    </p:spTree>
+  </p:cSld>
+  <p:clrMapOvr>
+    <a:masterClrMapping/>
+  </p:clrMapOvr>
+</p:sld>
+</file>
+
+<file path=ppt/slides/slide16.xml><?xml version="1.0" encoding="utf-8"?>
+<p:sld xmlns:a="http://schemas.openxmlformats.org/drawingml/2006/main" xmlns:p="http://schemas.openxmlformats.org/presentationml/2006/main" xmlns:r="http://schemas.openxmlformats.org/officeDocument/2006/relationships">
+  <p:cSld>
+    <p:spTree>
+      <p:nvGrpSpPr>
+        <p:cNvPr id="1" name=""/>
+        <p:cNvGrpSpPr/>
+        <p:nvPr/>
+      </p:nvGrpSpPr>
+      <p:grpSpPr/>
+      <p:sp>
+        <p:nvSpPr>
+          <p:cNvPr id="2" name="Rectangle 1"/>
+          <p:cNvSpPr/>
+          <p:nvPr/>
+        </p:nvSpPr>
+        <p:spPr>
+          <a:xfrm>
+            <a:off x="0" y="0"/>
+            <a:ext cx="12191695" cy="1188720"/>
+          </a:xfrm>
+          <a:prstGeom prst="rect">
+            <a:avLst/>
+          </a:prstGeom>
+          <a:solidFill>
+            <a:srgbClr val="2A78D6"/>
+          </a:solidFill>
+          <a:ln>
+            <a:noFill/>
+          </a:ln>
+          <a:effectLst/>
+        </p:spPr>
+        <p:style>
+          <a:lnRef idx="1">
+            <a:schemeClr val="accent1"/>
+          </a:lnRef>
+          <a:fillRef idx="3">
+            <a:schemeClr val="accent1"/>
+          </a:fillRef>
+          <a:effectRef idx="2">
+            <a:schemeClr val="accent1"/>
+          </a:effectRef>
+          <a:fontRef idx="minor">
+            <a:schemeClr val="lt1"/>
+          </a:fontRef>
+        </p:style>
+        <p:txBody>
+          <a:bodyPr rtlCol="0" anchor="ctr"/>
+          <a:lstStyle/>
+          <a:p>
+            <a:pPr algn="ctr"/>
+          </a:p>
+        </p:txBody>
+      </p:sp>
+      <p:sp>
+        <p:nvSpPr>
+          <p:cNvPr id="3" name="TextBox 2"/>
+          <p:cNvSpPr txBox="1"/>
+          <p:nvPr/>
+        </p:nvSpPr>
+        <p:spPr>
+          <a:xfrm>
+            <a:off x="640080" y="274320"/>
+            <a:ext cx="10911535" cy="731520"/>
+          </a:xfrm>
+          <a:prstGeom prst="rect">
+            <a:avLst/>
+          </a:prstGeom>
+          <a:noFill/>
+        </p:spPr>
+        <p:txBody>
+          <a:bodyPr wrap="square">
+            <a:spAutoFit/>
+          </a:bodyPr>
+          <a:lstStyle/>
+          <a:p>
+            <a:pPr>
+              <a:defRPr sz="2800" b="1">
+                <a:solidFill>
+                  <a:srgbClr val="FFFFFF"/>
+                </a:solidFill>
+                <a:latin typeface="Helvetica Neue"/>
+              </a:defRPr>
+            </a:pPr>
+            <a:r>
+              <a:t>What actually makes it accurate</a:t>
+            </a:r>
+          </a:p>
+        </p:txBody>
+      </p:sp>
+      <p:sp>
+        <p:nvSpPr>
+          <p:cNvPr id="4" name="TextBox 3"/>
+          <p:cNvSpPr txBox="1"/>
+          <p:nvPr/>
+        </p:nvSpPr>
+        <p:spPr>
+          <a:xfrm>
+            <a:off x="640080" y="1554480"/>
+            <a:ext cx="10911535" cy="4572000"/>
+          </a:xfrm>
+          <a:prstGeom prst="rect">
+            <a:avLst/>
+          </a:prstGeom>
+          <a:noFill/>
+        </p:spPr>
+        <p:txBody>
+          <a:bodyPr wrap="square">
+            <a:spAutoFit/>
+          </a:bodyPr>
+          <a:lstStyle/>
+          <a:p>
+            <a:pPr>
+              <a:spcAft>
+                <a:spcPts val="1600"/>
+              </a:spcAft>
+              <a:defRPr sz="1800" b="0">
+                <a:solidFill>
+                  <a:srgbClr val="0B0B0B"/>
+                </a:solidFill>
+                <a:latin typeface="Helvetica Neue"/>
+              </a:defRPr>
+            </a:pPr>
+            <a:r>
+              <a:t>▸  Classification reads the body first, not the subject — this corpus deliberately mislabels it.</a:t>
+            </a:r>
+          </a:p>
+          <a:p>
+            <a:pPr>
+              <a:spcAft>
+                <a:spcPts val="1600"/>
+              </a:spcAft>
+              <a:defRPr sz="1800" b="0">
+                <a:solidFill>
+                  <a:srgbClr val="0B0B0B"/>
+                </a:solidFill>
+                <a:latin typeface="Helvetica Neue"/>
+              </a:defRPr>
+            </a:pPr>
+            <a:r>
+              <a:t>▸  Field alignment is table-driven: an unrecognised label returns nothing, never a guess.</a:t>
+            </a:r>
+          </a:p>
+          <a:p>
+            <a:pPr>
+              <a:spcAft>
+                <a:spcPts val="1600"/>
+              </a:spcAft>
+              <a:defRPr sz="1800" b="0">
+                <a:solidFill>
+                  <a:srgbClr val="0B0B0B"/>
+                </a:solidFill>
+                <a:latin typeface="Helvetica Neue"/>
+              </a:defRPr>
+            </a:pPr>
+            <a:r>
+              <a:t>▸  No OCR, no vision model — scanned PDFs escalate correctly instead of inventing a value.</a:t>
+            </a:r>
+          </a:p>
+        </p:txBody>
+      </p:sp>
+      <p:sp>
+        <p:nvSpPr>
+          <p:cNvPr id="5" name="Rectangle 4"/>
+          <p:cNvSpPr/>
+          <p:nvPr/>
+        </p:nvSpPr>
+        <p:spPr>
+          <a:xfrm>
+            <a:off x="0" y="6803136"/>
+            <a:ext cx="12191695" cy="54864"/>
+          </a:xfrm>
+          <a:prstGeom prst="rect">
+            <a:avLst/>
+          </a:prstGeom>
+          <a:solidFill>
+            <a:srgbClr val="EDA100"/>
+          </a:solidFill>
+          <a:ln>
+            <a:noFill/>
+          </a:ln>
+          <a:effectLst/>
+        </p:spPr>
+        <p:style>
+          <a:lnRef idx="1">
+            <a:schemeClr val="accent1"/>
+          </a:lnRef>
+          <a:fillRef idx="3">
+            <a:schemeClr val="accent1"/>
+          </a:fillRef>
+          <a:effectRef idx="2">
+            <a:schemeClr val="accent1"/>
+          </a:effectRef>
+          <a:fontRef idx="minor">
+            <a:schemeClr val="lt1"/>
+          </a:fontRef>
+        </p:style>
+        <p:txBody>
+          <a:bodyPr rtlCol="0" anchor="ctr"/>
+          <a:lstStyle/>
+          <a:p>
+            <a:pPr algn="ctr"/>
+          </a:p>
+        </p:txBody>
+      </p:sp>
+      <p:sp>
+        <p:nvSpPr>
+          <p:cNvPr id="6" name="TextBox 5"/>
+          <p:cNvSpPr txBox="1"/>
+          <p:nvPr/>
+        </p:nvSpPr>
+        <p:spPr>
+          <a:xfrm>
+            <a:off x="640080" y="6473952"/>
+            <a:ext cx="7315200" cy="274320"/>
+          </a:xfrm>
+          <a:prstGeom prst="rect">
+            <a:avLst/>
+          </a:prstGeom>
+          <a:noFill/>
+        </p:spPr>
+        <p:txBody>
+          <a:bodyPr wrap="square">
+            <a:spAutoFit/>
+          </a:bodyPr>
+          <a:lstStyle/>
+          <a:p>
+            <a:pPr>
+              <a:defRPr sz="1000" b="0">
+                <a:solidFill>
+                  <a:srgbClr val="52514E"/>
+                </a:solidFill>
+                <a:latin typeface="Helvetica Neue"/>
+              </a:defRPr>
+            </a:pPr>
+            <a:r>
+              <a:t>Evermon — Averis × Monash Hackathon 2026</a:t>
+            </a:r>
+          </a:p>
+        </p:txBody>
+      </p:sp>
+      <p:sp>
+        <p:nvSpPr>
+          <p:cNvPr id="7" name="TextBox 6"/>
+          <p:cNvSpPr txBox="1"/>
+          <p:nvPr/>
+        </p:nvSpPr>
+        <p:spPr>
+          <a:xfrm>
+            <a:off x="11277295" y="6473952"/>
+            <a:ext cx="548640" cy="274320"/>
+          </a:xfrm>
+          <a:prstGeom prst="rect">
+            <a:avLst/>
+          </a:prstGeom>
+          <a:noFill/>
+        </p:spPr>
+        <p:txBody>
+          <a:bodyPr wrap="square">
+            <a:spAutoFit/>
+          </a:bodyPr>
+          <a:lstStyle/>
+          <a:p>
+            <a:pPr algn="r">
+              <a:defRPr sz="1000" b="1">
+                <a:solidFill>
+                  <a:srgbClr val="2A78D6"/>
+                </a:solidFill>
+                <a:latin typeface="Helvetica Neue"/>
+              </a:defRPr>
+            </a:pPr>
+            <a:r>
+              <a:t>16</a:t>
+            </a:r>
+          </a:p>
+        </p:txBody>
+      </p:sp>
+    </p:spTree>
+  </p:cSld>
+  <p:clrMapOvr>
+    <a:masterClrMapping/>
+  </p:clrMapOvr>
+</p:sld>
+</file>
+
+<file path=ppt/slides/slide17.xml><?xml version="1.0" encoding="utf-8"?>
+<p:sld xmlns:a="http://schemas.openxmlformats.org/drawingml/2006/main" xmlns:p="http://schemas.openxmlformats.org/presentationml/2006/main" xmlns:r="http://schemas.openxmlformats.org/officeDocument/2006/relationships">
+  <p:cSld>
+    <p:spTree>
+      <p:nvGrpSpPr>
+        <p:cNvPr id="1" name=""/>
+        <p:cNvGrpSpPr/>
+        <p:nvPr/>
+      </p:nvGrpSpPr>
+      <p:grpSpPr/>
+      <p:sp>
+        <p:nvSpPr>
+          <p:cNvPr id="2" name="Rectangle 1"/>
+          <p:cNvSpPr/>
+          <p:nvPr/>
+        </p:nvSpPr>
+        <p:spPr>
+          <a:xfrm>
+            <a:off x="0" y="0"/>
+            <a:ext cx="12191695" cy="6858000"/>
+          </a:xfrm>
+          <a:prstGeom prst="rect">
+            <a:avLst/>
+          </a:prstGeom>
+          <a:solidFill>
+            <a:srgbClr val="2A78D6"/>
+          </a:solidFill>
+          <a:ln>
+            <a:noFill/>
+          </a:ln>
+          <a:effectLst/>
+        </p:spPr>
+        <p:style>
+          <a:lnRef idx="1">
+            <a:schemeClr val="accent1"/>
+          </a:lnRef>
+          <a:fillRef idx="3">
+            <a:schemeClr val="accent1"/>
+          </a:fillRef>
+          <a:effectRef idx="2">
+            <a:schemeClr val="accent1"/>
+          </a:effectRef>
+          <a:fontRef idx="minor">
+            <a:schemeClr val="lt1"/>
+          </a:fontRef>
+        </p:style>
+        <p:txBody>
+          <a:bodyPr rtlCol="0" anchor="ctr"/>
+          <a:lstStyle/>
+          <a:p>
+            <a:pPr algn="ctr"/>
+          </a:p>
+        </p:txBody>
+      </p:sp>
+      <p:sp>
+        <p:nvSpPr>
+          <p:cNvPr id="3" name="TextBox 2"/>
+          <p:cNvSpPr txBox="1"/>
+          <p:nvPr/>
+        </p:nvSpPr>
+        <p:spPr>
+          <a:xfrm>
+            <a:off x="640080" y="2011680"/>
+            <a:ext cx="2286000" cy="1280160"/>
+          </a:xfrm>
+          <a:prstGeom prst="rect">
+            <a:avLst/>
+          </a:prstGeom>
+          <a:noFill/>
+        </p:spPr>
+        <p:txBody>
+          <a:bodyPr wrap="square">
+            <a:spAutoFit/>
+          </a:bodyPr>
+          <a:lstStyle/>
+          <a:p>
+            <a:pPr>
+              <a:defRPr sz="8000" b="1">
+                <a:solidFill>
+                  <a:srgbClr val="EDA100"/>
+                </a:solidFill>
+                <a:latin typeface="Helvetica Neue"/>
+              </a:defRPr>
+            </a:pPr>
+            <a:r>
+              <a:t>08</a:t>
+            </a:r>
+          </a:p>
+        </p:txBody>
+      </p:sp>
+      <p:sp>
+        <p:nvSpPr>
+          <p:cNvPr id="4" name="TextBox 3"/>
+          <p:cNvSpPr txBox="1"/>
+          <p:nvPr/>
+        </p:nvSpPr>
+        <p:spPr>
+          <a:xfrm>
+            <a:off x="640080" y="3200400"/>
+            <a:ext cx="10911535" cy="1188720"/>
+          </a:xfrm>
+          <a:prstGeom prst="rect">
+            <a:avLst/>
+          </a:prstGeom>
+          <a:noFill/>
+        </p:spPr>
+        <p:txBody>
+          <a:bodyPr wrap="square">
+            <a:spAutoFit/>
+          </a:bodyPr>
+          <a:lstStyle/>
+          <a:p>
+            <a:pPr>
+              <a:defRPr sz="4000" b="1">
+                <a:solidFill>
+                  <a:srgbClr val="FFFFFF"/>
+                </a:solidFill>
+                <a:latin typeface="Helvetica Neue"/>
+              </a:defRPr>
+            </a:pPr>
+            <a:r>
+              <a:t>Challenges Faced</a:t>
+            </a:r>
+          </a:p>
+        </p:txBody>
+      </p:sp>
+      <p:sp>
+        <p:nvSpPr>
+          <p:cNvPr id="5" name="Rectangle 4"/>
+          <p:cNvSpPr/>
+          <p:nvPr/>
+        </p:nvSpPr>
+        <p:spPr>
+          <a:xfrm>
+            <a:off x="0" y="6803136"/>
+            <a:ext cx="12191695" cy="54864"/>
+          </a:xfrm>
+          <a:prstGeom prst="rect">
+            <a:avLst/>
+          </a:prstGeom>
+          <a:solidFill>
+            <a:srgbClr val="EDA100"/>
+          </a:solidFill>
+          <a:ln>
+            <a:noFill/>
+          </a:ln>
+          <a:effectLst/>
+        </p:spPr>
+        <p:style>
+          <a:lnRef idx="1">
+            <a:schemeClr val="accent1"/>
+          </a:lnRef>
+          <a:fillRef idx="3">
+            <a:schemeClr val="accent1"/>
+          </a:fillRef>
+          <a:effectRef idx="2">
+            <a:schemeClr val="accent1"/>
+          </a:effectRef>
+          <a:fontRef idx="minor">
+            <a:schemeClr val="lt1"/>
+          </a:fontRef>
+        </p:style>
+        <p:txBody>
+          <a:bodyPr rtlCol="0" anchor="ctr"/>
+          <a:lstStyle/>
+          <a:p>
+            <a:pPr algn="ctr"/>
+          </a:p>
+        </p:txBody>
+      </p:sp>
+      <p:sp>
+        <p:nvSpPr>
+          <p:cNvPr id="6" name="TextBox 5"/>
+          <p:cNvSpPr txBox="1"/>
+          <p:nvPr/>
+        </p:nvSpPr>
+        <p:spPr>
+          <a:xfrm>
+            <a:off x="640080" y="6473952"/>
+            <a:ext cx="7315200" cy="274320"/>
+          </a:xfrm>
+          <a:prstGeom prst="rect">
+            <a:avLst/>
+          </a:prstGeom>
+          <a:noFill/>
+        </p:spPr>
+        <p:txBody>
+          <a:bodyPr wrap="square">
+            <a:spAutoFit/>
+          </a:bodyPr>
+          <a:lstStyle/>
+          <a:p>
+            <a:pPr>
+              <a:defRPr sz="1000" b="0">
+                <a:solidFill>
+                  <a:srgbClr val="52514E"/>
+                </a:solidFill>
+                <a:latin typeface="Helvetica Neue"/>
+              </a:defRPr>
+            </a:pPr>
+            <a:r>
+              <a:t>Evermon — Averis × Monash Hackathon 2026</a:t>
+            </a:r>
+          </a:p>
+        </p:txBody>
+      </p:sp>
+      <p:sp>
+        <p:nvSpPr>
+          <p:cNvPr id="7" name="TextBox 6"/>
+          <p:cNvSpPr txBox="1"/>
+          <p:nvPr/>
+        </p:nvSpPr>
+        <p:spPr>
+          <a:xfrm>
+            <a:off x="11277295" y="6473952"/>
+            <a:ext cx="548640" cy="274320"/>
+          </a:xfrm>
+          <a:prstGeom prst="rect">
+            <a:avLst/>
+          </a:prstGeom>
+          <a:noFill/>
+        </p:spPr>
+        <p:txBody>
+          <a:bodyPr wrap="square">
+            <a:spAutoFit/>
+          </a:bodyPr>
+          <a:lstStyle/>
+          <a:p>
+            <a:pPr algn="r">
+              <a:defRPr sz="1000" b="1">
+                <a:solidFill>
+                  <a:srgbClr val="2A78D6"/>
+                </a:solidFill>
+                <a:latin typeface="Helvetica Neue"/>
+              </a:defRPr>
+            </a:pPr>
+            <a:r>
+              <a:t>17</a:t>
+            </a:r>
+          </a:p>
+        </p:txBody>
+      </p:sp>
+    </p:spTree>
+  </p:cSld>
+  <p:clrMapOvr>
+    <a:masterClrMapping/>
+  </p:clrMapOvr>
+</p:sld>
+</file>
+
+<file path=ppt/slides/slide18.xml><?xml version="1.0" encoding="utf-8"?>
+<p:sld xmlns:a="http://schemas.openxmlformats.org/drawingml/2006/main" xmlns:p="http://schemas.openxmlformats.org/presentationml/2006/main" xmlns:r="http://schemas.openxmlformats.org/officeDocument/2006/relationships">
+  <p:cSld>
+    <p:spTree>
+      <p:nvGrpSpPr>
+        <p:cNvPr id="1" name=""/>
+        <p:cNvGrpSpPr/>
+        <p:nvPr/>
+      </p:nvGrpSpPr>
+      <p:grpSpPr/>
+      <p:sp>
+        <p:nvSpPr>
+          <p:cNvPr id="2" name="Rectangle 1"/>
+          <p:cNvSpPr/>
+          <p:nvPr/>
+        </p:nvSpPr>
+        <p:spPr>
+          <a:xfrm>
+            <a:off x="0" y="0"/>
+            <a:ext cx="12191695" cy="1188720"/>
+          </a:xfrm>
+          <a:prstGeom prst="rect">
+            <a:avLst/>
+          </a:prstGeom>
+          <a:solidFill>
+            <a:srgbClr val="2A78D6"/>
+          </a:solidFill>
+          <a:ln>
+            <a:noFill/>
+          </a:ln>
+          <a:effectLst/>
+        </p:spPr>
+        <p:style>
+          <a:lnRef idx="1">
+            <a:schemeClr val="accent1"/>
+          </a:lnRef>
+          <a:fillRef idx="3">
+            <a:schemeClr val="accent1"/>
+          </a:fillRef>
+          <a:effectRef idx="2">
+            <a:schemeClr val="accent1"/>
+          </a:effectRef>
+          <a:fontRef idx="minor">
+            <a:schemeClr val="lt1"/>
+          </a:fontRef>
+        </p:style>
+        <p:txBody>
+          <a:bodyPr rtlCol="0" anchor="ctr"/>
+          <a:lstStyle/>
+          <a:p>
+            <a:pPr algn="ctr"/>
+          </a:p>
+        </p:txBody>
+      </p:sp>
+      <p:sp>
+        <p:nvSpPr>
+          <p:cNvPr id="3" name="TextBox 2"/>
+          <p:cNvSpPr txBox="1"/>
+          <p:nvPr/>
+        </p:nvSpPr>
+        <p:spPr>
+          <a:xfrm>
+            <a:off x="640080" y="274320"/>
+            <a:ext cx="10911535" cy="731520"/>
+          </a:xfrm>
+          <a:prstGeom prst="rect">
+            <a:avLst/>
+          </a:prstGeom>
+          <a:noFill/>
+        </p:spPr>
+        <p:txBody>
+          <a:bodyPr wrap="square">
+            <a:spAutoFit/>
+          </a:bodyPr>
+          <a:lstStyle/>
+          <a:p>
+            <a:pPr>
+              <a:defRPr sz="2800" b="1">
+                <a:solidFill>
+                  <a:srgbClr val="FFFFFF"/>
+                </a:solidFill>
+                <a:latin typeface="Helvetica Neue"/>
+              </a:defRPr>
+            </a:pPr>
+            <a:r>
+              <a:t>Two scoring incidents, one operational</a:t>
+            </a:r>
+          </a:p>
+        </p:txBody>
+      </p:sp>
+      <p:sp>
+        <p:nvSpPr>
+          <p:cNvPr id="4" name="TextBox 3"/>
+          <p:cNvSpPr txBox="1"/>
+          <p:nvPr/>
+        </p:nvSpPr>
+        <p:spPr>
+          <a:xfrm>
+            <a:off x="640080" y="1554480"/>
+            <a:ext cx="10911535" cy="4572000"/>
+          </a:xfrm>
+          <a:prstGeom prst="rect">
+            <a:avLst/>
+          </a:prstGeom>
+          <a:noFill/>
+        </p:spPr>
+        <p:txBody>
+          <a:bodyPr wrap="square">
+            <a:spAutoFit/>
+          </a:bodyPr>
+          <a:lstStyle/>
+          <a:p>
+            <a:pPr>
+              <a:spcAft>
+                <a:spcPts val="1600"/>
+              </a:spcAft>
+              <a:defRPr sz="1800" b="0">
+                <a:solidFill>
+                  <a:srgbClr val="0B0B0B"/>
+                </a:solidFill>
+                <a:latin typeface="Helvetica Neue"/>
+              </a:defRPr>
+            </a:pPr>
+            <a:r>
+              <a:t>▸  91 "please send the BL" emails were first misclassified GENERAL — the scoreboard caught it.</a:t>
+            </a:r>
+          </a:p>
+          <a:p>
+            <a:pPr>
+              <a:spcAft>
+                <a:spcPts val="1600"/>
+              </a:spcAft>
+              <a:defRPr sz="1800" b="0">
+                <a:solidFill>
+                  <a:srgbClr val="0B0B0B"/>
+                </a:solidFill>
+                <a:latin typeface="Helvetica Neue"/>
+              </a:defRPr>
+            </a:pPr>
+            <a:r>
+              <a:t>▸  That fix alone spiked false escalations 20 -&gt; 111, fixed with a narrower rule.</a:t>
+            </a:r>
+          </a:p>
+          <a:p>
+            <a:pPr>
+              <a:spcAft>
+                <a:spcPts val="1600"/>
+              </a:spcAft>
+              <a:defRPr sz="1800" b="0">
+                <a:solidFill>
+                  <a:srgbClr val="0B0B0B"/>
+                </a:solidFill>
+                <a:latin typeface="Helvetica Neue"/>
+              </a:defRPr>
+            </a:pPr>
+            <a:r>
+              <a:t>▸  A stray background daemon raced a live correction during testing — an operational gap.</a:t>
+            </a:r>
+          </a:p>
+        </p:txBody>
+      </p:sp>
+      <p:sp>
+        <p:nvSpPr>
+          <p:cNvPr id="5" name="Rectangle 4"/>
+          <p:cNvSpPr/>
+          <p:nvPr/>
+        </p:nvSpPr>
+        <p:spPr>
+          <a:xfrm>
+            <a:off x="0" y="6803136"/>
+            <a:ext cx="12191695" cy="54864"/>
+          </a:xfrm>
+          <a:prstGeom prst="rect">
+            <a:avLst/>
+          </a:prstGeom>
+          <a:solidFill>
+            <a:srgbClr val="EDA100"/>
+          </a:solidFill>
+          <a:ln>
+            <a:noFill/>
+          </a:ln>
+          <a:effectLst/>
+        </p:spPr>
+        <p:style>
+          <a:lnRef idx="1">
+            <a:schemeClr val="accent1"/>
+          </a:lnRef>
+          <a:fillRef idx="3">
+            <a:schemeClr val="accent1"/>
+          </a:fillRef>
+          <a:effectRef idx="2">
+            <a:schemeClr val="accent1"/>
+          </a:effectRef>
+          <a:fontRef idx="minor">
+            <a:schemeClr val="lt1"/>
+          </a:fontRef>
+        </p:style>
+        <p:txBody>
+          <a:bodyPr rtlCol="0" anchor="ctr"/>
+          <a:lstStyle/>
+          <a:p>
+            <a:pPr algn="ctr"/>
+          </a:p>
+        </p:txBody>
+      </p:sp>
+      <p:sp>
+        <p:nvSpPr>
+          <p:cNvPr id="6" name="TextBox 5"/>
+          <p:cNvSpPr txBox="1"/>
+          <p:nvPr/>
+        </p:nvSpPr>
+        <p:spPr>
+          <a:xfrm>
+            <a:off x="640080" y="6473952"/>
+            <a:ext cx="7315200" cy="274320"/>
+          </a:xfrm>
+          <a:prstGeom prst="rect">
+            <a:avLst/>
+          </a:prstGeom>
+          <a:noFill/>
+        </p:spPr>
+        <p:txBody>
+          <a:bodyPr wrap="square">
+            <a:spAutoFit/>
+          </a:bodyPr>
+          <a:lstStyle/>
+          <a:p>
+            <a:pPr>
+              <a:defRPr sz="1000" b="0">
+                <a:solidFill>
+                  <a:srgbClr val="52514E"/>
+                </a:solidFill>
+                <a:latin typeface="Helvetica Neue"/>
+              </a:defRPr>
+            </a:pPr>
+            <a:r>
+              <a:t>Evermon — Averis × Monash Hackathon 2026</a:t>
+            </a:r>
+          </a:p>
+        </p:txBody>
+      </p:sp>
+      <p:sp>
+        <p:nvSpPr>
+          <p:cNvPr id="7" name="TextBox 6"/>
+          <p:cNvSpPr txBox="1"/>
+          <p:nvPr/>
+        </p:nvSpPr>
+        <p:spPr>
+          <a:xfrm>
+            <a:off x="11277295" y="6473952"/>
+            <a:ext cx="548640" cy="274320"/>
+          </a:xfrm>
+          <a:prstGeom prst="rect">
+            <a:avLst/>
+          </a:prstGeom>
+          <a:noFill/>
+        </p:spPr>
+        <p:txBody>
+          <a:bodyPr wrap="square">
+            <a:spAutoFit/>
+          </a:bodyPr>
+          <a:lstStyle/>
+          <a:p>
+            <a:pPr algn="r">
+              <a:defRPr sz="1000" b="1">
+                <a:solidFill>
+                  <a:srgbClr val="2A78D6"/>
+                </a:solidFill>
+                <a:latin typeface="Helvetica Neue"/>
+              </a:defRPr>
+            </a:pPr>
+            <a:r>
+              <a:t>18</a:t>
+            </a:r>
+          </a:p>
+        </p:txBody>
+      </p:sp>
+    </p:spTree>
+  </p:cSld>
+  <p:clrMapOvr>
+    <a:masterClrMapping/>
+  </p:clrMapOvr>
+</p:sld>
+</file>
+
+<file path=ppt/slides/slide19.xml><?xml version="1.0" encoding="utf-8"?>
+<p:sld xmlns:a="http://schemas.openxmlformats.org/drawingml/2006/main" xmlns:p="http://schemas.openxmlformats.org/presentationml/2006/main" xmlns:r="http://schemas.openxmlformats.org/officeDocument/2006/relationships">
+  <p:cSld>
+    <p:spTree>
+      <p:nvGrpSpPr>
+        <p:cNvPr id="1" name=""/>
+        <p:cNvGrpSpPr/>
+        <p:nvPr/>
+      </p:nvGrpSpPr>
+      <p:grpSpPr/>
+      <p:sp>
+        <p:nvSpPr>
+          <p:cNvPr id="2" name="Rectangle 1"/>
+          <p:cNvSpPr/>
+          <p:nvPr/>
+        </p:nvSpPr>
+        <p:spPr>
+          <a:xfrm>
+            <a:off x="0" y="0"/>
+            <a:ext cx="12191695" cy="6858000"/>
+          </a:xfrm>
+          <a:prstGeom prst="rect">
+            <a:avLst/>
+          </a:prstGeom>
+          <a:solidFill>
+            <a:srgbClr val="2A78D6"/>
+          </a:solidFill>
+          <a:ln>
+            <a:noFill/>
+          </a:ln>
+          <a:effectLst/>
+        </p:spPr>
+        <p:style>
+          <a:lnRef idx="1">
+            <a:schemeClr val="accent1"/>
+          </a:lnRef>
+          <a:fillRef idx="3">
+            <a:schemeClr val="accent1"/>
+          </a:fillRef>
+          <a:effectRef idx="2">
+            <a:schemeClr val="accent1"/>
+          </a:effectRef>
+          <a:fontRef idx="minor">
+            <a:schemeClr val="lt1"/>
+          </a:fontRef>
+        </p:style>
+        <p:txBody>
+          <a:bodyPr rtlCol="0" anchor="ctr"/>
+          <a:lstStyle/>
+          <a:p>
+            <a:pPr algn="ctr"/>
+          </a:p>
+        </p:txBody>
+      </p:sp>
+      <p:sp>
+        <p:nvSpPr>
+          <p:cNvPr id="3" name="TextBox 2"/>
+          <p:cNvSpPr txBox="1"/>
+          <p:nvPr/>
+        </p:nvSpPr>
+        <p:spPr>
+          <a:xfrm>
+            <a:off x="640080" y="2011680"/>
+            <a:ext cx="2286000" cy="1280160"/>
+          </a:xfrm>
+          <a:prstGeom prst="rect">
+            <a:avLst/>
+          </a:prstGeom>
+          <a:noFill/>
+        </p:spPr>
+        <p:txBody>
+          <a:bodyPr wrap="square">
+            <a:spAutoFit/>
+          </a:bodyPr>
+          <a:lstStyle/>
+          <a:p>
+            <a:pPr>
+              <a:defRPr sz="8000" b="1">
+                <a:solidFill>
+                  <a:srgbClr val="EDA100"/>
+                </a:solidFill>
+                <a:latin typeface="Helvetica Neue"/>
+              </a:defRPr>
+            </a:pPr>
+            <a:r>
+              <a:t>09</a:t>
+            </a:r>
+          </a:p>
+        </p:txBody>
+      </p:sp>
+      <p:sp>
+        <p:nvSpPr>
+          <p:cNvPr id="4" name="TextBox 3"/>
+          <p:cNvSpPr txBox="1"/>
+          <p:nvPr/>
+        </p:nvSpPr>
+        <p:spPr>
+          <a:xfrm>
+            <a:off x="640080" y="3200400"/>
+            <a:ext cx="10911535" cy="1188720"/>
+          </a:xfrm>
+          <a:prstGeom prst="rect">
+            <a:avLst/>
+          </a:prstGeom>
+          <a:noFill/>
+        </p:spPr>
+        <p:txBody>
+          <a:bodyPr wrap="square">
+            <a:spAutoFit/>
+          </a:bodyPr>
+          <a:lstStyle/>
+          <a:p>
+            <a:pPr>
+              <a:defRPr sz="4000" b="1">
+                <a:solidFill>
+                  <a:srgbClr val="FFFFFF"/>
+                </a:solidFill>
+                <a:latin typeface="Helvetica Neue"/>
+              </a:defRPr>
+            </a:pPr>
+            <a:r>
+              <a:t>Future Roadmap</a:t>
+            </a:r>
+          </a:p>
+        </p:txBody>
+      </p:sp>
+      <p:sp>
+        <p:nvSpPr>
+          <p:cNvPr id="5" name="Rectangle 4"/>
+          <p:cNvSpPr/>
+          <p:nvPr/>
+        </p:nvSpPr>
+        <p:spPr>
+          <a:xfrm>
+            <a:off x="0" y="6803136"/>
+            <a:ext cx="12191695" cy="54864"/>
+          </a:xfrm>
+          <a:prstGeom prst="rect">
+            <a:avLst/>
+          </a:prstGeom>
+          <a:solidFill>
+            <a:srgbClr val="EDA100"/>
+          </a:solidFill>
+          <a:ln>
+            <a:noFill/>
+          </a:ln>
+          <a:effectLst/>
+        </p:spPr>
+        <p:style>
+          <a:lnRef idx="1">
+            <a:schemeClr val="accent1"/>
+          </a:lnRef>
+          <a:fillRef idx="3">
+            <a:schemeClr val="accent1"/>
+          </a:fillRef>
+          <a:effectRef idx="2">
+            <a:schemeClr val="accent1"/>
+          </a:effectRef>
+          <a:fontRef idx="minor">
+            <a:schemeClr val="lt1"/>
+          </a:fontRef>
+        </p:style>
+        <p:txBody>
+          <a:bodyPr rtlCol="0" anchor="ctr"/>
+          <a:lstStyle/>
+          <a:p>
+            <a:pPr algn="ctr"/>
+          </a:p>
+        </p:txBody>
+      </p:sp>
+      <p:sp>
+        <p:nvSpPr>
+          <p:cNvPr id="6" name="TextBox 5"/>
+          <p:cNvSpPr txBox="1"/>
+          <p:nvPr/>
+        </p:nvSpPr>
+        <p:spPr>
+          <a:xfrm>
+            <a:off x="640080" y="6473952"/>
+            <a:ext cx="7315200" cy="274320"/>
+          </a:xfrm>
+          <a:prstGeom prst="rect">
+            <a:avLst/>
+          </a:prstGeom>
+          <a:noFill/>
+        </p:spPr>
+        <p:txBody>
+          <a:bodyPr wrap="square">
+            <a:spAutoFit/>
+          </a:bodyPr>
+          <a:lstStyle/>
+          <a:p>
+            <a:pPr>
+              <a:defRPr sz="1000" b="0">
+                <a:solidFill>
+                  <a:srgbClr val="52514E"/>
+                </a:solidFill>
+                <a:latin typeface="Helvetica Neue"/>
+              </a:defRPr>
+            </a:pPr>
+            <a:r>
+              <a:t>Evermon — Averis × Monash Hackathon 2026</a:t>
+            </a:r>
+          </a:p>
+        </p:txBody>
+      </p:sp>
+      <p:sp>
+        <p:nvSpPr>
+          <p:cNvPr id="7" name="TextBox 6"/>
+          <p:cNvSpPr txBox="1"/>
+          <p:nvPr/>
+        </p:nvSpPr>
+        <p:spPr>
+          <a:xfrm>
+            <a:off x="11277295" y="6473952"/>
+            <a:ext cx="548640" cy="274320"/>
+          </a:xfrm>
+          <a:prstGeom prst="rect">
+            <a:avLst/>
+          </a:prstGeom>
+          <a:noFill/>
+        </p:spPr>
+        <p:txBody>
+          <a:bodyPr wrap="square">
+            <a:spAutoFit/>
+          </a:bodyPr>
+          <a:lstStyle/>
+          <a:p>
+            <a:pPr algn="r">
+              <a:defRPr sz="1000" b="1">
+                <a:solidFill>
+                  <a:srgbClr val="2A78D6"/>
+                </a:solidFill>
+                <a:latin typeface="Helvetica Neue"/>
+              </a:defRPr>
+            </a:pPr>
+            <a:r>
+              <a:t>19</a:t>
             </a:r>
           </a:p>
         </p:txBody>
@@ -4952,6 +6486,636 @@
             </a:pPr>
             <a:r>
               <a:t>2</a:t>
+            </a:r>
+          </a:p>
+        </p:txBody>
+      </p:sp>
+    </p:spTree>
+  </p:cSld>
+  <p:clrMapOvr>
+    <a:masterClrMapping/>
+  </p:clrMapOvr>
+</p:sld>
+</file>
+
+<file path=ppt/slides/slide20.xml><?xml version="1.0" encoding="utf-8"?>
+<p:sld xmlns:a="http://schemas.openxmlformats.org/drawingml/2006/main" xmlns:p="http://schemas.openxmlformats.org/presentationml/2006/main" xmlns:r="http://schemas.openxmlformats.org/officeDocument/2006/relationships">
+  <p:cSld>
+    <p:spTree>
+      <p:nvGrpSpPr>
+        <p:cNvPr id="1" name=""/>
+        <p:cNvGrpSpPr/>
+        <p:nvPr/>
+      </p:nvGrpSpPr>
+      <p:grpSpPr/>
+      <p:sp>
+        <p:nvSpPr>
+          <p:cNvPr id="2" name="Rectangle 1"/>
+          <p:cNvSpPr/>
+          <p:nvPr/>
+        </p:nvSpPr>
+        <p:spPr>
+          <a:xfrm>
+            <a:off x="0" y="0"/>
+            <a:ext cx="12191695" cy="1188720"/>
+          </a:xfrm>
+          <a:prstGeom prst="rect">
+            <a:avLst/>
+          </a:prstGeom>
+          <a:solidFill>
+            <a:srgbClr val="2A78D6"/>
+          </a:solidFill>
+          <a:ln>
+            <a:noFill/>
+          </a:ln>
+          <a:effectLst/>
+        </p:spPr>
+        <p:style>
+          <a:lnRef idx="1">
+            <a:schemeClr val="accent1"/>
+          </a:lnRef>
+          <a:fillRef idx="3">
+            <a:schemeClr val="accent1"/>
+          </a:fillRef>
+          <a:effectRef idx="2">
+            <a:schemeClr val="accent1"/>
+          </a:effectRef>
+          <a:fontRef idx="minor">
+            <a:schemeClr val="lt1"/>
+          </a:fontRef>
+        </p:style>
+        <p:txBody>
+          <a:bodyPr rtlCol="0" anchor="ctr"/>
+          <a:lstStyle/>
+          <a:p>
+            <a:pPr algn="ctr"/>
+          </a:p>
+        </p:txBody>
+      </p:sp>
+      <p:sp>
+        <p:nvSpPr>
+          <p:cNvPr id="3" name="TextBox 2"/>
+          <p:cNvSpPr txBox="1"/>
+          <p:nvPr/>
+        </p:nvSpPr>
+        <p:spPr>
+          <a:xfrm>
+            <a:off x="640080" y="274320"/>
+            <a:ext cx="10911535" cy="731520"/>
+          </a:xfrm>
+          <a:prstGeom prst="rect">
+            <a:avLst/>
+          </a:prstGeom>
+          <a:noFill/>
+        </p:spPr>
+        <p:txBody>
+          <a:bodyPr wrap="square">
+            <a:spAutoFit/>
+          </a:bodyPr>
+          <a:lstStyle/>
+          <a:p>
+            <a:pPr>
+              <a:defRPr sz="2800" b="1">
+                <a:solidFill>
+                  <a:srgbClr val="FFFFFF"/>
+                </a:solidFill>
+                <a:latin typeface="Helvetica Neue"/>
+              </a:defRPr>
+            </a:pPr>
+            <a:r>
+              <a:t>What's next, and what's deliberately not built yet</a:t>
+            </a:r>
+          </a:p>
+        </p:txBody>
+      </p:sp>
+      <p:sp>
+        <p:nvSpPr>
+          <p:cNvPr id="4" name="TextBox 3"/>
+          <p:cNvSpPr txBox="1"/>
+          <p:nvPr/>
+        </p:nvSpPr>
+        <p:spPr>
+          <a:xfrm>
+            <a:off x="640080" y="1554480"/>
+            <a:ext cx="10911535" cy="4572000"/>
+          </a:xfrm>
+          <a:prstGeom prst="rect">
+            <a:avLst/>
+          </a:prstGeom>
+          <a:noFill/>
+        </p:spPr>
+        <p:txBody>
+          <a:bodyPr wrap="square">
+            <a:spAutoFit/>
+          </a:bodyPr>
+          <a:lstStyle/>
+          <a:p>
+            <a:pPr>
+              <a:spcAft>
+                <a:spcPts val="1600"/>
+              </a:spcAft>
+              <a:defRPr sz="1800" b="0">
+                <a:solidFill>
+                  <a:srgbClr val="0B0B0B"/>
+                </a:solidFill>
+                <a:latin typeface="Helvetica Neue"/>
+              </a:defRPr>
+            </a:pPr>
+            <a:r>
+              <a:t>▸  An audited OCR/vision fallback for scanned PDFs, with a stated confidence and escalation on doubt.</a:t>
+            </a:r>
+          </a:p>
+          <a:p>
+            <a:pPr>
+              <a:spcAft>
+                <a:spcPts val="1600"/>
+              </a:spcAft>
+              <a:defRPr sz="1800" b="0">
+                <a:solidFill>
+                  <a:srgbClr val="0B0B0B"/>
+                </a:solidFill>
+                <a:latin typeface="Helvetica Neue"/>
+              </a:defRPr>
+            </a:pPr>
+            <a:r>
+              <a:t>▸  Push-based escalation (webhook/notification) instead of a file a person has to poll.</a:t>
+            </a:r>
+          </a:p>
+          <a:p>
+            <a:pPr>
+              <a:spcAft>
+                <a:spcPts val="1600"/>
+              </a:spcAft>
+              <a:defRPr sz="1800" b="0">
+                <a:solidFill>
+                  <a:srgbClr val="0B0B0B"/>
+                </a:solidFill>
+                <a:latin typeface="Helvetica Neue"/>
+              </a:defRPr>
+            </a:pPr>
+            <a:r>
+              <a:t>▸  A single-instance lock for the watcher daemon; exercising the untested Docker/HTTP loader path.</a:t>
+            </a:r>
+          </a:p>
+        </p:txBody>
+      </p:sp>
+      <p:sp>
+        <p:nvSpPr>
+          <p:cNvPr id="5" name="Rectangle 4"/>
+          <p:cNvSpPr/>
+          <p:nvPr/>
+        </p:nvSpPr>
+        <p:spPr>
+          <a:xfrm>
+            <a:off x="0" y="6803136"/>
+            <a:ext cx="12191695" cy="54864"/>
+          </a:xfrm>
+          <a:prstGeom prst="rect">
+            <a:avLst/>
+          </a:prstGeom>
+          <a:solidFill>
+            <a:srgbClr val="EDA100"/>
+          </a:solidFill>
+          <a:ln>
+            <a:noFill/>
+          </a:ln>
+          <a:effectLst/>
+        </p:spPr>
+        <p:style>
+          <a:lnRef idx="1">
+            <a:schemeClr val="accent1"/>
+          </a:lnRef>
+          <a:fillRef idx="3">
+            <a:schemeClr val="accent1"/>
+          </a:fillRef>
+          <a:effectRef idx="2">
+            <a:schemeClr val="accent1"/>
+          </a:effectRef>
+          <a:fontRef idx="minor">
+            <a:schemeClr val="lt1"/>
+          </a:fontRef>
+        </p:style>
+        <p:txBody>
+          <a:bodyPr rtlCol="0" anchor="ctr"/>
+          <a:lstStyle/>
+          <a:p>
+            <a:pPr algn="ctr"/>
+          </a:p>
+        </p:txBody>
+      </p:sp>
+      <p:sp>
+        <p:nvSpPr>
+          <p:cNvPr id="6" name="TextBox 5"/>
+          <p:cNvSpPr txBox="1"/>
+          <p:nvPr/>
+        </p:nvSpPr>
+        <p:spPr>
+          <a:xfrm>
+            <a:off x="640080" y="6473952"/>
+            <a:ext cx="7315200" cy="274320"/>
+          </a:xfrm>
+          <a:prstGeom prst="rect">
+            <a:avLst/>
+          </a:prstGeom>
+          <a:noFill/>
+        </p:spPr>
+        <p:txBody>
+          <a:bodyPr wrap="square">
+            <a:spAutoFit/>
+          </a:bodyPr>
+          <a:lstStyle/>
+          <a:p>
+            <a:pPr>
+              <a:defRPr sz="1000" b="0">
+                <a:solidFill>
+                  <a:srgbClr val="52514E"/>
+                </a:solidFill>
+                <a:latin typeface="Helvetica Neue"/>
+              </a:defRPr>
+            </a:pPr>
+            <a:r>
+              <a:t>Evermon — Averis × Monash Hackathon 2026</a:t>
+            </a:r>
+          </a:p>
+        </p:txBody>
+      </p:sp>
+      <p:sp>
+        <p:nvSpPr>
+          <p:cNvPr id="7" name="TextBox 6"/>
+          <p:cNvSpPr txBox="1"/>
+          <p:nvPr/>
+        </p:nvSpPr>
+        <p:spPr>
+          <a:xfrm>
+            <a:off x="11277295" y="6473952"/>
+            <a:ext cx="548640" cy="274320"/>
+          </a:xfrm>
+          <a:prstGeom prst="rect">
+            <a:avLst/>
+          </a:prstGeom>
+          <a:noFill/>
+        </p:spPr>
+        <p:txBody>
+          <a:bodyPr wrap="square">
+            <a:spAutoFit/>
+          </a:bodyPr>
+          <a:lstStyle/>
+          <a:p>
+            <a:pPr algn="r">
+              <a:defRPr sz="1000" b="1">
+                <a:solidFill>
+                  <a:srgbClr val="2A78D6"/>
+                </a:solidFill>
+                <a:latin typeface="Helvetica Neue"/>
+              </a:defRPr>
+            </a:pPr>
+            <a:r>
+              <a:t>20</a:t>
+            </a:r>
+          </a:p>
+        </p:txBody>
+      </p:sp>
+    </p:spTree>
+  </p:cSld>
+  <p:clrMapOvr>
+    <a:masterClrMapping/>
+  </p:clrMapOvr>
+</p:sld>
+</file>
+
+<file path=ppt/slides/slide21.xml><?xml version="1.0" encoding="utf-8"?>
+<p:sld xmlns:a="http://schemas.openxmlformats.org/drawingml/2006/main" xmlns:p="http://schemas.openxmlformats.org/presentationml/2006/main" xmlns:r="http://schemas.openxmlformats.org/officeDocument/2006/relationships">
+  <p:cSld>
+    <p:spTree>
+      <p:nvGrpSpPr>
+        <p:cNvPr id="1" name=""/>
+        <p:cNvGrpSpPr/>
+        <p:nvPr/>
+      </p:nvGrpSpPr>
+      <p:grpSpPr/>
+      <p:sp>
+        <p:nvSpPr>
+          <p:cNvPr id="2" name="Rectangle 1"/>
+          <p:cNvSpPr/>
+          <p:nvPr/>
+        </p:nvSpPr>
+        <p:spPr>
+          <a:xfrm>
+            <a:off x="0" y="0"/>
+            <a:ext cx="12191695" cy="6858000"/>
+          </a:xfrm>
+          <a:prstGeom prst="rect">
+            <a:avLst/>
+          </a:prstGeom>
+          <a:solidFill>
+            <a:srgbClr val="0D1B2A"/>
+          </a:solidFill>
+          <a:ln>
+            <a:noFill/>
+          </a:ln>
+          <a:effectLst/>
+        </p:spPr>
+        <p:style>
+          <a:lnRef idx="1">
+            <a:schemeClr val="accent1"/>
+          </a:lnRef>
+          <a:fillRef idx="3">
+            <a:schemeClr val="accent1"/>
+          </a:fillRef>
+          <a:effectRef idx="2">
+            <a:schemeClr val="accent1"/>
+          </a:effectRef>
+          <a:fontRef idx="minor">
+            <a:schemeClr val="lt1"/>
+          </a:fontRef>
+        </p:style>
+        <p:txBody>
+          <a:bodyPr rtlCol="0" anchor="ctr"/>
+          <a:lstStyle/>
+          <a:p>
+            <a:pPr algn="ctr"/>
+          </a:p>
+        </p:txBody>
+      </p:sp>
+      <p:sp>
+        <p:nvSpPr>
+          <p:cNvPr id="3" name="Rectangle 2"/>
+          <p:cNvSpPr/>
+          <p:nvPr/>
+        </p:nvSpPr>
+        <p:spPr>
+          <a:xfrm>
+            <a:off x="0" y="0"/>
+            <a:ext cx="12191695" cy="109728"/>
+          </a:xfrm>
+          <a:prstGeom prst="rect">
+            <a:avLst/>
+          </a:prstGeom>
+          <a:solidFill>
+            <a:srgbClr val="EDA100"/>
+          </a:solidFill>
+          <a:ln>
+            <a:noFill/>
+          </a:ln>
+          <a:effectLst/>
+        </p:spPr>
+        <p:style>
+          <a:lnRef idx="1">
+            <a:schemeClr val="accent1"/>
+          </a:lnRef>
+          <a:fillRef idx="3">
+            <a:schemeClr val="accent1"/>
+          </a:fillRef>
+          <a:effectRef idx="2">
+            <a:schemeClr val="accent1"/>
+          </a:effectRef>
+          <a:fontRef idx="minor">
+            <a:schemeClr val="lt1"/>
+          </a:fontRef>
+        </p:style>
+        <p:txBody>
+          <a:bodyPr rtlCol="0" anchor="ctr"/>
+          <a:lstStyle/>
+          <a:p>
+            <a:pPr algn="ctr"/>
+          </a:p>
+        </p:txBody>
+      </p:sp>
+      <p:sp>
+        <p:nvSpPr>
+          <p:cNvPr id="4" name="TextBox 3"/>
+          <p:cNvSpPr txBox="1"/>
+          <p:nvPr/>
+        </p:nvSpPr>
+        <p:spPr>
+          <a:xfrm>
+            <a:off x="640080" y="2103120"/>
+            <a:ext cx="10911535" cy="1097280"/>
+          </a:xfrm>
+          <a:prstGeom prst="rect">
+            <a:avLst/>
+          </a:prstGeom>
+          <a:noFill/>
+        </p:spPr>
+        <p:txBody>
+          <a:bodyPr wrap="square">
+            <a:spAutoFit/>
+          </a:bodyPr>
+          <a:lstStyle/>
+          <a:p>
+            <a:pPr>
+              <a:defRPr sz="4800" b="1">
+                <a:solidFill>
+                  <a:srgbClr val="FFFFFF"/>
+                </a:solidFill>
+                <a:latin typeface="Helvetica Neue"/>
+              </a:defRPr>
+            </a:pPr>
+            <a:r>
+              <a:t>Try it yourself</a:t>
+            </a:r>
+          </a:p>
+        </p:txBody>
+      </p:sp>
+      <p:sp>
+        <p:nvSpPr>
+          <p:cNvPr id="5" name="TextBox 4"/>
+          <p:cNvSpPr txBox="1"/>
+          <p:nvPr/>
+        </p:nvSpPr>
+        <p:spPr>
+          <a:xfrm>
+            <a:off x="640080" y="3383280"/>
+            <a:ext cx="10911535" cy="2286000"/>
+          </a:xfrm>
+          <a:prstGeom prst="rect">
+            <a:avLst/>
+          </a:prstGeom>
+          <a:noFill/>
+        </p:spPr>
+        <p:txBody>
+          <a:bodyPr wrap="square">
+            <a:spAutoFit/>
+          </a:bodyPr>
+          <a:lstStyle/>
+          <a:p>
+            <a:pPr>
+              <a:spcAft>
+                <a:spcPts val="1000"/>
+              </a:spcAft>
+              <a:defRPr sz="1800" b="0">
+                <a:solidFill>
+                  <a:srgbClr val="C3C9D1"/>
+                </a:solidFill>
+                <a:latin typeface="Helvetica Neue"/>
+              </a:defRPr>
+            </a:pPr>
+            <a:r>
+              <a:t>Live prototype: evermon-demo.nazrijz336.workers.dev</a:t>
+            </a:r>
+          </a:p>
+          <a:p>
+            <a:pPr>
+              <a:spcAft>
+                <a:spcPts val="1000"/>
+              </a:spcAft>
+              <a:defRPr sz="1800" b="0">
+                <a:solidFill>
+                  <a:srgbClr val="C3C9D1"/>
+                </a:solidFill>
+                <a:latin typeface="Helvetica Neue"/>
+              </a:defRPr>
+            </a:pPr>
+            <a:r>
+              <a:t>Demo video: youtu.be/TE72CMXwmZ0</a:t>
+            </a:r>
+          </a:p>
+          <a:p>
+            <a:pPr>
+              <a:spcAft>
+                <a:spcPts val="1000"/>
+              </a:spcAft>
+              <a:defRPr sz="1800" b="0">
+                <a:solidFill>
+                  <a:srgbClr val="C3C9D1"/>
+                </a:solidFill>
+                <a:latin typeface="Helvetica Neue"/>
+              </a:defRPr>
+            </a:pPr>
+            <a:r>
+              <a:t>Source: github.com/ponli550/Evermon</a:t>
+            </a:r>
+          </a:p>
+          <a:p>
+            <a:pPr>
+              <a:spcAft>
+                <a:spcPts val="1000"/>
+              </a:spcAft>
+              <a:defRPr sz="1800" b="0">
+                <a:solidFill>
+                  <a:srgbClr val="C3C9D1"/>
+                </a:solidFill>
+                <a:latin typeface="Helvetica Neue"/>
+              </a:defRPr>
+            </a:pPr>
+            <a:r>
+              <a:t>Thank you.</a:t>
+            </a:r>
+          </a:p>
+        </p:txBody>
+      </p:sp>
+      <p:sp>
+        <p:nvSpPr>
+          <p:cNvPr id="6" name="Rectangle 5"/>
+          <p:cNvSpPr/>
+          <p:nvPr/>
+        </p:nvSpPr>
+        <p:spPr>
+          <a:xfrm>
+            <a:off x="0" y="6803136"/>
+            <a:ext cx="12191695" cy="54864"/>
+          </a:xfrm>
+          <a:prstGeom prst="rect">
+            <a:avLst/>
+          </a:prstGeom>
+          <a:solidFill>
+            <a:srgbClr val="EDA100"/>
+          </a:solidFill>
+          <a:ln>
+            <a:noFill/>
+          </a:ln>
+          <a:effectLst/>
+        </p:spPr>
+        <p:style>
+          <a:lnRef idx="1">
+            <a:schemeClr val="accent1"/>
+          </a:lnRef>
+          <a:fillRef idx="3">
+            <a:schemeClr val="accent1"/>
+          </a:fillRef>
+          <a:effectRef idx="2">
+            <a:schemeClr val="accent1"/>
+          </a:effectRef>
+          <a:fontRef idx="minor">
+            <a:schemeClr val="lt1"/>
+          </a:fontRef>
+        </p:style>
+        <p:txBody>
+          <a:bodyPr rtlCol="0" anchor="ctr"/>
+          <a:lstStyle/>
+          <a:p>
+            <a:pPr algn="ctr"/>
+          </a:p>
+        </p:txBody>
+      </p:sp>
+      <p:sp>
+        <p:nvSpPr>
+          <p:cNvPr id="7" name="TextBox 6"/>
+          <p:cNvSpPr txBox="1"/>
+          <p:nvPr/>
+        </p:nvSpPr>
+        <p:spPr>
+          <a:xfrm>
+            <a:off x="640080" y="6473952"/>
+            <a:ext cx="7315200" cy="274320"/>
+          </a:xfrm>
+          <a:prstGeom prst="rect">
+            <a:avLst/>
+          </a:prstGeom>
+          <a:noFill/>
+        </p:spPr>
+        <p:txBody>
+          <a:bodyPr wrap="square">
+            <a:spAutoFit/>
+          </a:bodyPr>
+          <a:lstStyle/>
+          <a:p>
+            <a:pPr>
+              <a:defRPr sz="1000" b="0">
+                <a:solidFill>
+                  <a:srgbClr val="52514E"/>
+                </a:solidFill>
+                <a:latin typeface="Helvetica Neue"/>
+              </a:defRPr>
+            </a:pPr>
+            <a:r>
+              <a:t>Evermon — Averis × Monash Hackathon 2026</a:t>
+            </a:r>
+          </a:p>
+        </p:txBody>
+      </p:sp>
+      <p:sp>
+        <p:nvSpPr>
+          <p:cNvPr id="8" name="TextBox 7"/>
+          <p:cNvSpPr txBox="1"/>
+          <p:nvPr/>
+        </p:nvSpPr>
+        <p:spPr>
+          <a:xfrm>
+            <a:off x="11277295" y="6473952"/>
+            <a:ext cx="548640" cy="274320"/>
+          </a:xfrm>
+          <a:prstGeom prst="rect">
+            <a:avLst/>
+          </a:prstGeom>
+          <a:noFill/>
+        </p:spPr>
+        <p:txBody>
+          <a:bodyPr wrap="square">
+            <a:spAutoFit/>
+          </a:bodyPr>
+          <a:lstStyle/>
+          <a:p>
+            <a:pPr algn="r">
+              <a:defRPr sz="1000" b="1">
+                <a:solidFill>
+                  <a:srgbClr val="2A78D6"/>
+                </a:solidFill>
+                <a:latin typeface="Helvetica Neue"/>
+              </a:defRPr>
+            </a:pPr>
+            <a:r>
+              <a:t>21</a:t>
             </a:r>
           </a:p>
         </p:txBody>

</xml_diff>